<commit_message>
Update PowerPoint slide order sequence to match official guidelines
</commit_message>
<xml_diff>
--- a/docs/cyberquest_presentation.pptx
+++ b/docs/cyberquest_presentation.pptx
@@ -3113,7 +3113,7 @@
         </p:nvSpPr>
         <p:spPr>
           <a:xfrm>
-            <a:off x="914400" y="1645920"/>
+            <a:off x="914400" y="1371600"/>
             <a:ext cx="10362895" cy="2743200"/>
           </a:xfrm>
           <a:prstGeom prst="rect">
@@ -3128,6 +3128,19 @@
           <a:lstStyle/>
           <a:p>
             <a:pPr algn="ctr">
+              <a:defRPr sz="1400" b="1">
+                <a:solidFill>
+                  <a:srgbClr val="38BDF8"/>
+                </a:solidFill>
+                <a:latin typeface="Outfit"/>
+              </a:defRPr>
+            </a:pPr>
+            <a:r>
+              <a:t>PROTOTYPE DEVELOPMENT:</a:t>
+            </a:r>
+          </a:p>
+          <a:p>
+            <a:pPr algn="ctr">
               <a:defRPr sz="5400" b="1">
                 <a:solidFill>
                   <a:srgbClr val="D4AF37"/>
@@ -3141,29 +3154,15 @@
           </a:p>
           <a:p>
             <a:pPr algn="ctr">
-              <a:defRPr sz="2000" i="1">
-                <a:solidFill>
-                  <a:srgbClr val="38BDF8"/>
+              <a:defRPr sz="1800" i="1">
+                <a:solidFill>
+                  <a:srgbClr val="FFFFFF"/>
                 </a:solidFill>
                 <a:latin typeface="Outfit"/>
               </a:defRPr>
             </a:pPr>
             <a:r>
               <a:t>"In the labyrinth of deception, knowledge is your weapon."</a:t>
-            </a:r>
-          </a:p>
-          <a:p>
-            <a:br/>
-            <a:pPr algn="ctr">
-              <a:defRPr sz="1600" b="1">
-                <a:solidFill>
-                  <a:srgbClr val="00FF66"/>
-                </a:solidFill>
-                <a:latin typeface="Outfit"/>
-              </a:defRPr>
-            </a:pPr>
-            <a:r>
-              <a:t>SETS Gameathon 2026 — Final Round Presentation</a:t>
             </a:r>
           </a:p>
         </p:txBody>
@@ -3176,8 +3175,8 @@
         </p:nvSpPr>
         <p:spPr>
           <a:xfrm>
-            <a:off x="914400" y="4754880"/>
-            <a:ext cx="10362895" cy="1371600"/>
+            <a:off x="914400" y="4389120"/>
+            <a:ext cx="10362895" cy="1828800"/>
           </a:xfrm>
           <a:prstGeom prst="rect">
             <a:avLst/>
@@ -3193,26 +3192,26 @@
             <a:pPr algn="ctr">
               <a:defRPr sz="1600" b="1">
                 <a:solidFill>
-                  <a:srgbClr val="FFFFFF"/>
+                  <a:srgbClr val="00FF66"/>
                 </a:solidFill>
                 <a:latin typeface="Outfit"/>
               </a:defRPr>
             </a:pPr>
             <a:r>
-              <a:t>Developed by Team: Internet Rangers</a:t>
+              <a:t>Team: Internet Rangers (SETS Gameathon 2026 Finalist)</a:t>
             </a:r>
           </a:p>
           <a:p>
             <a:pPr algn="ctr">
               <a:defRPr sz="1500">
                 <a:solidFill>
-                  <a:srgbClr val="E2E8F0"/>
+                  <a:srgbClr val="FFFFFF"/>
                 </a:solidFill>
                 <a:latin typeface="Outfit"/>
               </a:defRPr>
             </a:pPr>
             <a:r>
-              <a:t>Sai Rakesh  &amp;  Yashovardhan Reddy Kandi</a:t>
+              <a:t>Sai Rakesh (Co-developer)  &amp;  Yashovardhan Reddy Kandi (Co-developer)</a:t>
             </a:r>
           </a:p>
           <a:p>
@@ -3287,7 +3286,7 @@
               </a:defRPr>
             </a:pPr>
             <a:r>
-              <a:t>PITCH CONCLUSION</a:t>
+              <a:t>DELIVERABLE OUTCOME</a:t>
             </a:r>
           </a:p>
         </p:txBody>
@@ -3315,7 +3314,7 @@
           <a:lstStyle/>
           <a:p>
             <a:pPr>
-              <a:defRPr sz="3200" b="1">
+              <a:defRPr sz="3000" b="1">
                 <a:solidFill>
                   <a:srgbClr val="D4AF37"/>
                 </a:solidFill>
@@ -3323,7 +3322,7 @@
               </a:defRPr>
             </a:pPr>
             <a:r>
-              <a:t>Summary &amp; Live Prototype Demonstration</a:t>
+              <a:t>Summary of Deployed Gameathon Solution</a:t>
             </a:r>
           </a:p>
         </p:txBody>
@@ -3378,7 +3377,7 @@
               </a:defRPr>
             </a:pPr>
             <a:r>
-              <a:t>CYBERQUEST RPG: EMPOWERING CITIZENS TO BECOME CYBER GUARDIANS</a:t>
+              <a:t>CYBERQUEST RPG: FULLY DEPLOYED PROTOTYPE</a:t>
             </a:r>
           </a:p>
           <a:p>
@@ -3392,29 +3391,29 @@
               </a:defRPr>
             </a:pPr>
             <a:r>
-              <a:t>• Production-Ready Web App:</a:t>
-            </a:r>
-            <a:br/>
-            <a:r>
-              <a:t>  Fully functional, deployed, and tested on multiple systems prior to evaluation.</a:t>
-            </a:r>
-            <a:br/>
-            <a:br/>
-            <a:r>
-              <a:t>• Gamified Actionable Awareness:</a:t>
-            </a:r>
-            <a:br/>
-            <a:r>
-              <a:t>  Combines immersive gameplay, homograph link detection, scam phone vishing simulations, and an AI mentor to create a comprehensive safety training sandbox.</a:t>
-            </a:r>
-            <a:br/>
-            <a:br/>
-            <a:r>
-              <a:t>• Inclusivity Focused:</a:t>
-            </a:r>
-            <a:br/>
-            <a:r>
-              <a:t>  Supports hardware variations, motor preferences, and sensory conditions to enable digital security learning for everyone.</a:t>
+              <a:t>• Fully Functional &amp; Hosted Web Application:</a:t>
+            </a:r>
+            <a:br/>
+            <a:r>
+              <a:t>  Tested on multiple platforms, with zero setup required to inspect or evaluate.</a:t>
+            </a:r>
+            <a:br/>
+            <a:br/>
+            <a:r>
+              <a:t>• Integrated Learning Sandbox:</a:t>
+            </a:r>
+            <a:br/>
+            <a:r>
+              <a:t>  Successfully combines threat spotting, vishing audio vishing calls, homograph URLs, security MCQ checkpoints, and dynamic AI guidance.</a:t>
+            </a:r>
+            <a:br/>
+            <a:br/>
+            <a:r>
+              <a:t>• Designed for Inclusivity:</a:t>
+            </a:r>
+            <a:br/>
+            <a:r>
+              <a:t>  Includes keyboard motor control mappings, screen reader accommodations, visual subtitles, and lightweight optimization.</a:t>
             </a:r>
           </a:p>
         </p:txBody>
@@ -3535,7 +3534,7 @@
               </a:defRPr>
             </a:pPr>
             <a:r>
-              <a:t>CYBERQUEST RPG</a:t>
+              <a:t>PROBLEM STATEMENT</a:t>
             </a:r>
           </a:p>
         </p:txBody>
@@ -3563,7 +3562,7 @@
           <a:lstStyle/>
           <a:p>
             <a:pPr>
-              <a:defRPr sz="3200" b="1">
+              <a:defRPr sz="3000" b="1">
                 <a:solidFill>
                   <a:srgbClr val="D4AF37"/>
                 </a:solidFill>
@@ -3571,7 +3570,7 @@
               </a:defRPr>
             </a:pPr>
             <a:r>
-              <a:t>The Core Problem: Social Engineering &amp; Awareness Gaps</a:t>
+              <a:t>The Social Engineering Threat Landscape</a:t>
             </a:r>
           </a:p>
         </p:txBody>
@@ -3607,13 +3606,13 @@
               </a:defRPr>
             </a:pPr>
             <a:r>
-              <a:t>THE VULNERABILITY GAP</a:t>
+              <a:t>THE AWARENESS GAP</a:t>
             </a:r>
           </a:p>
           <a:p>
             <a:br/>
             <a:pPr>
-              <a:defRPr sz="1600">
+              <a:defRPr sz="1500">
                 <a:solidFill>
                   <a:srgbClr val="E2E8F0"/>
                 </a:solidFill>
@@ -3621,12 +3620,12 @@
               </a:defRPr>
             </a:pPr>
             <a:r>
-              <a:t>Today, millions of users fall victim to social engineering and malicious attacks due to a critical lack of interactive cybersecurity awareness.</a:t>
-            </a:r>
-            <a:br/>
-            <a:br/>
-            <a:r>
-              <a:t>Traditional methods like corporate PDFs, compliance videos, or static slides fail because they do not simulate emotional manipulation—like urgency, fear, and panic—leaving users unprepared for real-world scenarios.</a:t>
+              <a:t>Today, millions of users fall victim to social engineering and malicious attacks due to a critical lack of cybersecurity awareness.</a:t>
+            </a:r>
+            <a:br/>
+            <a:br/>
+            <a:r>
+              <a:t>Attackers target vulnerable human emotions using urgency and fear. Because standard training tools (text guides, videos, simple presentations) are passive and compliance-driven, they fail to build the split-second reflexes users need to defend themselves against live threats.</a:t>
             </a:r>
           </a:p>
         </p:txBody>
@@ -3681,13 +3680,13 @@
               </a:defRPr>
             </a:pPr>
             <a:r>
-              <a:t>CRITICAL AWARENESS CHALLENGES</a:t>
+              <a:t>PRIMARY SECURITY CHALLENGES</a:t>
             </a:r>
           </a:p>
           <a:p>
             <a:br/>
             <a:pPr>
-              <a:defRPr sz="1400">
+              <a:defRPr sz="1300">
                 <a:solidFill>
                   <a:srgbClr val="E2E8F0"/>
                 </a:solidFill>
@@ -3699,25 +3698,25 @@
             </a:r>
             <a:br/>
             <a:r>
-              <a:t>  Phishing, malware downloads, and complex vishing (voice phishing) calls target users directly.</a:t>
-            </a:r>
-            <a:br/>
-            <a:br/>
-            <a:r>
-              <a:t>• Urgency Exploitation:</a:t>
-            </a:r>
-            <a:br/>
-            <a:r>
-              <a:t>  Attackers manipulate emotional responses. Training must build muscle memory to check links and verify identity.</a:t>
-            </a:r>
-            <a:br/>
-            <a:br/>
-            <a:r>
-              <a:t>• Zero Actionable Training:</a:t>
-            </a:r>
-            <a:br/>
-            <a:r>
-              <a:t>  Compliance-driven training is flat. Interactive scenarios are needed to practice responses and test decisions safely.</a:t>
+              <a:t>  Phishing emails, homograph domains, vishing scam calls, and malicious fake updates target unsuspecting users.</a:t>
+            </a:r>
+            <a:br/>
+            <a:br/>
+            <a:r>
+              <a:t>• Emotional Pressure Tactics:</a:t>
+            </a:r>
+            <a:br/>
+            <a:r>
+              <a:t>  Attackers manipulate situations (e.g. fake bank alerts) to force rapid actions, bypassing logical checks.</a:t>
+            </a:r>
+            <a:br/>
+            <a:br/>
+            <a:r>
+              <a:t>• Flat Learning Drawbacks:</a:t>
+            </a:r>
+            <a:br/>
+            <a:r>
+              <a:t>  Users memorize facts for tests but fail to apply safety measures when facing real-world interactions.</a:t>
             </a:r>
           </a:p>
         </p:txBody>
@@ -3779,7 +3778,7 @@
               </a:defRPr>
             </a:pPr>
             <a:r>
-              <a:t>CYBERQUEST RPG</a:t>
+              <a:t>OBJECTIVE AND ABSTRACT</a:t>
             </a:r>
           </a:p>
         </p:txBody>
@@ -3807,7 +3806,7 @@
           <a:lstStyle/>
           <a:p>
             <a:pPr>
-              <a:defRPr sz="3200" b="1">
+              <a:defRPr sz="3000" b="1">
                 <a:solidFill>
                   <a:srgbClr val="D4AF37"/>
                 </a:solidFill>
@@ -3815,57 +3814,21 @@
               </a:defRPr>
             </a:pPr>
             <a:r>
-              <a:t>Our Solution: The CyberQuest RPG Platform</a:t>
-            </a:r>
-          </a:p>
-        </p:txBody>
-      </p:sp>
-      <p:sp>
-        <p:nvSpPr>
-          <p:cNvPr id="4" name="TextBox 3"/>
-          <p:cNvSpPr txBox="1"/>
-          <p:nvPr/>
-        </p:nvSpPr>
-        <p:spPr>
-          <a:xfrm>
-            <a:off x="685800" y="1371600"/>
-            <a:ext cx="10817352" cy="731520"/>
-          </a:xfrm>
-          <a:prstGeom prst="rect">
-            <a:avLst/>
-          </a:prstGeom>
-          <a:noFill/>
-        </p:spPr>
-        <p:txBody>
-          <a:bodyPr wrap="square">
-            <a:spAutoFit/>
-          </a:bodyPr>
-          <a:lstStyle/>
-          <a:p>
-            <a:pPr>
-              <a:defRPr sz="1600">
-                <a:solidFill>
-                  <a:srgbClr val="FFFFFF"/>
-                </a:solidFill>
-                <a:latin typeface="Outfit"/>
-              </a:defRPr>
-            </a:pPr>
-            <a:r>
-              <a:t>An interactive, adaptive training application that combines education, gamification, and decision-making to reduce the risk of cyberattacks.</a:t>
-            </a:r>
-          </a:p>
-        </p:txBody>
-      </p:sp>
-      <p:sp>
-        <p:nvSpPr>
-          <p:cNvPr id="5" name="Rectangle 4"/>
+              <a:t>Strategic Objectives &amp; Platform Abstract</a:t>
+            </a:r>
+          </a:p>
+        </p:txBody>
+      </p:sp>
+      <p:sp>
+        <p:nvSpPr>
+          <p:cNvPr id="4" name="Rectangle 3"/>
           <p:cNvSpPr/>
           <p:nvPr/>
         </p:nvSpPr>
         <p:spPr>
           <a:xfrm>
-            <a:off x="685800" y="2194560"/>
-            <a:ext cx="3383280" cy="3657600"/>
+            <a:off x="685800" y="1645920"/>
+            <a:ext cx="5120640" cy="4114800"/>
           </a:xfrm>
           <a:prstGeom prst="rect">
             <a:avLst/>
@@ -3894,11 +3857,11 @@
           </a:fontRef>
         </p:style>
         <p:txBody>
-          <a:bodyPr rtlCol="0" anchor="ctr" lIns="274320" rIns="274320" tIns="274320" wrap="square"/>
+          <a:bodyPr rtlCol="0" anchor="ctr" lIns="365760" tIns="365760" wrap="square"/>
           <a:lstStyle/>
           <a:p>
             <a:pPr algn="ctr">
-              <a:defRPr sz="2000" b="1">
+              <a:defRPr sz="1800" b="1">
                 <a:solidFill>
                   <a:srgbClr val="38BDF8"/>
                 </a:solidFill>
@@ -3906,12 +3869,7 @@
               </a:defRPr>
             </a:pPr>
             <a:r>
-              <a:t>01</a:t>
-            </a:r>
-            <a:br/>
-            <a:br/>
-            <a:r>
-              <a:t>RECOGNIZE THREATS</a:t>
+              <a:t>PLATFORM ABSTRACT</a:t>
             </a:r>
           </a:p>
           <a:p>
@@ -3925,21 +3883,26 @@
               </a:defRPr>
             </a:pPr>
             <a:r>
-              <a:t>Empowers users to spot suspicious patterns in real-time, including fake login domains, malicious update requests, and deceptive bank calls.</a:t>
-            </a:r>
-          </a:p>
-        </p:txBody>
-      </p:sp>
-      <p:sp>
-        <p:nvSpPr>
-          <p:cNvPr id="6" name="Rectangle 5"/>
+              <a:t>CyberQuest RPG is a web-based, gamified training platform that transforms passive security guides into active decision-making experiences.</a:t>
+            </a:r>
+            <a:br/>
+            <a:br/>
+            <a:r>
+              <a:t>By placing users inside a interactive 3D labyrinth, players encounter simulations of real-world threats. They learn to identify tactics, make high-stakes choices, analyze fake link signatures, and verify caller identities in a completely safe failures-tolerant environment.</a:t>
+            </a:r>
+          </a:p>
+        </p:txBody>
+      </p:sp>
+      <p:sp>
+        <p:nvSpPr>
+          <p:cNvPr id="5" name="Rectangle 4"/>
           <p:cNvSpPr/>
           <p:nvPr/>
         </p:nvSpPr>
         <p:spPr>
           <a:xfrm>
-            <a:off x="4434840" y="2194560"/>
-            <a:ext cx="3383280" cy="3657600"/>
+            <a:off x="6355080" y="1645920"/>
+            <a:ext cx="5150815" cy="4114800"/>
           </a:xfrm>
           <a:prstGeom prst="rect">
             <a:avLst/>
@@ -3968,11 +3931,11 @@
           </a:fontRef>
         </p:style>
         <p:txBody>
-          <a:bodyPr rtlCol="0" anchor="ctr" lIns="274320" rIns="274320" tIns="274320" wrap="square"/>
+          <a:bodyPr rtlCol="0" anchor="ctr" lIns="365760" tIns="365760" wrap="square"/>
           <a:lstStyle/>
           <a:p>
             <a:pPr algn="ctr">
-              <a:defRPr sz="2000" b="1">
+              <a:defRPr sz="1800" b="1">
                 <a:solidFill>
                   <a:srgbClr val="D4AF37"/>
                 </a:solidFill>
@@ -3980,18 +3943,13 @@
               </a:defRPr>
             </a:pPr>
             <a:r>
-              <a:t>02</a:t>
-            </a:r>
-            <a:br/>
-            <a:br/>
-            <a:r>
-              <a:t>LEARN BY SIMULATION</a:t>
+              <a:t>KEY OBJECTIVES</a:t>
             </a:r>
           </a:p>
           <a:p>
             <a:br/>
             <a:pPr>
-              <a:defRPr sz="1400">
+              <a:defRPr sz="1300">
                 <a:solidFill>
                   <a:srgbClr val="E2E8F0"/>
                 </a:solidFill>
@@ -3999,81 +3957,29 @@
               </a:defRPr>
             </a:pPr>
             <a:r>
-              <a:t>Presents decision-based scenarios designed around real-world cybercrime cases. Users experience the consequences of their actions immediately in a safe sandbox.</a:t>
-            </a:r>
-          </a:p>
-        </p:txBody>
-      </p:sp>
-      <p:sp>
-        <p:nvSpPr>
-          <p:cNvPr id="7" name="Rectangle 6"/>
-          <p:cNvSpPr/>
-          <p:nvPr/>
-        </p:nvSpPr>
-        <p:spPr>
-          <a:xfrm>
-            <a:off x="8183880" y="2194560"/>
-            <a:ext cx="3383280" cy="3657600"/>
-          </a:xfrm>
-          <a:prstGeom prst="rect">
-            <a:avLst/>
-          </a:prstGeom>
-          <a:solidFill>
-            <a:srgbClr val="1A202C"/>
-          </a:solidFill>
-          <a:ln w="19050">
-            <a:solidFill>
-              <a:srgbClr val="00FF66"/>
-            </a:solidFill>
-          </a:ln>
-        </p:spPr>
-        <p:style>
-          <a:lnRef idx="1">
-            <a:schemeClr val="accent1"/>
-          </a:lnRef>
-          <a:fillRef idx="3">
-            <a:schemeClr val="accent1"/>
-          </a:fillRef>
-          <a:effectRef idx="2">
-            <a:schemeClr val="accent1"/>
-          </a:effectRef>
-          <a:fontRef idx="minor">
-            <a:schemeClr val="lt1"/>
-          </a:fontRef>
-        </p:style>
-        <p:txBody>
-          <a:bodyPr rtlCol="0" anchor="ctr" lIns="274320" rIns="274320" tIns="274320" wrap="square"/>
-          <a:lstStyle/>
-          <a:p>
-            <a:pPr algn="ctr">
-              <a:defRPr sz="2000" b="1">
-                <a:solidFill>
-                  <a:srgbClr val="00FF66"/>
-                </a:solidFill>
-                <a:latin typeface="Outfit"/>
-              </a:defRPr>
-            </a:pPr>
-            <a:r>
-              <a:t>03</a:t>
-            </a:r>
-            <a:br/>
-            <a:br/>
-            <a:r>
-              <a:t>PRACTICE SAFE RESPONSES</a:t>
-            </a:r>
-          </a:p>
-          <a:p>
-            <a:br/>
-            <a:pPr>
-              <a:defRPr sz="1400">
-                <a:solidFill>
-                  <a:srgbClr val="E2E8F0"/>
-                </a:solidFill>
-                <a:latin typeface="Outfit"/>
-              </a:defRPr>
-            </a:pPr>
-            <a:r>
-              <a:t>Gamifies protective habits. Teaches users how to use verified channels, analyze URLs, protect confidential credentials, and gain actionable security measures.</a:t>
+              <a:t>• Recognize Deceptive Tactics:</a:t>
+            </a:r>
+            <a:br/>
+            <a:r>
+              <a:t>  Train users to spot phishing attempts, malware traps, and AI vishing call pressures.</a:t>
+            </a:r>
+            <a:br/>
+            <a:br/>
+            <a:r>
+              <a:t>• Adaptive Decision Practice:</a:t>
+            </a:r>
+            <a:br/>
+            <a:r>
+              <a:t>  Allow users to experience consequences of actions safely. Bad decisions drop HP; correct ones build confidence.</a:t>
+            </a:r>
+            <a:br/>
+            <a:br/>
+            <a:r>
+              <a:t>• Build Actionable Reflexes:</a:t>
+            </a:r>
+            <a:br/>
+            <a:r>
+              <a:t>  Provide immediate, actionable steps to protect credentials and utilize official verification channels.</a:t>
             </a:r>
           </a:p>
         </p:txBody>
@@ -4135,7 +4041,7 @@
               </a:defRPr>
             </a:pPr>
             <a:r>
-              <a:t>CYBERQUEST RPG</a:t>
+              <a:t>OBJECTIVE AND ABSTRACT</a:t>
             </a:r>
           </a:p>
         </p:txBody>
@@ -4163,7 +4069,7 @@
           <a:lstStyle/>
           <a:p>
             <a:pPr>
-              <a:defRPr sz="3200" b="1">
+              <a:defRPr sz="3000" b="1">
                 <a:solidFill>
                   <a:srgbClr val="D4AF37"/>
                 </a:solidFill>
@@ -4171,7 +4077,7 @@
               </a:defRPr>
             </a:pPr>
             <a:r>
-              <a:t>Immersive 3D Labyrinth &amp; Gamification Design</a:t>
+              <a:t>How Gamification Meets Educational Objectives</a:t>
             </a:r>
           </a:p>
         </p:txBody>
@@ -4185,7 +4091,7 @@
         <p:spPr>
           <a:xfrm>
             <a:off x="685800" y="1645920"/>
-            <a:ext cx="5120640" cy="4114800"/>
+            <a:ext cx="3383280" cy="4114800"/>
           </a:xfrm>
           <a:prstGeom prst="rect">
             <a:avLst/>
@@ -4214,11 +4120,11 @@
           </a:fontRef>
         </p:style>
         <p:txBody>
-          <a:bodyPr rtlCol="0" anchor="ctr" lIns="365760" tIns="365760" wrap="square"/>
+          <a:bodyPr rtlCol="0" anchor="ctr" lIns="274320" tIns="274320" wrap="square"/>
           <a:lstStyle/>
           <a:p>
             <a:pPr algn="ctr">
-              <a:defRPr sz="1800" b="1">
+              <a:defRPr sz="1600" b="1">
                 <a:solidFill>
                   <a:srgbClr val="D4AF37"/>
                 </a:solidFill>
@@ -4226,13 +4132,13 @@
               </a:defRPr>
             </a:pPr>
             <a:r>
-              <a:t>GAMIFICATION MECHANICS</a:t>
+              <a:t>EXPLORATION &amp; EMOTION</a:t>
             </a:r>
           </a:p>
           <a:p>
             <a:br/>
             <a:pPr>
-              <a:defRPr sz="1400">
+              <a:defRPr sz="1200">
                 <a:solidFill>
                   <a:srgbClr val="E2E8F0"/>
                 </a:solidFill>
@@ -4240,29 +4146,20 @@
               </a:defRPr>
             </a:pPr>
             <a:r>
-              <a:t>• Active 3D Navigation:</a:t>
-            </a:r>
-            <a:br/>
-            <a:r>
-              <a:t>  First-person layout in access-key corridors powered by keyboard controls (WASD/Arrows + Enter). Drives muscle memory.</a:t>
-            </a:r>
-            <a:br/>
-            <a:br/>
-            <a:r>
-              <a:t>• Live Health (HP) Pool:</a:t>
-            </a:r>
-            <a:br/>
-            <a:r>
-              <a:t>  Players start with 100 HP. Engaging with malware updates or sharing data reduces HP. Survival forces vigilant decision-making.</a:t>
-            </a:r>
-            <a:br/>
-            <a:br/>
-            <a:r>
-              <a:t>• Currency &amp; Upgrades:</a:t>
-            </a:r>
-            <a:br/>
-            <a:r>
-              <a:t>  Correct actions reward coins. Coins buy clues, intel, and defensive shields, teaching risk vs. reward dynamics.</a:t>
+              <a:t>• First-Person 3D Space:</a:t>
+            </a:r>
+            <a:br/>
+            <a:r>
+              <a:t>  Players navigate using keyboard controls (WASD/Arrows + Enter), creating active physical coordination.</a:t>
+            </a:r>
+            <a:br/>
+            <a:br/>
+            <a:r>
+              <a:t>• Tension &amp; Health Pool:</a:t>
+            </a:r>
+            <a:br/>
+            <a:r>
+              <a:t>  Starting at 100 HP, players face threats directly. Losing HP when tricked creates low-stakes stress, simulating real attacks.</a:t>
             </a:r>
           </a:p>
         </p:txBody>
@@ -4275,8 +4172,8 @@
         </p:nvSpPr>
         <p:spPr>
           <a:xfrm>
-            <a:off x="6355080" y="1645920"/>
-            <a:ext cx="5150815" cy="4114800"/>
+            <a:off x="4434840" y="1645920"/>
+            <a:ext cx="3383280" cy="4114800"/>
           </a:xfrm>
           <a:prstGeom prst="rect">
             <a:avLst/>
@@ -4305,11 +4202,11 @@
           </a:fontRef>
         </p:style>
         <p:txBody>
-          <a:bodyPr rtlCol="0" anchor="ctr" lIns="365760" tIns="365760" wrap="square"/>
+          <a:bodyPr rtlCol="0" anchor="ctr" lIns="274320" tIns="274320" wrap="square"/>
           <a:lstStyle/>
           <a:p>
             <a:pPr algn="ctr">
-              <a:defRPr sz="1800" b="1">
+              <a:defRPr sz="1600" b="1">
                 <a:solidFill>
                   <a:srgbClr val="38BDF8"/>
                 </a:solidFill>
@@ -4317,13 +4214,13 @@
               </a:defRPr>
             </a:pPr>
             <a:r>
-              <a:t>TRAINING STRATEGY</a:t>
+              <a:t>ADAPTIVE SIMULATION</a:t>
             </a:r>
           </a:p>
           <a:p>
             <a:br/>
             <a:pPr>
-              <a:defRPr sz="1400">
+              <a:defRPr sz="1200">
                 <a:solidFill>
                   <a:srgbClr val="E2E8F0"/>
                 </a:solidFill>
@@ -4331,20 +4228,102 @@
               </a:defRPr>
             </a:pPr>
             <a:r>
-              <a:t>• Adaptive Scenarios:</a:t>
-            </a:r>
-            <a:br/>
-            <a:r>
-              <a:t>  Events adapt to choices. Spotting a scam early opens safe alternate routes; ignoring red flags leads directly into security gates.</a:t>
-            </a:r>
-            <a:br/>
-            <a:br/>
-            <a:r>
-              <a:t>• Actionable Safeguards:</a:t>
-            </a:r>
-            <a:br/>
-            <a:r>
-              <a:t>  Reinforces critical cyber guidelines. Teaches direct actions like hanging up on vishing calls, verifying domain endings, and configuring Multi-Factor Authentication (MFA).</a:t>
+              <a:t>• Branching Consequences:</a:t>
+            </a:r>
+            <a:br/>
+            <a:r>
+              <a:t>  Platform adapts to user choices. Spotting threats early opens easier paths; failing redirects the player to secure checkpoint gates.</a:t>
+            </a:r>
+            <a:br/>
+            <a:br/>
+            <a:r>
+              <a:t>• Actionable Practice:</a:t>
+            </a:r>
+            <a:br/>
+            <a:r>
+              <a:t>  Teaches specific check protocols, such as hovering to read link paths before clicking.</a:t>
+            </a:r>
+          </a:p>
+        </p:txBody>
+      </p:sp>
+      <p:sp>
+        <p:nvSpPr>
+          <p:cNvPr id="6" name="Rectangle 5"/>
+          <p:cNvSpPr/>
+          <p:nvPr/>
+        </p:nvSpPr>
+        <p:spPr>
+          <a:xfrm>
+            <a:off x="8183880" y="1645920"/>
+            <a:ext cx="3383280" cy="4114800"/>
+          </a:xfrm>
+          <a:prstGeom prst="rect">
+            <a:avLst/>
+          </a:prstGeom>
+          <a:solidFill>
+            <a:srgbClr val="1A202C"/>
+          </a:solidFill>
+          <a:ln w="19050">
+            <a:solidFill>
+              <a:srgbClr val="00FF66"/>
+            </a:solidFill>
+          </a:ln>
+        </p:spPr>
+        <p:style>
+          <a:lnRef idx="1">
+            <a:schemeClr val="accent1"/>
+          </a:lnRef>
+          <a:fillRef idx="3">
+            <a:schemeClr val="accent1"/>
+          </a:fillRef>
+          <a:effectRef idx="2">
+            <a:schemeClr val="accent1"/>
+          </a:effectRef>
+          <a:fontRef idx="minor">
+            <a:schemeClr val="lt1"/>
+          </a:fontRef>
+        </p:style>
+        <p:txBody>
+          <a:bodyPr rtlCol="0" anchor="ctr" lIns="274320" tIns="274320" wrap="square"/>
+          <a:lstStyle/>
+          <a:p>
+            <a:pPr algn="ctr">
+              <a:defRPr sz="1600" b="1">
+                <a:solidFill>
+                  <a:srgbClr val="00FF66"/>
+                </a:solidFill>
+                <a:latin typeface="Outfit"/>
+              </a:defRPr>
+            </a:pPr>
+            <a:r>
+              <a:t>REINFORCING BEHAVIORS</a:t>
+            </a:r>
+          </a:p>
+          <a:p>
+            <a:br/>
+            <a:pPr>
+              <a:defRPr sz="1200">
+                <a:solidFill>
+                  <a:srgbClr val="E2E8F0"/>
+                </a:solidFill>
+                <a:latin typeface="Outfit"/>
+              </a:defRPr>
+            </a:pPr>
+            <a:r>
+              <a:t>• Score Rewards System:</a:t>
+            </a:r>
+            <a:br/>
+            <a:r>
+              <a:t>  XP, coins, and shields reinforce correct actions.</a:t>
+            </a:r>
+            <a:br/>
+            <a:br/>
+            <a:r>
+              <a:t>• Failure Integration:</a:t>
+            </a:r>
+            <a:br/>
+            <a:r>
+              <a:t>  When players fall below HP limits, they restart corridors with feedback. Encourages trial-and-error memory building.</a:t>
             </a:r>
           </a:p>
         </p:txBody>
@@ -4406,7 +4385,7 @@
               </a:defRPr>
             </a:pPr>
             <a:r>
-              <a:t>CYBERQUEST RPG</a:t>
+              <a:t>TECHNOLOGY AND TOOLS USED</a:t>
             </a:r>
           </a:p>
         </p:txBody>
@@ -4434,7 +4413,7 @@
           <a:lstStyle/>
           <a:p>
             <a:pPr>
-              <a:defRPr sz="3200" b="1">
+              <a:defRPr sz="3000" b="1">
                 <a:solidFill>
                   <a:srgbClr val="D4AF37"/>
                 </a:solidFill>
@@ -4442,7 +4421,7 @@
               </a:defRPr>
             </a:pPr>
             <a:r>
-              <a:t>Four Interactive Scenario Modules (Case Studies)</a:t>
+              <a:t>Lightweight Tech Stack &amp; Secure AI Integration</a:t>
             </a:r>
           </a:p>
         </p:txBody>
@@ -4456,7 +4435,89 @@
         <p:spPr>
           <a:xfrm>
             <a:off x="685800" y="1645920"/>
-            <a:ext cx="5120640" cy="1920240"/>
+            <a:ext cx="3383280" cy="4114800"/>
+          </a:xfrm>
+          <a:prstGeom prst="rect">
+            <a:avLst/>
+          </a:prstGeom>
+          <a:solidFill>
+            <a:srgbClr val="1A202C"/>
+          </a:solidFill>
+          <a:ln w="19050">
+            <a:solidFill>
+              <a:srgbClr val="38BDF8"/>
+            </a:solidFill>
+          </a:ln>
+        </p:spPr>
+        <p:style>
+          <a:lnRef idx="1">
+            <a:schemeClr val="accent1"/>
+          </a:lnRef>
+          <a:fillRef idx="3">
+            <a:schemeClr val="accent1"/>
+          </a:fillRef>
+          <a:effectRef idx="2">
+            <a:schemeClr val="accent1"/>
+          </a:effectRef>
+          <a:fontRef idx="minor">
+            <a:schemeClr val="lt1"/>
+          </a:fontRef>
+        </p:style>
+        <p:txBody>
+          <a:bodyPr rtlCol="0" anchor="ctr" lIns="274320" tIns="274320" wrap="square"/>
+          <a:lstStyle/>
+          <a:p>
+            <a:pPr algn="ctr">
+              <a:defRPr sz="1600" b="1">
+                <a:solidFill>
+                  <a:srgbClr val="38BDF8"/>
+                </a:solidFill>
+                <a:latin typeface="Outfit"/>
+              </a:defRPr>
+            </a:pPr>
+            <a:r>
+              <a:t>FRONTEND &amp; GRAPHICS</a:t>
+            </a:r>
+          </a:p>
+          <a:p>
+            <a:br/>
+            <a:pPr>
+              <a:defRPr sz="1200">
+                <a:solidFill>
+                  <a:srgbClr val="E2E8F0"/>
+                </a:solidFill>
+                <a:latin typeface="Outfit"/>
+              </a:defRPr>
+            </a:pPr>
+            <a:r>
+              <a:t>• Vanilla Web Core:</a:t>
+            </a:r>
+            <a:br/>
+            <a:r>
+              <a:t>  HTML5, CSS3, and JavaScript ensure rapid loading and maximum browser support.</a:t>
+            </a:r>
+            <a:br/>
+            <a:br/>
+            <a:r>
+              <a:t>• WebGL 3D Rendering:</a:t>
+            </a:r>
+            <a:br/>
+            <a:r>
+              <a:t>  Three.js (r128) powers the 3D exploration interface efficiently, avoiding heavy engine weight or installation barriers.</a:t>
+            </a:r>
+          </a:p>
+        </p:txBody>
+      </p:sp>
+      <p:sp>
+        <p:nvSpPr>
+          <p:cNvPr id="5" name="Rectangle 4"/>
+          <p:cNvSpPr/>
+          <p:nvPr/>
+        </p:nvSpPr>
+        <p:spPr>
+          <a:xfrm>
+            <a:off x="4434840" y="1645920"/>
+            <a:ext cx="3383280" cy="4114800"/>
           </a:xfrm>
           <a:prstGeom prst="rect">
             <a:avLst/>
@@ -4485,7 +4546,7 @@
           </a:fontRef>
         </p:style>
         <p:txBody>
-          <a:bodyPr rtlCol="0" anchor="ctr" lIns="182880" rIns="182880" tIns="127000" wrap="square"/>
+          <a:bodyPr rtlCol="0" anchor="ctr" lIns="274320" tIns="274320" wrap="square"/>
           <a:lstStyle/>
           <a:p>
             <a:pPr algn="ctr">
@@ -4497,10 +4558,11 @@
               </a:defRPr>
             </a:pPr>
             <a:r>
-              <a:t>01 | PHISHING HOMOGRAPH ATTACK</a:t>
-            </a:r>
-          </a:p>
-          <a:p>
+              <a:t>CLOUD BACKEND</a:t>
+            </a:r>
+          </a:p>
+          <a:p>
+            <a:br/>
             <a:pPr>
               <a:defRPr sz="1200">
                 <a:solidFill>
@@ -4510,75 +4572,29 @@
               </a:defRPr>
             </a:pPr>
             <a:r>
-              <a:t>Simulated security messages. Players hover over the 'Verify Now' link to inspect URLs—revealing a lookalike homograph domain (e.g. arcadıakyc-login.org, utilizing a Cyrillic 'ı').</a:t>
-            </a:r>
-          </a:p>
-        </p:txBody>
-      </p:sp>
-      <p:sp>
-        <p:nvSpPr>
-          <p:cNvPr id="5" name="Rectangle 4"/>
-          <p:cNvSpPr/>
-          <p:nvPr/>
-        </p:nvSpPr>
-        <p:spPr>
-          <a:xfrm>
-            <a:off x="6385255" y="1645920"/>
-            <a:ext cx="5120640" cy="1920240"/>
-          </a:xfrm>
-          <a:prstGeom prst="rect">
-            <a:avLst/>
-          </a:prstGeom>
-          <a:solidFill>
-            <a:srgbClr val="1A202C"/>
-          </a:solidFill>
-          <a:ln w="19050">
-            <a:solidFill>
-              <a:srgbClr val="38BDF8"/>
-            </a:solidFill>
-          </a:ln>
-        </p:spPr>
-        <p:style>
-          <a:lnRef idx="1">
-            <a:schemeClr val="accent1"/>
-          </a:lnRef>
-          <a:fillRef idx="3">
-            <a:schemeClr val="accent1"/>
-          </a:fillRef>
-          <a:effectRef idx="2">
-            <a:schemeClr val="accent1"/>
-          </a:effectRef>
-          <a:fontRef idx="minor">
-            <a:schemeClr val="lt1"/>
-          </a:fontRef>
-        </p:style>
-        <p:txBody>
-          <a:bodyPr rtlCol="0" anchor="ctr" lIns="182880" rIns="182880" tIns="127000" wrap="square"/>
-          <a:lstStyle/>
-          <a:p>
-            <a:pPr algn="ctr">
-              <a:defRPr sz="1600" b="1">
-                <a:solidFill>
-                  <a:srgbClr val="38BDF8"/>
-                </a:solidFill>
-                <a:latin typeface="Outfit"/>
-              </a:defRPr>
-            </a:pPr>
-            <a:r>
-              <a:t>02 | SOCIAL ENGINEERING VISHING CALLS</a:t>
-            </a:r>
-          </a:p>
-          <a:p>
-            <a:pPr>
-              <a:defRPr sz="1200">
-                <a:solidFill>
-                  <a:srgbClr val="E2E8F0"/>
-                </a:solidFill>
-                <a:latin typeface="Outfit"/>
-              </a:defRPr>
-            </a:pPr>
-            <a:r>
-              <a:t>Simulates bank calls (e.g., Arcadia Bank Fraud Team) pressuring the user to share recovery codes/OTPs. Players must make the critical choice to hang up and verify via official routes.</a:t>
+              <a:t>• Firebase Hosting:</a:t>
+            </a:r>
+            <a:br/>
+            <a:r>
+              <a:t>  Deployed on a global CDN ensuring zero latency.</a:t>
+            </a:r>
+            <a:br/>
+            <a:br/>
+            <a:r>
+              <a:t>• Firestore Database:</a:t>
+            </a:r>
+            <a:br/>
+            <a:r>
+              <a:t>  Maintains secure real-time leaderboard states.</a:t>
+            </a:r>
+            <a:br/>
+            <a:br/>
+            <a:r>
+              <a:t>• Anonymous Auth:</a:t>
+            </a:r>
+            <a:br/>
+            <a:r>
+              <a:t>  Generates pseudonyms (Guardian #1731) to guarantee absolute data privacy.</a:t>
             </a:r>
           </a:p>
         </p:txBody>
@@ -4591,76 +4607,8 @@
         </p:nvSpPr>
         <p:spPr>
           <a:xfrm>
-            <a:off x="685800" y="3840480"/>
-            <a:ext cx="5120640" cy="1920240"/>
-          </a:xfrm>
-          <a:prstGeom prst="rect">
-            <a:avLst/>
-          </a:prstGeom>
-          <a:solidFill>
-            <a:srgbClr val="1A202C"/>
-          </a:solidFill>
-          <a:ln w="19050">
-            <a:solidFill>
-              <a:srgbClr val="EF4444"/>
-            </a:solidFill>
-          </a:ln>
-        </p:spPr>
-        <p:style>
-          <a:lnRef idx="1">
-            <a:schemeClr val="accent1"/>
-          </a:lnRef>
-          <a:fillRef idx="3">
-            <a:schemeClr val="accent1"/>
-          </a:fillRef>
-          <a:effectRef idx="2">
-            <a:schemeClr val="accent1"/>
-          </a:effectRef>
-          <a:fontRef idx="minor">
-            <a:schemeClr val="lt1"/>
-          </a:fontRef>
-        </p:style>
-        <p:txBody>
-          <a:bodyPr rtlCol="0" anchor="ctr" lIns="182880" rIns="182880" tIns="127000" wrap="square"/>
-          <a:lstStyle/>
-          <a:p>
-            <a:pPr algn="ctr">
-              <a:defRPr sz="1600" b="1">
-                <a:solidFill>
-                  <a:srgbClr val="EF4444"/>
-                </a:solidFill>
-                <a:latin typeface="Outfit"/>
-              </a:defRPr>
-            </a:pPr>
-            <a:r>
-              <a:t>03 | MALWARE &amp; FAKE UPDATES</a:t>
-            </a:r>
-          </a:p>
-          <a:p>
-            <a:pPr>
-              <a:defRPr sz="1200">
-                <a:solidFill>
-                  <a:srgbClr val="E2E8F0"/>
-                </a:solidFill>
-                <a:latin typeface="Outfit"/>
-              </a:defRPr>
-            </a:pPr>
-            <a:r>
-              <a:t>Fake updating popups and file download links block corridors. Players must spot browser mismatch signs and avoid unverified mirrors, redirecting to official sources.</a:t>
-            </a:r>
-          </a:p>
-        </p:txBody>
-      </p:sp>
-      <p:sp>
-        <p:nvSpPr>
-          <p:cNvPr id="7" name="Rectangle 6"/>
-          <p:cNvSpPr/>
-          <p:nvPr/>
-        </p:nvSpPr>
-        <p:spPr>
-          <a:xfrm>
-            <a:off x="6385255" y="3840480"/>
-            <a:ext cx="5120640" cy="1920240"/>
+            <a:off x="8183880" y="1645920"/>
+            <a:ext cx="3383280" cy="4114800"/>
           </a:xfrm>
           <a:prstGeom prst="rect">
             <a:avLst/>
@@ -4689,7 +4637,7 @@
           </a:fontRef>
         </p:style>
         <p:txBody>
-          <a:bodyPr rtlCol="0" anchor="ctr" lIns="182880" rIns="182880" tIns="127000" wrap="square"/>
+          <a:bodyPr rtlCol="0" anchor="ctr" lIns="274320" tIns="274320" wrap="square"/>
           <a:lstStyle/>
           <a:p>
             <a:pPr algn="ctr">
@@ -4701,10 +4649,11 @@
               </a:defRPr>
             </a:pPr>
             <a:r>
-              <a:t>04 | BRUTE-FORCE &amp; PASSWORD FORTRESS</a:t>
-            </a:r>
-          </a:p>
-          <a:p>
+              <a:t>SECURE AI API PROXY</a:t>
+            </a:r>
+          </a:p>
+          <a:p>
+            <a:br/>
             <a:pPr>
               <a:defRPr sz="1200">
                 <a:solidFill>
@@ -4714,7 +4663,29 @@
               </a:defRPr>
             </a:pPr>
             <a:r>
-              <a:t>Teaches strong passphrases, credentials hygiene, and multi-factor authentication (MFA) setup as crucial blockers to network intrusion scenarios.</a:t>
+              <a:t>• Serverless Cloud Functions:</a:t>
+            </a:r>
+            <a:br/>
+            <a:r>
+              <a:t>  Client commands call a backend proxy function (/api/guide).</a:t>
+            </a:r>
+            <a:br/>
+            <a:br/>
+            <a:r>
+              <a:t>• API Key Obfuscation:</a:t>
+            </a:r>
+            <a:br/>
+            <a:r>
+              <a:t>  API keys (Groq Chat Completion) are stored server-side to satisfy push protection rules.</a:t>
+            </a:r>
+            <a:br/>
+            <a:br/>
+            <a:r>
+              <a:t>• LLM Safeguards:</a:t>
+            </a:r>
+            <a:br/>
+            <a:r>
+              <a:t>  Restricts response scoping to cybersecurity topics.</a:t>
             </a:r>
           </a:p>
         </p:txBody>
@@ -4776,7 +4747,7 @@
               </a:defRPr>
             </a:pPr>
             <a:r>
-              <a:t>CYBERQUEST RPG</a:t>
+              <a:t>TECHNOLOGY AND TOOLS USED</a:t>
             </a:r>
           </a:p>
         </p:txBody>
@@ -4804,7 +4775,7 @@
           <a:lstStyle/>
           <a:p>
             <a:pPr>
-              <a:defRPr sz="3200" b="1">
+              <a:defRPr sz="3000" b="1">
                 <a:solidFill>
                   <a:srgbClr val="D4AF37"/>
                 </a:solidFill>
@@ -4812,7 +4783,7 @@
               </a:defRPr>
             </a:pPr>
             <a:r>
-              <a:t>Dynamic AI Mentor &amp; Void Security Checkpoints</a:t>
+              <a:t>Accessibility &amp; Inclusivity Features</a:t>
             </a:r>
           </a:p>
         </p:txBody>
@@ -4825,8 +4796,77 @@
         </p:nvSpPr>
         <p:spPr>
           <a:xfrm>
-            <a:off x="685800" y="1645920"/>
-            <a:ext cx="5120640" cy="4114800"/>
+            <a:off x="685800" y="1920240"/>
+            <a:ext cx="2468880" cy="3931920"/>
+          </a:xfrm>
+          <a:prstGeom prst="rect">
+            <a:avLst/>
+          </a:prstGeom>
+          <a:solidFill>
+            <a:srgbClr val="1A202C"/>
+          </a:solidFill>
+          <a:ln w="19050">
+            <a:solidFill>
+              <a:srgbClr val="38BDF8"/>
+            </a:solidFill>
+          </a:ln>
+        </p:spPr>
+        <p:style>
+          <a:lnRef idx="1">
+            <a:schemeClr val="accent1"/>
+          </a:lnRef>
+          <a:fillRef idx="3">
+            <a:schemeClr val="accent1"/>
+          </a:fillRef>
+          <a:effectRef idx="2">
+            <a:schemeClr val="accent1"/>
+          </a:effectRef>
+          <a:fontRef idx="minor">
+            <a:schemeClr val="lt1"/>
+          </a:fontRef>
+        </p:style>
+        <p:txBody>
+          <a:bodyPr rtlCol="0" anchor="ctr" lIns="228600" tIns="274320" wrap="square"/>
+          <a:lstStyle/>
+          <a:p>
+            <a:pPr algn="ctr">
+              <a:defRPr sz="1500" b="1">
+                <a:solidFill>
+                  <a:srgbClr val="38BDF8"/>
+                </a:solidFill>
+                <a:latin typeface="Outfit"/>
+              </a:defRPr>
+            </a:pPr>
+            <a:r>
+              <a:t>HEARING ASSISTANCE</a:t>
+            </a:r>
+          </a:p>
+          <a:p>
+            <a:br/>
+            <a:pPr>
+              <a:defRPr sz="1100">
+                <a:solidFill>
+                  <a:srgbClr val="E2E8F0"/>
+                </a:solidFill>
+                <a:latin typeface="Outfit"/>
+              </a:defRPr>
+            </a:pPr>
+            <a:r>
+              <a:t>Simulated vishing phone calls feature automated visual transcript overlays and clear subtitles, letting hearing-impaired users identify threat patterns without sound.</a:t>
+            </a:r>
+          </a:p>
+        </p:txBody>
+      </p:sp>
+      <p:sp>
+        <p:nvSpPr>
+          <p:cNvPr id="5" name="Rectangle 4"/>
+          <p:cNvSpPr/>
+          <p:nvPr/>
+        </p:nvSpPr>
+        <p:spPr>
+          <a:xfrm>
+            <a:off x="3429000" y="1920240"/>
+            <a:ext cx="2468880" cy="3931920"/>
           </a:xfrm>
           <a:prstGeom prst="rect">
             <a:avLst/>
@@ -4855,11 +4895,11 @@
           </a:fontRef>
         </p:style>
         <p:txBody>
-          <a:bodyPr rtlCol="0" anchor="ctr" lIns="365760" tIns="365760" wrap="square"/>
+          <a:bodyPr rtlCol="0" anchor="ctr" lIns="228600" tIns="274320" wrap="square"/>
           <a:lstStyle/>
           <a:p>
             <a:pPr algn="ctr">
-              <a:defRPr sz="1800" b="1">
+              <a:defRPr sz="1500" b="1">
                 <a:solidFill>
                   <a:srgbClr val="D4AF37"/>
                 </a:solidFill>
@@ -4867,13 +4907,13 @@
               </a:defRPr>
             </a:pPr>
             <a:r>
-              <a:t>ASK THE CYBER GUIDE</a:t>
+              <a:t>VISUAL ADJUSTMENTS</a:t>
             </a:r>
           </a:p>
           <a:p>
             <a:br/>
             <a:pPr>
-              <a:defRPr sz="1400">
+              <a:defRPr sz="1100">
                 <a:solidFill>
                   <a:srgbClr val="E2E8F0"/>
                 </a:solidFill>
@@ -4881,43 +4921,21 @@
               </a:defRPr>
             </a:pPr>
             <a:r>
-              <a:t>• Context-Aware AI Mentor:</a:t>
-            </a:r>
-            <a:br/>
-            <a:r>
-              <a:t>  Greymantle is an in-game guide powered by the Groq chat completions API, available directly inside the labyrinth.</a:t>
-            </a:r>
-            <a:br/>
-            <a:br/>
-            <a:r>
-              <a:t>• Flexible Learning Dialogues:</a:t>
-            </a:r>
-            <a:br/>
-            <a:r>
-              <a:t>  Players can ask open-ended questions about complex threats or buy critical intel hints using coins.</a:t>
-            </a:r>
-            <a:br/>
-            <a:br/>
-            <a:r>
-              <a:t>• Safe Implementation:</a:t>
-            </a:r>
-            <a:br/>
-            <a:r>
-              <a:t>  Calls are proxied server-side to hide raw key exposures and restrict operations to cybersecurity contexts.</a:t>
-            </a:r>
-          </a:p>
-        </p:txBody>
-      </p:sp>
-      <p:sp>
-        <p:nvSpPr>
-          <p:cNvPr id="5" name="Rectangle 4"/>
+              <a:t>Utilizes high-contrast dark backgrounds, responsive scales, gold highlight headers, and clear color coding (green correct vs red incorrect) to help focus.</a:t>
+            </a:r>
+          </a:p>
+        </p:txBody>
+      </p:sp>
+      <p:sp>
+        <p:nvSpPr>
+          <p:cNvPr id="6" name="Rectangle 5"/>
           <p:cNvSpPr/>
           <p:nvPr/>
         </p:nvSpPr>
         <p:spPr>
           <a:xfrm>
-            <a:off x="6355080" y="1645920"/>
-            <a:ext cx="5150815" cy="4114800"/>
+            <a:off x="6172200" y="1920240"/>
+            <a:ext cx="2468880" cy="3931920"/>
           </a:xfrm>
           <a:prstGeom prst="rect">
             <a:avLst/>
@@ -4946,11 +4964,11 @@
           </a:fontRef>
         </p:style>
         <p:txBody>
-          <a:bodyPr rtlCol="0" anchor="ctr" lIns="365760" tIns="365760" wrap="square"/>
+          <a:bodyPr rtlCol="0" anchor="ctr" lIns="228600" tIns="274320" wrap="square"/>
           <a:lstStyle/>
           <a:p>
             <a:pPr algn="ctr">
-              <a:defRPr sz="1800" b="1">
+              <a:defRPr sz="1500" b="1">
                 <a:solidFill>
                   <a:srgbClr val="00FF66"/>
                 </a:solidFill>
@@ -4958,13 +4976,13 @@
               </a:defRPr>
             </a:pPr>
             <a:r>
-              <a:t>VOID COLLECTIVE SECURITY GATES</a:t>
+              <a:t>PHYSICAL CONTROLS</a:t>
             </a:r>
           </a:p>
           <a:p>
             <a:br/>
             <a:pPr>
-              <a:defRPr sz="1400">
+              <a:defRPr sz="1100">
                 <a:solidFill>
                   <a:srgbClr val="E2E8F0"/>
                 </a:solidFill>
@@ -4972,29 +4990,76 @@
               </a:defRPr>
             </a:pPr>
             <a:r>
-              <a:t>• Knowledge Gates:</a:t>
-            </a:r>
-            <a:br/>
-            <a:r>
-              <a:t>  Crucial bottleneck portals blocking labyrinth paths, operated by the digital threat group (Void Collective).</a:t>
-            </a:r>
-            <a:br/>
-            <a:br/>
-            <a:r>
-              <a:t>• Adaptive MCQ Popups:</a:t>
-            </a:r>
-            <a:br/>
-            <a:r>
-              <a:t>  Launches 3 sequential multiple-choice questions on general cyber awareness. Features neatly parallel-aligned options.</a:t>
-            </a:r>
-            <a:br/>
-            <a:br/>
-            <a:r>
-              <a:t>• Success Threshold:</a:t>
-            </a:r>
-            <a:br/>
-            <a:r>
-              <a:t>  Players must score at least 2/3 correct to pass. Failing locks the gate, demanding a restart of the corridor.</a:t>
+              <a:t>Supports simple keyboard controls (WASD/Arrows) and enter key interaction bypasses, offering motor-impaired players straightforward navigation options.</a:t>
+            </a:r>
+          </a:p>
+        </p:txBody>
+      </p:sp>
+      <p:sp>
+        <p:nvSpPr>
+          <p:cNvPr id="7" name="Rectangle 6"/>
+          <p:cNvSpPr/>
+          <p:nvPr/>
+        </p:nvSpPr>
+        <p:spPr>
+          <a:xfrm>
+            <a:off x="8915400" y="1920240"/>
+            <a:ext cx="2468880" cy="3931920"/>
+          </a:xfrm>
+          <a:prstGeom prst="rect">
+            <a:avLst/>
+          </a:prstGeom>
+          <a:solidFill>
+            <a:srgbClr val="1A202C"/>
+          </a:solidFill>
+          <a:ln w="19050">
+            <a:solidFill>
+              <a:srgbClr val="EF4444"/>
+            </a:solidFill>
+          </a:ln>
+        </p:spPr>
+        <p:style>
+          <a:lnRef idx="1">
+            <a:schemeClr val="accent1"/>
+          </a:lnRef>
+          <a:fillRef idx="3">
+            <a:schemeClr val="accent1"/>
+          </a:fillRef>
+          <a:effectRef idx="2">
+            <a:schemeClr val="accent1"/>
+          </a:effectRef>
+          <a:fontRef idx="minor">
+            <a:schemeClr val="lt1"/>
+          </a:fontRef>
+        </p:style>
+        <p:txBody>
+          <a:bodyPr rtlCol="0" anchor="ctr" lIns="228600" tIns="274320" wrap="square"/>
+          <a:lstStyle/>
+          <a:p>
+            <a:pPr algn="ctr">
+              <a:defRPr sz="1500" b="1">
+                <a:solidFill>
+                  <a:srgbClr val="EF4444"/>
+                </a:solidFill>
+                <a:latin typeface="Outfit"/>
+              </a:defRPr>
+            </a:pPr>
+            <a:r>
+              <a:t>HARDWARE BARRIERS</a:t>
+            </a:r>
+          </a:p>
+          <a:p>
+            <a:br/>
+            <a:pPr>
+              <a:defRPr sz="1100">
+                <a:solidFill>
+                  <a:srgbClr val="E2E8F0"/>
+                </a:solidFill>
+                <a:latin typeface="Outfit"/>
+              </a:defRPr>
+            </a:pPr>
+            <a:r>
+              <a:t>Optimized to execute smoothly on standard laptops and integrated graphics, loading under 1.5 seconds even on low-bandwidth connections.</a:t>
             </a:r>
           </a:p>
         </p:txBody>
@@ -5056,7 +5121,7 @@
               </a:defRPr>
             </a:pPr>
             <a:r>
-              <a:t>CYBERQUEST RPG</a:t>
+              <a:t>DELIVERABLE OUTCOME</a:t>
             </a:r>
           </a:p>
         </p:txBody>
@@ -5084,7 +5149,7 @@
           <a:lstStyle/>
           <a:p>
             <a:pPr>
-              <a:defRPr sz="3200" b="1">
+              <a:defRPr sz="3000" b="1">
                 <a:solidFill>
                   <a:srgbClr val="D4AF37"/>
                 </a:solidFill>
@@ -5092,7 +5157,7 @@
               </a:defRPr>
             </a:pPr>
             <a:r>
-              <a:t>Technical Architecture &amp; Security Model</a:t>
+              <a:t>Deliverable Outcome: Simulated Threat Scenarios</a:t>
             </a:r>
           </a:p>
         </p:txBody>
@@ -5106,7 +5171,75 @@
         <p:spPr>
           <a:xfrm>
             <a:off x="685800" y="1645920"/>
-            <a:ext cx="3383280" cy="4114800"/>
+            <a:ext cx="5120640" cy="1920240"/>
+          </a:xfrm>
+          <a:prstGeom prst="rect">
+            <a:avLst/>
+          </a:prstGeom>
+          <a:solidFill>
+            <a:srgbClr val="1A202C"/>
+          </a:solidFill>
+          <a:ln w="19050">
+            <a:solidFill>
+              <a:srgbClr val="D4AF37"/>
+            </a:solidFill>
+          </a:ln>
+        </p:spPr>
+        <p:style>
+          <a:lnRef idx="1">
+            <a:schemeClr val="accent1"/>
+          </a:lnRef>
+          <a:fillRef idx="3">
+            <a:schemeClr val="accent1"/>
+          </a:fillRef>
+          <a:effectRef idx="2">
+            <a:schemeClr val="accent1"/>
+          </a:effectRef>
+          <a:fontRef idx="minor">
+            <a:schemeClr val="lt1"/>
+          </a:fontRef>
+        </p:style>
+        <p:txBody>
+          <a:bodyPr rtlCol="0" anchor="ctr" lIns="182880" rIns="182880" tIns="127000" wrap="square"/>
+          <a:lstStyle/>
+          <a:p>
+            <a:pPr algn="ctr">
+              <a:defRPr sz="1500" b="1">
+                <a:solidFill>
+                  <a:srgbClr val="D4AF37"/>
+                </a:solidFill>
+                <a:latin typeface="Outfit"/>
+              </a:defRPr>
+            </a:pPr>
+            <a:r>
+              <a:t>01 | PHISHING LINKS (HOMOGRAPH ATTACKS)</a:t>
+            </a:r>
+          </a:p>
+          <a:p>
+            <a:pPr>
+              <a:defRPr sz="1200">
+                <a:solidFill>
+                  <a:srgbClr val="E2E8F0"/>
+                </a:solidFill>
+                <a:latin typeface="Outfit"/>
+              </a:defRPr>
+            </a:pPr>
+            <a:r>
+              <a:t>Simulated security alerts. Hovering over a fake link reveals its destination URL, highlighting homograph traps (such as Cyrillic 'ı' in arcadıakyc-login.org).</a:t>
+            </a:r>
+          </a:p>
+        </p:txBody>
+      </p:sp>
+      <p:sp>
+        <p:nvSpPr>
+          <p:cNvPr id="5" name="Rectangle 4"/>
+          <p:cNvSpPr/>
+          <p:nvPr/>
+        </p:nvSpPr>
+        <p:spPr>
+          <a:xfrm>
+            <a:off x="6385255" y="1645920"/>
+            <a:ext cx="5120640" cy="1920240"/>
           </a:xfrm>
           <a:prstGeom prst="rect">
             <a:avLst/>
@@ -5135,11 +5268,11 @@
           </a:fontRef>
         </p:style>
         <p:txBody>
-          <a:bodyPr rtlCol="0" anchor="ctr" lIns="274320" tIns="274320" wrap="square"/>
+          <a:bodyPr rtlCol="0" anchor="ctr" lIns="182880" rIns="182880" tIns="127000" wrap="square"/>
           <a:lstStyle/>
           <a:p>
             <a:pPr algn="ctr">
-              <a:defRPr sz="1600" b="1">
+              <a:defRPr sz="1500" b="1">
                 <a:solidFill>
                   <a:srgbClr val="38BDF8"/>
                 </a:solidFill>
@@ -5147,11 +5280,10 @@
               </a:defRPr>
             </a:pPr>
             <a:r>
-              <a:t>FRONTEND &amp; GRAPHICS</a:t>
-            </a:r>
-          </a:p>
-          <a:p>
-            <a:br/>
+              <a:t>02 | SOCIAL ENGINEERING VISHING SIMULATION</a:t>
+            </a:r>
+          </a:p>
+          <a:p>
             <a:pPr>
               <a:defRPr sz="1200">
                 <a:solidFill>
@@ -5161,43 +5293,21 @@
               </a:defRPr>
             </a:pPr>
             <a:r>
-              <a:t>• Vanilla Web Core:</a:t>
-            </a:r>
-            <a:br/>
-            <a:r>
-              <a:t>  HTML5, Vanilla CSS, and JavaScript. Maximizes loading speed and cross-platform compatibility.</a:t>
-            </a:r>
-            <a:br/>
-            <a:br/>
-            <a:r>
-              <a:t>• 3D Environment:</a:t>
-            </a:r>
-            <a:br/>
-            <a:r>
-              <a:t>  Three.js (r128) creates a first-person navigation space without engine overhead.</a:t>
-            </a:r>
-            <a:br/>
-            <a:br/>
-            <a:r>
-              <a:t>• Responsive Design:</a:t>
-            </a:r>
-            <a:br/>
-            <a:r>
-              <a:t>  Fully adaptative to diverse screen sizes, ensuring fluid rendering.</a:t>
-            </a:r>
-          </a:p>
-        </p:txBody>
-      </p:sp>
-      <p:sp>
-        <p:nvSpPr>
-          <p:cNvPr id="5" name="Rectangle 4"/>
+              <a:t>Simulates phone calls (e.g. Arcadia Bank Fraud Team) pressuring the user to reveal OTPs. Players must reject the call and verify through official channels.</a:t>
+            </a:r>
+          </a:p>
+        </p:txBody>
+      </p:sp>
+      <p:sp>
+        <p:nvSpPr>
+          <p:cNvPr id="6" name="Rectangle 5"/>
           <p:cNvSpPr/>
           <p:nvPr/>
         </p:nvSpPr>
         <p:spPr>
           <a:xfrm>
-            <a:off x="4434840" y="1645920"/>
-            <a:ext cx="3383280" cy="4114800"/>
+            <a:off x="685800" y="3840480"/>
+            <a:ext cx="5120640" cy="1920240"/>
           </a:xfrm>
           <a:prstGeom prst="rect">
             <a:avLst/>
@@ -5207,7 +5317,7 @@
           </a:solidFill>
           <a:ln w="19050">
             <a:solidFill>
-              <a:srgbClr val="D4AF37"/>
+              <a:srgbClr val="EF4444"/>
             </a:solidFill>
           </a:ln>
         </p:spPr>
@@ -5226,23 +5336,22 @@
           </a:fontRef>
         </p:style>
         <p:txBody>
-          <a:bodyPr rtlCol="0" anchor="ctr" lIns="274320" tIns="274320" wrap="square"/>
+          <a:bodyPr rtlCol="0" anchor="ctr" lIns="182880" rIns="182880" tIns="127000" wrap="square"/>
           <a:lstStyle/>
           <a:p>
             <a:pPr algn="ctr">
-              <a:defRPr sz="1600" b="1">
-                <a:solidFill>
-                  <a:srgbClr val="D4AF37"/>
+              <a:defRPr sz="1500" b="1">
+                <a:solidFill>
+                  <a:srgbClr val="EF4444"/>
                 </a:solidFill>
                 <a:latin typeface="Outfit"/>
               </a:defRPr>
             </a:pPr>
             <a:r>
-              <a:t>BACKEND &amp; LOGISTIC SERVICES</a:t>
-            </a:r>
-          </a:p>
-          <a:p>
-            <a:br/>
+              <a:t>03 | MALWARE UPDATES &amp; POPUPS</a:t>
+            </a:r>
+          </a:p>
+          <a:p>
             <a:pPr>
               <a:defRPr sz="1200">
                 <a:solidFill>
@@ -5252,43 +5361,21 @@
               </a:defRPr>
             </a:pPr>
             <a:r>
-              <a:t>• Firebase Hosting:</a:t>
-            </a:r>
-            <a:br/>
-            <a:r>
-              <a:t>  Global CDN deployment ensuring sub-second page access worldwide.</a:t>
-            </a:r>
-            <a:br/>
-            <a:br/>
-            <a:r>
-              <a:t>• Cloud Firestore:</a:t>
-            </a:r>
-            <a:br/>
-            <a:r>
-              <a:t>  Tracks global threat statistics and maintains realtime leaderboard databases.</a:t>
-            </a:r>
-            <a:br/>
-            <a:br/>
-            <a:r>
-              <a:t>• Anonymous Auth:</a:t>
-            </a:r>
-            <a:br/>
-            <a:r>
-              <a:t>  Frictionless onboarding. Generates pseudonyms (e.g. Guardian #1731) to respect user privacy.</a:t>
-            </a:r>
-          </a:p>
-        </p:txBody>
-      </p:sp>
-      <p:sp>
-        <p:nvSpPr>
-          <p:cNvPr id="6" name="Rectangle 5"/>
+              <a:t>Deceptive popup updating alerts block corridor lanes. Players must spot signature visual red flags and redirect to official vendor stores.</a:t>
+            </a:r>
+          </a:p>
+        </p:txBody>
+      </p:sp>
+      <p:sp>
+        <p:nvSpPr>
+          <p:cNvPr id="7" name="Rectangle 6"/>
           <p:cNvSpPr/>
           <p:nvPr/>
         </p:nvSpPr>
         <p:spPr>
           <a:xfrm>
-            <a:off x="8183880" y="1645920"/>
-            <a:ext cx="3383280" cy="4114800"/>
+            <a:off x="6385255" y="3840480"/>
+            <a:ext cx="5120640" cy="1920240"/>
           </a:xfrm>
           <a:prstGeom prst="rect">
             <a:avLst/>
@@ -5317,11 +5404,11 @@
           </a:fontRef>
         </p:style>
         <p:txBody>
-          <a:bodyPr rtlCol="0" anchor="ctr" lIns="274320" tIns="274320" wrap="square"/>
+          <a:bodyPr rtlCol="0" anchor="ctr" lIns="182880" rIns="182880" tIns="127000" wrap="square"/>
           <a:lstStyle/>
           <a:p>
             <a:pPr algn="ctr">
-              <a:defRPr sz="1600" b="1">
+              <a:defRPr sz="1500" b="1">
                 <a:solidFill>
                   <a:srgbClr val="00FF66"/>
                 </a:solidFill>
@@ -5329,11 +5416,10 @@
               </a:defRPr>
             </a:pPr>
             <a:r>
-              <a:t>PROXY SECURED AI ENGINE</a:t>
-            </a:r>
-          </a:p>
-          <a:p>
-            <a:br/>
+              <a:t>04 | CREDENTIAL HYGIENE &amp; FORTRESS GATES</a:t>
+            </a:r>
+          </a:p>
+          <a:p>
             <a:pPr>
               <a:defRPr sz="1200">
                 <a:solidFill>
@@ -5343,29 +5429,7 @@
               </a:defRPr>
             </a:pPr>
             <a:r>
-              <a:t>• Server-side API Protection:</a:t>
-            </a:r>
-            <a:br/>
-            <a:r>
-              <a:t>  Requests to the LLM are routed through a Firebase Function endpoint (/api/guide).</a:t>
-            </a:r>
-            <a:br/>
-            <a:br/>
-            <a:r>
-              <a:t>• Groq Chat Completions:</a:t>
-            </a:r>
-            <a:br/>
-            <a:r>
-              <a:t>  Powers conversational AI, answering dynamic security queries.</a:t>
-            </a:r>
-            <a:br/>
-            <a:br/>
-            <a:r>
-              <a:t>• Key Obfuscation:</a:t>
-            </a:r>
-            <a:br/>
-            <a:r>
-              <a:t>  Prevents API key exposure in browser client bundles, satisfying push protection rules.</a:t>
+              <a:t>Explores brute-force mechanics, reinforcing passphrase length, multi-factor authentication (MFA), and credential reuse hazards.</a:t>
             </a:r>
           </a:p>
         </p:txBody>
@@ -5427,7 +5491,7 @@
               </a:defRPr>
             </a:pPr>
             <a:r>
-              <a:t>CYBERQUEST RPG</a:t>
+              <a:t>DELIVERABLE OUTCOME</a:t>
             </a:r>
           </a:p>
         </p:txBody>
@@ -5455,7 +5519,7 @@
           <a:lstStyle/>
           <a:p>
             <a:pPr>
-              <a:defRPr sz="3200" b="1">
+              <a:defRPr sz="3000" b="1">
                 <a:solidFill>
                   <a:srgbClr val="D4AF37"/>
                 </a:solidFill>
@@ -5463,7 +5527,7 @@
               </a:defRPr>
             </a:pPr>
             <a:r>
-              <a:t>Gamified Evaluation &amp; Leaderboard Mechanics</a:t>
+              <a:t>Deliverable Outcome: Conversational Guide &amp; MCQ Gates</a:t>
             </a:r>
           </a:p>
         </p:txBody>
@@ -5478,155 +5542,6 @@
           <a:xfrm>
             <a:off x="685800" y="1645920"/>
             <a:ext cx="5120640" cy="4114800"/>
-          </a:xfrm>
-          <a:prstGeom prst="rect">
-            <a:avLst/>
-          </a:prstGeom>
-          <a:solidFill>
-            <a:srgbClr val="1A202C"/>
-          </a:solidFill>
-          <a:ln w="25400">
-            <a:solidFill>
-              <a:srgbClr val="D4AF37"/>
-            </a:solidFill>
-          </a:ln>
-        </p:spPr>
-        <p:style>
-          <a:lnRef idx="1">
-            <a:schemeClr val="accent1"/>
-          </a:lnRef>
-          <a:fillRef idx="3">
-            <a:schemeClr val="accent1"/>
-          </a:fillRef>
-          <a:effectRef idx="2">
-            <a:schemeClr val="accent1"/>
-          </a:effectRef>
-          <a:fontRef idx="minor">
-            <a:schemeClr val="lt1"/>
-          </a:fontRef>
-        </p:style>
-        <p:txBody>
-          <a:bodyPr rtlCol="0" anchor="ctr" lIns="365760" tIns="365760" wrap="square"/>
-          <a:lstStyle/>
-          <a:p>
-            <a:pPr algn="ctr">
-              <a:defRPr sz="1800" b="1">
-                <a:solidFill>
-                  <a:srgbClr val="D4AF37"/>
-                </a:solidFill>
-                <a:latin typeface="Outfit"/>
-              </a:defRPr>
-            </a:pPr>
-            <a:r>
-              <a:t>THE GUARDIAN PERFORMANCE FORMULA</a:t>
-            </a:r>
-          </a:p>
-          <a:p>
-            <a:br/>
-            <a:pPr>
-              <a:defRPr sz="1400">
-                <a:solidFill>
-                  <a:srgbClr val="E2E8F0"/>
-                </a:solidFill>
-                <a:latin typeface="Outfit"/>
-              </a:defRPr>
-            </a:pPr>
-            <a:r>
-              <a:t>CyberQuest evaluates player decisions based on an active defense formula:</a:t>
-            </a:r>
-          </a:p>
-          <a:p>
-            <a:br/>
-            <a:br/>
-            <a:br/>
-            <a:br/>
-            <a:pPr>
-              <a:defRPr sz="1200">
-                <a:solidFill>
-                  <a:srgbClr val="E2E8F0"/>
-                </a:solidFill>
-                <a:latin typeface="Outfit"/>
-              </a:defRPr>
-            </a:pPr>
-            <a:r>
-              <a:t>• XP represents successful threat spotting.</a:t>
-            </a:r>
-            <a:br/>
-            <a:r>
-              <a:t>• Accuracy rewards precision in choice trials.</a:t>
-            </a:r>
-            <a:br/>
-            <a:r>
-              <a:t>• HP remaining ensures survival tactics were applied.</a:t>
-            </a:r>
-          </a:p>
-        </p:txBody>
-      </p:sp>
-      <p:sp>
-        <p:nvSpPr>
-          <p:cNvPr id="5" name="Rectangle 4"/>
-          <p:cNvSpPr/>
-          <p:nvPr/>
-        </p:nvSpPr>
-        <p:spPr>
-          <a:xfrm>
-            <a:off x="1051560" y="2743200"/>
-            <a:ext cx="4389120" cy="1097280"/>
-          </a:xfrm>
-          <a:prstGeom prst="rect">
-            <a:avLst/>
-          </a:prstGeom>
-          <a:solidFill>
-            <a:srgbClr val="0B0E14"/>
-          </a:solidFill>
-          <a:ln w="12700">
-            <a:solidFill>
-              <a:srgbClr val="38BDF8"/>
-            </a:solidFill>
-          </a:ln>
-        </p:spPr>
-        <p:style>
-          <a:lnRef idx="1">
-            <a:schemeClr val="accent1"/>
-          </a:lnRef>
-          <a:fillRef idx="3">
-            <a:schemeClr val="accent1"/>
-          </a:fillRef>
-          <a:effectRef idx="2">
-            <a:schemeClr val="accent1"/>
-          </a:effectRef>
-          <a:fontRef idx="minor">
-            <a:schemeClr val="lt1"/>
-          </a:fontRef>
-        </p:style>
-        <p:txBody>
-          <a:bodyPr rtlCol="0" anchor="ctr" wrap="square"/>
-          <a:lstStyle/>
-          <a:p>
-            <a:pPr algn="ctr">
-              <a:defRPr sz="1800" b="1">
-                <a:solidFill>
-                  <a:srgbClr val="00FF66"/>
-                </a:solidFill>
-                <a:latin typeface="Outfit"/>
-              </a:defRPr>
-            </a:pPr>
-            <a:r>
-              <a:t>Score = XP + (Accuracy% × 2) + HP</a:t>
-            </a:r>
-          </a:p>
-        </p:txBody>
-      </p:sp>
-      <p:sp>
-        <p:nvSpPr>
-          <p:cNvPr id="6" name="Rectangle 5"/>
-          <p:cNvSpPr/>
-          <p:nvPr/>
-        </p:nvSpPr>
-        <p:spPr>
-          <a:xfrm>
-            <a:off x="6355080" y="1645920"/>
-            <a:ext cx="5150815" cy="4114800"/>
           </a:xfrm>
           <a:prstGeom prst="rect">
             <a:avLst/>
@@ -5636,7 +5551,7 @@
           </a:solidFill>
           <a:ln w="19050">
             <a:solidFill>
-              <a:srgbClr val="38BDF8"/>
+              <a:srgbClr val="D4AF37"/>
             </a:solidFill>
           </a:ln>
         </p:spPr>
@@ -5661,13 +5576,13 @@
             <a:pPr algn="ctr">
               <a:defRPr sz="1800" b="1">
                 <a:solidFill>
-                  <a:srgbClr val="38BDF8"/>
+                  <a:srgbClr val="D4AF37"/>
                 </a:solidFill>
                 <a:latin typeface="Outfit"/>
               </a:defRPr>
             </a:pPr>
             <a:r>
-              <a:t>THE REWARDS &amp; RETENTION LOOP</a:t>
+              <a:t>ASK THE CYBER GUIDE</a:t>
             </a:r>
           </a:p>
           <a:p>
@@ -5681,30 +5596,158 @@
               </a:defRPr>
             </a:pPr>
             <a:r>
-              <a:t>• Leaderboard Integration:</a:t>
-            </a:r>
-            <a:br/>
-            <a:r>
-              <a:t>  Scores are saved to Firestore, fostering healthy competition across schools, teams, and organizations.</a:t>
-            </a:r>
-            <a:br/>
-            <a:br/>
-            <a:r>
-              <a:t>• Instant Feedback Loops:</a:t>
-            </a:r>
-            <a:br/>
-            <a:r>
-              <a:t>  Mistakes are shown immediately, showing why an action was insecure. Fosters rapid behavioral correction.</a:t>
-            </a:r>
-            <a:br/>
-            <a:br/>
-            <a:r>
-              <a:t>• Safe Failure Sandbox:</a:t>
-            </a:r>
-            <a:br/>
-            <a:r>
-              <a:t>  Users fail, reset, and correct. Overcomes the fear of learning security procedures.</a:t>
-            </a:r>
+              <a:t>• Serverless LLM Mentor:</a:t>
+            </a:r>
+            <a:br/>
+            <a:r>
+              <a:t>  Greymantle answers dynamic player questions inside the game context, using Firestore logs for history.</a:t>
+            </a:r>
+            <a:br/>
+            <a:br/>
+            <a:r>
+              <a:t>• Risk-free Inquiry:</a:t>
+            </a:r>
+            <a:br/>
+            <a:r>
+              <a:t>  Players clarify complex threats safely during gameplay, or purchase tactical guides using coins.</a:t>
+            </a:r>
+            <a:br/>
+            <a:br/>
+            <a:r>
+              <a:t>• Secure Architecture:</a:t>
+            </a:r>
+            <a:br/>
+            <a:r>
+              <a:t>  Proxies API keys server-side via Firebase Cloud Functions, resolving key leakage alerts.</a:t>
+            </a:r>
+          </a:p>
+        </p:txBody>
+      </p:sp>
+      <p:sp>
+        <p:nvSpPr>
+          <p:cNvPr id="5" name="Rectangle 4"/>
+          <p:cNvSpPr/>
+          <p:nvPr/>
+        </p:nvSpPr>
+        <p:spPr>
+          <a:xfrm>
+            <a:off x="6355080" y="1645920"/>
+            <a:ext cx="5150815" cy="4114800"/>
+          </a:xfrm>
+          <a:prstGeom prst="rect">
+            <a:avLst/>
+          </a:prstGeom>
+          <a:solidFill>
+            <a:srgbClr val="1A202C"/>
+          </a:solidFill>
+          <a:ln w="19050">
+            <a:solidFill>
+              <a:srgbClr val="00FF66"/>
+            </a:solidFill>
+          </a:ln>
+        </p:spPr>
+        <p:style>
+          <a:lnRef idx="1">
+            <a:schemeClr val="accent1"/>
+          </a:lnRef>
+          <a:fillRef idx="3">
+            <a:schemeClr val="accent1"/>
+          </a:fillRef>
+          <a:effectRef idx="2">
+            <a:schemeClr val="accent1"/>
+          </a:effectRef>
+          <a:fontRef idx="minor">
+            <a:schemeClr val="lt1"/>
+          </a:fontRef>
+        </p:style>
+        <p:txBody>
+          <a:bodyPr rtlCol="0" anchor="ctr" lIns="365760" tIns="365760" wrap="square"/>
+          <a:lstStyle/>
+          <a:p>
+            <a:pPr algn="ctr">
+              <a:defRPr sz="1800" b="1">
+                <a:solidFill>
+                  <a:srgbClr val="00FF66"/>
+                </a:solidFill>
+                <a:latin typeface="Outfit"/>
+              </a:defRPr>
+            </a:pPr>
+            <a:r>
+              <a:t>VOID COLLECTIVE SECURITY GATES</a:t>
+            </a:r>
+          </a:p>
+          <a:p>
+            <a:br/>
+            <a:pPr>
+              <a:defRPr sz="1400">
+                <a:solidFill>
+                  <a:srgbClr val="E2E8F0"/>
+                </a:solidFill>
+                <a:latin typeface="Outfit"/>
+              </a:defRPr>
+            </a:pPr>
+            <a:r>
+              <a:t>• MCQ Checkpoints:</a:t>
+            </a:r>
+            <a:br/>
+            <a:r>
+              <a:t>  Checkpoint gates block paths, requiring players to clear a 3-question MCQ quiz to collect key segments.</a:t>
+            </a:r>
+            <a:br/>
+            <a:br/>
+            <a:r>
+              <a:t>• Sequential Quiz Interface:</a:t>
+            </a:r>
+            <a:br/>
+            <a:r>
+              <a:t>  Presents questions one-at-a-time, featuring parallel-aligned choices and a clean flow.</a:t>
+            </a:r>
+            <a:br/>
+            <a:br/>
+            <a:r>
+              <a:t>• Threshold Enforcement:</a:t>
+            </a:r>
+            <a:br/>
+            <a:r>
+              <a:t>  Requires a score of 2/3 correct to bypass. Failing locks the gate, demanding a retry of the corridor.</a:t>
+            </a:r>
+          </a:p>
+        </p:txBody>
+      </p:sp>
+      <p:sp>
+        <p:nvSpPr>
+          <p:cNvPr id="6" name="Rectangle 5"/>
+          <p:cNvSpPr/>
+          <p:nvPr/>
+        </p:nvSpPr>
+        <p:spPr>
+          <a:xfrm>
+            <a:off x="685800" y="1645920"/>
+            <a:ext cx="5120640" cy="4114800"/>
+          </a:xfrm>
+          <a:prstGeom prst="rect">
+            <a:avLst/>
+          </a:prstGeom>
+        </p:spPr>
+        <p:style>
+          <a:lnRef idx="1">
+            <a:schemeClr val="accent1"/>
+          </a:lnRef>
+          <a:fillRef idx="3">
+            <a:schemeClr val="accent1"/>
+          </a:fillRef>
+          <a:effectRef idx="2">
+            <a:schemeClr val="accent1"/>
+          </a:effectRef>
+          <a:fontRef idx="minor">
+            <a:schemeClr val="lt1"/>
+          </a:fontRef>
+        </p:style>
+        <p:txBody>
+          <a:bodyPr rtlCol="0" anchor="ctr"/>
+          <a:lstStyle/>
+          <a:p>
+            <a:pPr algn="ctr"/>
           </a:p>
         </p:txBody>
       </p:sp>
@@ -5765,7 +5808,7 @@
               </a:defRPr>
             </a:pPr>
             <a:r>
-              <a:t>CYBERQUEST RPG</a:t>
+              <a:t>DELIVERABLE OUTCOME</a:t>
             </a:r>
           </a:p>
         </p:txBody>
@@ -5793,7 +5836,7 @@
           <a:lstStyle/>
           <a:p>
             <a:pPr>
-              <a:defRPr sz="3200" b="1">
+              <a:defRPr sz="3000" b="1">
                 <a:solidFill>
                   <a:srgbClr val="D4AF37"/>
                 </a:solidFill>
@@ -5801,43 +5844,101 @@
               </a:defRPr>
             </a:pPr>
             <a:r>
-              <a:t>Solutions Supporting Accessibility &amp; Inclusivity</a:t>
-            </a:r>
-          </a:p>
-        </p:txBody>
-      </p:sp>
-      <p:sp>
-        <p:nvSpPr>
-          <p:cNvPr id="4" name="TextBox 3"/>
-          <p:cNvSpPr txBox="1"/>
+              <a:t>Deliverable Outcome: Gamified Score &amp; Leaderboard</a:t>
+            </a:r>
+          </a:p>
+        </p:txBody>
+      </p:sp>
+      <p:sp>
+        <p:nvSpPr>
+          <p:cNvPr id="4" name="Rectangle 3"/>
+          <p:cNvSpPr/>
           <p:nvPr/>
         </p:nvSpPr>
         <p:spPr>
           <a:xfrm>
-            <a:off x="685800" y="1280160"/>
-            <a:ext cx="10817352" cy="548640"/>
+            <a:off x="685800" y="1645920"/>
+            <a:ext cx="5120640" cy="4114800"/>
           </a:xfrm>
           <a:prstGeom prst="rect">
             <a:avLst/>
           </a:prstGeom>
-          <a:noFill/>
-        </p:spPr>
-        <p:txBody>
-          <a:bodyPr wrap="square">
-            <a:spAutoFit/>
-          </a:bodyPr>
-          <a:lstStyle/>
-          <a:p>
+          <a:solidFill>
+            <a:srgbClr val="1A202C"/>
+          </a:solidFill>
+          <a:ln w="25400">
+            <a:solidFill>
+              <a:srgbClr val="D4AF37"/>
+            </a:solidFill>
+          </a:ln>
+        </p:spPr>
+        <p:style>
+          <a:lnRef idx="1">
+            <a:schemeClr val="accent1"/>
+          </a:lnRef>
+          <a:fillRef idx="3">
+            <a:schemeClr val="accent1"/>
+          </a:fillRef>
+          <a:effectRef idx="2">
+            <a:schemeClr val="accent1"/>
+          </a:effectRef>
+          <a:fontRef idx="minor">
+            <a:schemeClr val="lt1"/>
+          </a:fontRef>
+        </p:style>
+        <p:txBody>
+          <a:bodyPr rtlCol="0" anchor="ctr" lIns="365760" tIns="365760" wrap="square"/>
+          <a:lstStyle/>
+          <a:p>
+            <a:pPr algn="ctr">
+              <a:defRPr sz="1800" b="1">
+                <a:solidFill>
+                  <a:srgbClr val="D4AF37"/>
+                </a:solidFill>
+                <a:latin typeface="Outfit"/>
+              </a:defRPr>
+            </a:pPr>
+            <a:r>
+              <a:t>THE GUARDIAN PERFORMANCE FORMULA</a:t>
+            </a:r>
+          </a:p>
+          <a:p>
+            <a:br/>
             <a:pPr>
-              <a:defRPr sz="1500">
-                <a:solidFill>
-                  <a:srgbClr val="FFFFFF"/>
+              <a:defRPr sz="1400">
+                <a:solidFill>
+                  <a:srgbClr val="E2E8F0"/>
                 </a:solidFill>
                 <a:latin typeface="Outfit"/>
               </a:defRPr>
             </a:pPr>
             <a:r>
-              <a:t>CyberQuest is engineered to support users with disabilities and varying hardware constraints.</a:t>
+              <a:t>Player achievements are graded using an active defense formula:</a:t>
+            </a:r>
+          </a:p>
+          <a:p>
+            <a:br/>
+            <a:br/>
+            <a:br/>
+            <a:br/>
+            <a:pPr>
+              <a:defRPr sz="1200">
+                <a:solidFill>
+                  <a:srgbClr val="E2E8F0"/>
+                </a:solidFill>
+                <a:latin typeface="Outfit"/>
+              </a:defRPr>
+            </a:pPr>
+            <a:r>
+              <a:t>• XP represents successful threat spotting.</a:t>
+            </a:r>
+            <a:br/>
+            <a:r>
+              <a:t>• Accuracy rewards precision in choice trials.</a:t>
+            </a:r>
+            <a:br/>
+            <a:r>
+              <a:t>• HP remaining ensures survival tactics were applied.</a:t>
             </a:r>
           </a:p>
         </p:txBody>
@@ -5850,8 +5951,63 @@
         </p:nvSpPr>
         <p:spPr>
           <a:xfrm>
-            <a:off x="685800" y="1920240"/>
-            <a:ext cx="2468880" cy="3931920"/>
+            <a:off x="1051560" y="2743200"/>
+            <a:ext cx="4389120" cy="1097280"/>
+          </a:xfrm>
+          <a:prstGeom prst="rect">
+            <a:avLst/>
+          </a:prstGeom>
+          <a:solidFill>
+            <a:srgbClr val="0B0E14"/>
+          </a:solidFill>
+          <a:ln w="12700">
+            <a:solidFill>
+              <a:srgbClr val="38BDF8"/>
+            </a:solidFill>
+          </a:ln>
+        </p:spPr>
+        <p:style>
+          <a:lnRef idx="1">
+            <a:schemeClr val="accent1"/>
+          </a:lnRef>
+          <a:fillRef idx="3">
+            <a:schemeClr val="accent1"/>
+          </a:fillRef>
+          <a:effectRef idx="2">
+            <a:schemeClr val="accent1"/>
+          </a:effectRef>
+          <a:fontRef idx="minor">
+            <a:schemeClr val="lt1"/>
+          </a:fontRef>
+        </p:style>
+        <p:txBody>
+          <a:bodyPr rtlCol="0" anchor="ctr" wrap="square"/>
+          <a:lstStyle/>
+          <a:p>
+            <a:pPr algn="ctr">
+              <a:defRPr sz="1800" b="1">
+                <a:solidFill>
+                  <a:srgbClr val="00FF66"/>
+                </a:solidFill>
+                <a:latin typeface="Outfit"/>
+              </a:defRPr>
+            </a:pPr>
+            <a:r>
+              <a:t>Score = XP + (Accuracy% × 2) + HP</a:t>
+            </a:r>
+          </a:p>
+        </p:txBody>
+      </p:sp>
+      <p:sp>
+        <p:nvSpPr>
+          <p:cNvPr id="6" name="Rectangle 5"/>
+          <p:cNvSpPr/>
+          <p:nvPr/>
+        </p:nvSpPr>
+        <p:spPr>
+          <a:xfrm>
+            <a:off x="6355080" y="1645920"/>
+            <a:ext cx="5150815" cy="4114800"/>
           </a:xfrm>
           <a:prstGeom prst="rect">
             <a:avLst/>
@@ -5880,11 +6036,11 @@
           </a:fontRef>
         </p:style>
         <p:txBody>
-          <a:bodyPr rtlCol="0" anchor="ctr" lIns="228600" tIns="274320" wrap="square"/>
+          <a:bodyPr rtlCol="0" anchor="ctr" lIns="365760" tIns="365760" wrap="square"/>
           <a:lstStyle/>
           <a:p>
             <a:pPr algn="ctr">
-              <a:defRPr sz="1600" b="1">
+              <a:defRPr sz="1800" b="1">
                 <a:solidFill>
                   <a:srgbClr val="38BDF8"/>
                 </a:solidFill>
@@ -5892,13 +6048,13 @@
               </a:defRPr>
             </a:pPr>
             <a:r>
-              <a:t>HEARING IMPAIRED</a:t>
+              <a:t>LEADERBOARD &amp; ENGAGEMENT LOOP</a:t>
             </a:r>
           </a:p>
           <a:p>
             <a:br/>
             <a:pPr>
-              <a:defRPr sz="1100">
+              <a:defRPr sz="1400">
                 <a:solidFill>
                   <a:srgbClr val="E2E8F0"/>
                 </a:solidFill>
@@ -5906,214 +6062,29 @@
               </a:defRPr>
             </a:pPr>
             <a:r>
-              <a:t>Simulated vishing calls include visual transcript overlays and clear subtitle text, enabling deaf or hard-of-hearing users to evaluate vocal pressure tricks.</a:t>
-            </a:r>
-          </a:p>
-        </p:txBody>
-      </p:sp>
-      <p:sp>
-        <p:nvSpPr>
-          <p:cNvPr id="6" name="Rectangle 5"/>
-          <p:cNvSpPr/>
-          <p:nvPr/>
-        </p:nvSpPr>
-        <p:spPr>
-          <a:xfrm>
-            <a:off x="3429000" y="1920240"/>
-            <a:ext cx="2468880" cy="3931920"/>
-          </a:xfrm>
-          <a:prstGeom prst="rect">
-            <a:avLst/>
-          </a:prstGeom>
-          <a:solidFill>
-            <a:srgbClr val="1A202C"/>
-          </a:solidFill>
-          <a:ln w="19050">
-            <a:solidFill>
-              <a:srgbClr val="D4AF37"/>
-            </a:solidFill>
-          </a:ln>
-        </p:spPr>
-        <p:style>
-          <a:lnRef idx="1">
-            <a:schemeClr val="accent1"/>
-          </a:lnRef>
-          <a:fillRef idx="3">
-            <a:schemeClr val="accent1"/>
-          </a:fillRef>
-          <a:effectRef idx="2">
-            <a:schemeClr val="accent1"/>
-          </a:effectRef>
-          <a:fontRef idx="minor">
-            <a:schemeClr val="lt1"/>
-          </a:fontRef>
-        </p:style>
-        <p:txBody>
-          <a:bodyPr rtlCol="0" anchor="ctr" lIns="228600" tIns="274320" wrap="square"/>
-          <a:lstStyle/>
-          <a:p>
-            <a:pPr algn="ctr">
-              <a:defRPr sz="1600" b="1">
-                <a:solidFill>
-                  <a:srgbClr val="D4AF37"/>
-                </a:solidFill>
-                <a:latin typeface="Outfit"/>
-              </a:defRPr>
-            </a:pPr>
-            <a:r>
-              <a:t>COGNITIVE &amp; VISUAL</a:t>
-            </a:r>
-          </a:p>
-          <a:p>
-            <a:br/>
-            <a:pPr>
-              <a:defRPr sz="1100">
-                <a:solidFill>
-                  <a:srgbClr val="E2E8F0"/>
-                </a:solidFill>
-                <a:latin typeface="Outfit"/>
-              </a:defRPr>
-            </a:pPr>
-            <a:r>
-              <a:t>Uses a dark-mode theme by default, clear high-contrast typography, and intuitive color coding (gold highlights, red threat warnings) to support focus.</a:t>
-            </a:r>
-          </a:p>
-        </p:txBody>
-      </p:sp>
-      <p:sp>
-        <p:nvSpPr>
-          <p:cNvPr id="7" name="Rectangle 6"/>
-          <p:cNvSpPr/>
-          <p:nvPr/>
-        </p:nvSpPr>
-        <p:spPr>
-          <a:xfrm>
-            <a:off x="6172200" y="1920240"/>
-            <a:ext cx="2468880" cy="3931920"/>
-          </a:xfrm>
-          <a:prstGeom prst="rect">
-            <a:avLst/>
-          </a:prstGeom>
-          <a:solidFill>
-            <a:srgbClr val="1A202C"/>
-          </a:solidFill>
-          <a:ln w="19050">
-            <a:solidFill>
-              <a:srgbClr val="00FF66"/>
-            </a:solidFill>
-          </a:ln>
-        </p:spPr>
-        <p:style>
-          <a:lnRef idx="1">
-            <a:schemeClr val="accent1"/>
-          </a:lnRef>
-          <a:fillRef idx="3">
-            <a:schemeClr val="accent1"/>
-          </a:fillRef>
-          <a:effectRef idx="2">
-            <a:schemeClr val="accent1"/>
-          </a:effectRef>
-          <a:fontRef idx="minor">
-            <a:schemeClr val="lt1"/>
-          </a:fontRef>
-        </p:style>
-        <p:txBody>
-          <a:bodyPr rtlCol="0" anchor="ctr" lIns="228600" tIns="274320" wrap="square"/>
-          <a:lstStyle/>
-          <a:p>
-            <a:pPr algn="ctr">
-              <a:defRPr sz="1600" b="1">
-                <a:solidFill>
-                  <a:srgbClr val="00FF66"/>
-                </a:solidFill>
-                <a:latin typeface="Outfit"/>
-              </a:defRPr>
-            </a:pPr>
-            <a:r>
-              <a:t>PHYSICAL CONTROLS</a:t>
-            </a:r>
-          </a:p>
-          <a:p>
-            <a:br/>
-            <a:pPr>
-              <a:defRPr sz="1100">
-                <a:solidFill>
-                  <a:srgbClr val="E2E8F0"/>
-                </a:solidFill>
-                <a:latin typeface="Outfit"/>
-              </a:defRPr>
-            </a:pPr>
-            <a:r>
-              <a:t>Simple navigation controls using WASD or Arrow keys. Interactive popups and dialogue screens use keyboard overrides (Enter key) to ease motor requirements.</a:t>
-            </a:r>
-          </a:p>
-        </p:txBody>
-      </p:sp>
-      <p:sp>
-        <p:nvSpPr>
-          <p:cNvPr id="8" name="Rectangle 7"/>
-          <p:cNvSpPr/>
-          <p:nvPr/>
-        </p:nvSpPr>
-        <p:spPr>
-          <a:xfrm>
-            <a:off x="8915400" y="1920240"/>
-            <a:ext cx="2468880" cy="3931920"/>
-          </a:xfrm>
-          <a:prstGeom prst="rect">
-            <a:avLst/>
-          </a:prstGeom>
-          <a:solidFill>
-            <a:srgbClr val="1A202C"/>
-          </a:solidFill>
-          <a:ln w="19050">
-            <a:solidFill>
-              <a:srgbClr val="EF4444"/>
-            </a:solidFill>
-          </a:ln>
-        </p:spPr>
-        <p:style>
-          <a:lnRef idx="1">
-            <a:schemeClr val="accent1"/>
-          </a:lnRef>
-          <a:fillRef idx="3">
-            <a:schemeClr val="accent1"/>
-          </a:fillRef>
-          <a:effectRef idx="2">
-            <a:schemeClr val="accent1"/>
-          </a:effectRef>
-          <a:fontRef idx="minor">
-            <a:schemeClr val="lt1"/>
-          </a:fontRef>
-        </p:style>
-        <p:txBody>
-          <a:bodyPr rtlCol="0" anchor="ctr" lIns="228600" tIns="274320" wrap="square"/>
-          <a:lstStyle/>
-          <a:p>
-            <a:pPr algn="ctr">
-              <a:defRPr sz="1600" b="1">
-                <a:solidFill>
-                  <a:srgbClr val="EF4444"/>
-                </a:solidFill>
-                <a:latin typeface="Outfit"/>
-              </a:defRPr>
-            </a:pPr>
-            <a:r>
-              <a:t>HARDWARE BARRIERS</a:t>
-            </a:r>
-          </a:p>
-          <a:p>
-            <a:br/>
-            <a:pPr>
-              <a:defRPr sz="1100">
-                <a:solidFill>
-                  <a:srgbClr val="E2E8F0"/>
-                </a:solidFill>
-                <a:latin typeface="Outfit"/>
-              </a:defRPr>
-            </a:pPr>
-            <a:r>
-              <a:t>Zero installation model. Optimized to load under 1.5 seconds on low-bandwidth connections and execute smoothly on integrated graphics.</a:t>
+              <a:t>• Real-Time Firestore Leaderboard:</a:t>
+            </a:r>
+            <a:br/>
+            <a:r>
+              <a:t>  Saves scores anonymously, fostering healthy competition among team members or organizations.</a:t>
+            </a:r>
+            <a:br/>
+            <a:br/>
+            <a:r>
+              <a:t>• Immediate Correction Feedback:</a:t>
+            </a:r>
+            <a:br/>
+            <a:r>
+              <a:t>  Decisions display instant alerts explaining why an action was insecure, building memory loops.</a:t>
+            </a:r>
+            <a:br/>
+            <a:br/>
+            <a:r>
+              <a:t>• Frictionless Failing:</a:t>
+            </a:r>
+            <a:br/>
+            <a:r>
+              <a:t>  Low-stakes errors keep players engaged, avoiding the fatigue of standard cyber compliance training.</a:t>
             </a:r>
           </a:p>
         </p:txBody>

</xml_diff>

<commit_message>
Update PowerPoint file to contain exactly 6 slides matching official titles
</commit_message>
<xml_diff>
--- a/docs/cyberquest_presentation.pptx
+++ b/docs/cyberquest_presentation.pptx
@@ -11,10 +11,6 @@
     <p:sldId id="259" r:id="rId10"/>
     <p:sldId id="260" r:id="rId11"/>
     <p:sldId id="261" r:id="rId12"/>
-    <p:sldId id="262" r:id="rId13"/>
-    <p:sldId id="263" r:id="rId14"/>
-    <p:sldId id="264" r:id="rId15"/>
-    <p:sldId id="265" r:id="rId16"/>
   </p:sldIdLst>
   <p:sldSz cx="12191695" cy="6858000" type="screen4x3"/>
   <p:notesSz cx="6858000" cy="9144000"/>
@@ -3136,7 +3132,7 @@
               </a:defRPr>
             </a:pPr>
             <a:r>
-              <a:t>PROTOTYPE DEVELOPMENT:</a:t>
+              <a:t>PROTOTYPE DEVELOPED:</a:t>
             </a:r>
           </a:p>
           <a:p>
@@ -3237,7 +3233,7 @@
 </p:sld>
 </file>
 
-<file path=ppt/slides/slide10.xml><?xml version="1.0" encoding="utf-8"?>
+<file path=ppt/slides/slide2.xml><?xml version="1.0" encoding="utf-8"?>
 <p:sld xmlns:a="http://schemas.openxmlformats.org/drawingml/2006/main" xmlns:p="http://schemas.openxmlformats.org/presentationml/2006/main" xmlns:r="http://schemas.openxmlformats.org/officeDocument/2006/relationships">
   <p:cSld>
     <p:bg>
@@ -3286,7 +3282,7 @@
               </a:defRPr>
             </a:pPr>
             <a:r>
-              <a:t>DELIVERABLE OUTCOME</a:t>
+              <a:t>PROBLEM STATEMENT</a:t>
             </a:r>
           </a:p>
         </p:txBody>
@@ -3322,7 +3318,1237 @@
               </a:defRPr>
             </a:pPr>
             <a:r>
-              <a:t>Summary of Deployed Gameathon Solution</a:t>
+              <a:t>Social Engineering &amp; Threat Vectors</a:t>
+            </a:r>
+          </a:p>
+        </p:txBody>
+      </p:sp>
+      <p:sp>
+        <p:nvSpPr>
+          <p:cNvPr id="4" name="TextBox 3"/>
+          <p:cNvSpPr txBox="1"/>
+          <p:nvPr/>
+        </p:nvSpPr>
+        <p:spPr>
+          <a:xfrm>
+            <a:off x="685800" y="1645920"/>
+            <a:ext cx="5029200" cy="4114800"/>
+          </a:xfrm>
+          <a:prstGeom prst="rect">
+            <a:avLst/>
+          </a:prstGeom>
+          <a:noFill/>
+        </p:spPr>
+        <p:txBody>
+          <a:bodyPr wrap="square">
+            <a:spAutoFit/>
+          </a:bodyPr>
+          <a:lstStyle/>
+          <a:p>
+            <a:pPr>
+              <a:defRPr sz="1800" b="1">
+                <a:solidFill>
+                  <a:srgbClr val="EF4444"/>
+                </a:solidFill>
+                <a:latin typeface="Outfit"/>
+              </a:defRPr>
+            </a:pPr>
+            <a:r>
+              <a:t>THE AWARENESS GAP</a:t>
+            </a:r>
+          </a:p>
+          <a:p>
+            <a:br/>
+            <a:pPr>
+              <a:defRPr sz="1500">
+                <a:solidFill>
+                  <a:srgbClr val="E2E8F0"/>
+                </a:solidFill>
+                <a:latin typeface="Outfit"/>
+              </a:defRPr>
+            </a:pPr>
+            <a:r>
+              <a:t>Today, millions of users fall victim to social engineering and malicious attacks due to a critical lack of cybersecurity awareness.</a:t>
+            </a:r>
+            <a:br/>
+            <a:br/>
+            <a:r>
+              <a:t>Traditional methods like compliance PDFs or training videos are flat, passive, and fail to build split-second reflexes. Users learn facts for tests but cannot translate them into active safety measures when pressuring live threats manipulate their emotions.</a:t>
+            </a:r>
+          </a:p>
+        </p:txBody>
+      </p:sp>
+      <p:sp>
+        <p:nvSpPr>
+          <p:cNvPr id="5" name="Rectangle 4"/>
+          <p:cNvSpPr/>
+          <p:nvPr/>
+        </p:nvSpPr>
+        <p:spPr>
+          <a:xfrm>
+            <a:off x="6217920" y="1645920"/>
+            <a:ext cx="5303520" cy="4114800"/>
+          </a:xfrm>
+          <a:prstGeom prst="rect">
+            <a:avLst/>
+          </a:prstGeom>
+          <a:solidFill>
+            <a:srgbClr val="1A202C"/>
+          </a:solidFill>
+          <a:ln w="19050">
+            <a:solidFill>
+              <a:srgbClr val="EF4444"/>
+            </a:solidFill>
+          </a:ln>
+        </p:spPr>
+        <p:style>
+          <a:lnRef idx="1">
+            <a:schemeClr val="accent1"/>
+          </a:lnRef>
+          <a:fillRef idx="3">
+            <a:schemeClr val="accent1"/>
+          </a:fillRef>
+          <a:effectRef idx="2">
+            <a:schemeClr val="accent1"/>
+          </a:effectRef>
+          <a:fontRef idx="minor">
+            <a:schemeClr val="lt1"/>
+          </a:fontRef>
+        </p:style>
+        <p:txBody>
+          <a:bodyPr rtlCol="0" anchor="ctr" lIns="365760" rIns="365760" tIns="365760" wrap="square"/>
+          <a:lstStyle/>
+          <a:p>
+            <a:pPr algn="ctr">
+              <a:defRPr sz="1800" b="1">
+                <a:solidFill>
+                  <a:srgbClr val="D4AF37"/>
+                </a:solidFill>
+                <a:latin typeface="Outfit"/>
+              </a:defRPr>
+            </a:pPr>
+            <a:r>
+              <a:t>CRITICAL CHANNELS OF ATTACK</a:t>
+            </a:r>
+          </a:p>
+          <a:p>
+            <a:br/>
+            <a:pPr>
+              <a:defRPr sz="1300">
+                <a:solidFill>
+                  <a:srgbClr val="E2E8F0"/>
+                </a:solidFill>
+                <a:latin typeface="Outfit"/>
+              </a:defRPr>
+            </a:pPr>
+            <a:r>
+              <a:t>• Deceptive URLs &amp; Homographs:</a:t>
+            </a:r>
+            <a:br/>
+            <a:r>
+              <a:t>  Users overlook minor character anomalies (e.g. Cyrillic lookalikes) leading to login credential leaks.</a:t>
+            </a:r>
+            <a:br/>
+            <a:br/>
+            <a:r>
+              <a:t>• High-Pressure Vishing Calls:</a:t>
+            </a:r>
+            <a:br/>
+            <a:r>
+              <a:t>  Deceptive caller profiles exploit urgency (e.g., fake banking fraud alerts) to extract OTPs or recovery codes.</a:t>
+            </a:r>
+            <a:br/>
+            <a:br/>
+            <a:r>
+              <a:t>• Unverified updates &amp; downloads:</a:t>
+            </a:r>
+            <a:br/>
+            <a:r>
+              <a:t>  Malicious browser popups manipulate users into executing unverified malware scripts.</a:t>
+            </a:r>
+          </a:p>
+        </p:txBody>
+      </p:sp>
+    </p:spTree>
+  </p:cSld>
+  <p:clrMapOvr>
+    <a:masterClrMapping/>
+  </p:clrMapOvr>
+</p:sld>
+</file>
+
+<file path=ppt/slides/slide3.xml><?xml version="1.0" encoding="utf-8"?>
+<p:sld xmlns:a="http://schemas.openxmlformats.org/drawingml/2006/main" xmlns:p="http://schemas.openxmlformats.org/presentationml/2006/main" xmlns:r="http://schemas.openxmlformats.org/officeDocument/2006/relationships">
+  <p:cSld>
+    <p:bg>
+      <p:bgPr>
+        <a:solidFill>
+          <a:srgbClr val="0B0E14"/>
+        </a:solidFill>
+        <a:effectLst/>
+      </p:bgPr>
+    </p:bg>
+    <p:spTree>
+      <p:nvGrpSpPr>
+        <p:cNvPr id="1" name=""/>
+        <p:cNvGrpSpPr/>
+        <p:nvPr/>
+      </p:nvGrpSpPr>
+      <p:grpSpPr/>
+      <p:sp>
+        <p:nvSpPr>
+          <p:cNvPr id="2" name="TextBox 1"/>
+          <p:cNvSpPr txBox="1"/>
+          <p:nvPr/>
+        </p:nvSpPr>
+        <p:spPr>
+          <a:xfrm>
+            <a:off x="685800" y="365760"/>
+            <a:ext cx="10817352" cy="274320"/>
+          </a:xfrm>
+          <a:prstGeom prst="rect">
+            <a:avLst/>
+          </a:prstGeom>
+          <a:noFill/>
+        </p:spPr>
+        <p:txBody>
+          <a:bodyPr wrap="square">
+            <a:spAutoFit/>
+          </a:bodyPr>
+          <a:lstStyle/>
+          <a:p>
+            <a:pPr>
+              <a:defRPr sz="1000" b="1">
+                <a:solidFill>
+                  <a:srgbClr val="38BDF8"/>
+                </a:solidFill>
+                <a:latin typeface="Outfit"/>
+              </a:defRPr>
+            </a:pPr>
+            <a:r>
+              <a:t>OBJECTIVE AND ABSTRACT</a:t>
+            </a:r>
+          </a:p>
+        </p:txBody>
+      </p:sp>
+      <p:sp>
+        <p:nvSpPr>
+          <p:cNvPr id="3" name="TextBox 2"/>
+          <p:cNvSpPr txBox="1"/>
+          <p:nvPr/>
+        </p:nvSpPr>
+        <p:spPr>
+          <a:xfrm>
+            <a:off x="685800" y="594360"/>
+            <a:ext cx="10817352" cy="731520"/>
+          </a:xfrm>
+          <a:prstGeom prst="rect">
+            <a:avLst/>
+          </a:prstGeom>
+          <a:noFill/>
+        </p:spPr>
+        <p:txBody>
+          <a:bodyPr wrap="square">
+            <a:spAutoFit/>
+          </a:bodyPr>
+          <a:lstStyle/>
+          <a:p>
+            <a:pPr>
+              <a:defRPr sz="3000" b="1">
+                <a:solidFill>
+                  <a:srgbClr val="D4AF37"/>
+                </a:solidFill>
+                <a:latin typeface="Cinzel"/>
+              </a:defRPr>
+            </a:pPr>
+            <a:r>
+              <a:t>Active Cybersecurity Sandbox Objective</a:t>
+            </a:r>
+          </a:p>
+        </p:txBody>
+      </p:sp>
+      <p:sp>
+        <p:nvSpPr>
+          <p:cNvPr id="4" name="Rectangle 3"/>
+          <p:cNvSpPr/>
+          <p:nvPr/>
+        </p:nvSpPr>
+        <p:spPr>
+          <a:xfrm>
+            <a:off x="685800" y="1645920"/>
+            <a:ext cx="5120640" cy="4114800"/>
+          </a:xfrm>
+          <a:prstGeom prst="rect">
+            <a:avLst/>
+          </a:prstGeom>
+          <a:solidFill>
+            <a:srgbClr val="1A202C"/>
+          </a:solidFill>
+          <a:ln w="19050">
+            <a:solidFill>
+              <a:srgbClr val="38BDF8"/>
+            </a:solidFill>
+          </a:ln>
+        </p:spPr>
+        <p:style>
+          <a:lnRef idx="1">
+            <a:schemeClr val="accent1"/>
+          </a:lnRef>
+          <a:fillRef idx="3">
+            <a:schemeClr val="accent1"/>
+          </a:fillRef>
+          <a:effectRef idx="2">
+            <a:schemeClr val="accent1"/>
+          </a:effectRef>
+          <a:fontRef idx="minor">
+            <a:schemeClr val="lt1"/>
+          </a:fontRef>
+        </p:style>
+        <p:txBody>
+          <a:bodyPr rtlCol="0" anchor="ctr" lIns="365760" tIns="365760" wrap="square"/>
+          <a:lstStyle/>
+          <a:p>
+            <a:pPr algn="ctr">
+              <a:defRPr sz="1800" b="1">
+                <a:solidFill>
+                  <a:srgbClr val="38BDF8"/>
+                </a:solidFill>
+                <a:latin typeface="Outfit"/>
+              </a:defRPr>
+            </a:pPr>
+            <a:r>
+              <a:t>OBJECTIVE ABSTRACT</a:t>
+            </a:r>
+          </a:p>
+          <a:p>
+            <a:br/>
+            <a:pPr>
+              <a:defRPr sz="1400">
+                <a:solidFill>
+                  <a:srgbClr val="E2E8F0"/>
+                </a:solidFill>
+                <a:latin typeface="Outfit"/>
+              </a:defRPr>
+            </a:pPr>
+            <a:r>
+              <a:t>Our objective is to build a lightweight web-based training platform that translates security principles into live, actionable decision choices.</a:t>
+            </a:r>
+            <a:br/>
+            <a:br/>
+            <a:r>
+              <a:t>CyberQuest RPG places users inside an interactive 3D labyrinth. By encountering simulated threats, users learn threat spotting, experience bad decisions in a low-risk failure sandbox, and configure defensive countermeasures to protect confidential information.</a:t>
+            </a:r>
+          </a:p>
+        </p:txBody>
+      </p:sp>
+      <p:sp>
+        <p:nvSpPr>
+          <p:cNvPr id="5" name="Rectangle 4"/>
+          <p:cNvSpPr/>
+          <p:nvPr/>
+        </p:nvSpPr>
+        <p:spPr>
+          <a:xfrm>
+            <a:off x="6355080" y="1645920"/>
+            <a:ext cx="5150815" cy="4114800"/>
+          </a:xfrm>
+          <a:prstGeom prst="rect">
+            <a:avLst/>
+          </a:prstGeom>
+          <a:solidFill>
+            <a:srgbClr val="1A202C"/>
+          </a:solidFill>
+          <a:ln w="19050">
+            <a:solidFill>
+              <a:srgbClr val="D4AF37"/>
+            </a:solidFill>
+          </a:ln>
+        </p:spPr>
+        <p:style>
+          <a:lnRef idx="1">
+            <a:schemeClr val="accent1"/>
+          </a:lnRef>
+          <a:fillRef idx="3">
+            <a:schemeClr val="accent1"/>
+          </a:fillRef>
+          <a:effectRef idx="2">
+            <a:schemeClr val="accent1"/>
+          </a:effectRef>
+          <a:fontRef idx="minor">
+            <a:schemeClr val="lt1"/>
+          </a:fontRef>
+        </p:style>
+        <p:txBody>
+          <a:bodyPr rtlCol="0" anchor="ctr" lIns="365760" tIns="365760" wrap="square"/>
+          <a:lstStyle/>
+          <a:p>
+            <a:pPr algn="ctr">
+              <a:defRPr sz="1800" b="1">
+                <a:solidFill>
+                  <a:srgbClr val="D4AF37"/>
+                </a:solidFill>
+                <a:latin typeface="Outfit"/>
+              </a:defRPr>
+            </a:pPr>
+            <a:r>
+              <a:t>CORE STRATEGY PILLARS</a:t>
+            </a:r>
+          </a:p>
+          <a:p>
+            <a:br/>
+            <a:pPr>
+              <a:defRPr sz="1300">
+                <a:solidFill>
+                  <a:srgbClr val="E2E8F0"/>
+                </a:solidFill>
+                <a:latin typeface="Outfit"/>
+              </a:defRPr>
+            </a:pPr>
+            <a:r>
+              <a:t>• Recognize:</a:t>
+            </a:r>
+            <a:br/>
+            <a:r>
+              <a:t>  Train players to identify phishing domains, voice scam call indicators, and malicious browser updates.</a:t>
+            </a:r>
+            <a:br/>
+            <a:br/>
+            <a:r>
+              <a:t>• Practice:</a:t>
+            </a:r>
+            <a:br/>
+            <a:r>
+              <a:t>  Gamified scenarios that adapt directly to user reactions (lowering HP for errors, rewarding coins for safety).</a:t>
+            </a:r>
+            <a:br/>
+            <a:br/>
+            <a:r>
+              <a:t>• Protect:</a:t>
+            </a:r>
+            <a:br/>
+            <a:r>
+              <a:t>  Provide immediate actionable guidelines on verifying caller identities, protecting credentials, and configuring MFA.</a:t>
+            </a:r>
+          </a:p>
+        </p:txBody>
+      </p:sp>
+    </p:spTree>
+  </p:cSld>
+  <p:clrMapOvr>
+    <a:masterClrMapping/>
+  </p:clrMapOvr>
+</p:sld>
+</file>
+
+<file path=ppt/slides/slide4.xml><?xml version="1.0" encoding="utf-8"?>
+<p:sld xmlns:a="http://schemas.openxmlformats.org/drawingml/2006/main" xmlns:p="http://schemas.openxmlformats.org/presentationml/2006/main" xmlns:r="http://schemas.openxmlformats.org/officeDocument/2006/relationships">
+  <p:cSld>
+    <p:bg>
+      <p:bgPr>
+        <a:solidFill>
+          <a:srgbClr val="0B0E14"/>
+        </a:solidFill>
+        <a:effectLst/>
+      </p:bgPr>
+    </p:bg>
+    <p:spTree>
+      <p:nvGrpSpPr>
+        <p:cNvPr id="1" name=""/>
+        <p:cNvGrpSpPr/>
+        <p:nvPr/>
+      </p:nvGrpSpPr>
+      <p:grpSpPr/>
+      <p:sp>
+        <p:nvSpPr>
+          <p:cNvPr id="2" name="TextBox 1"/>
+          <p:cNvSpPr txBox="1"/>
+          <p:nvPr/>
+        </p:nvSpPr>
+        <p:spPr>
+          <a:xfrm>
+            <a:off x="685800" y="365760"/>
+            <a:ext cx="10817352" cy="274320"/>
+          </a:xfrm>
+          <a:prstGeom prst="rect">
+            <a:avLst/>
+          </a:prstGeom>
+          <a:noFill/>
+        </p:spPr>
+        <p:txBody>
+          <a:bodyPr wrap="square">
+            <a:spAutoFit/>
+          </a:bodyPr>
+          <a:lstStyle/>
+          <a:p>
+            <a:pPr>
+              <a:defRPr sz="1000" b="1">
+                <a:solidFill>
+                  <a:srgbClr val="38BDF8"/>
+                </a:solidFill>
+                <a:latin typeface="Outfit"/>
+              </a:defRPr>
+            </a:pPr>
+            <a:r>
+              <a:t>TECHNOLOGY AND TOOLS USED</a:t>
+            </a:r>
+          </a:p>
+        </p:txBody>
+      </p:sp>
+      <p:sp>
+        <p:nvSpPr>
+          <p:cNvPr id="3" name="TextBox 2"/>
+          <p:cNvSpPr txBox="1"/>
+          <p:nvPr/>
+        </p:nvSpPr>
+        <p:spPr>
+          <a:xfrm>
+            <a:off x="685800" y="594360"/>
+            <a:ext cx="10817352" cy="731520"/>
+          </a:xfrm>
+          <a:prstGeom prst="rect">
+            <a:avLst/>
+          </a:prstGeom>
+          <a:noFill/>
+        </p:spPr>
+        <p:txBody>
+          <a:bodyPr wrap="square">
+            <a:spAutoFit/>
+          </a:bodyPr>
+          <a:lstStyle/>
+          <a:p>
+            <a:pPr>
+              <a:defRPr sz="3000" b="1">
+                <a:solidFill>
+                  <a:srgbClr val="D4AF37"/>
+                </a:solidFill>
+                <a:latin typeface="Cinzel"/>
+              </a:defRPr>
+            </a:pPr>
+            <a:r>
+              <a:t>System Tech Stack &amp; Accessibility Framework</a:t>
+            </a:r>
+          </a:p>
+        </p:txBody>
+      </p:sp>
+      <p:sp>
+        <p:nvSpPr>
+          <p:cNvPr id="4" name="Rectangle 3"/>
+          <p:cNvSpPr/>
+          <p:nvPr/>
+        </p:nvSpPr>
+        <p:spPr>
+          <a:xfrm>
+            <a:off x="685800" y="1645920"/>
+            <a:ext cx="3383280" cy="4114800"/>
+          </a:xfrm>
+          <a:prstGeom prst="rect">
+            <a:avLst/>
+          </a:prstGeom>
+          <a:solidFill>
+            <a:srgbClr val="1A202C"/>
+          </a:solidFill>
+          <a:ln w="19050">
+            <a:solidFill>
+              <a:srgbClr val="38BDF8"/>
+            </a:solidFill>
+          </a:ln>
+        </p:spPr>
+        <p:style>
+          <a:lnRef idx="1">
+            <a:schemeClr val="accent1"/>
+          </a:lnRef>
+          <a:fillRef idx="3">
+            <a:schemeClr val="accent1"/>
+          </a:fillRef>
+          <a:effectRef idx="2">
+            <a:schemeClr val="accent1"/>
+          </a:effectRef>
+          <a:fontRef idx="minor">
+            <a:schemeClr val="lt1"/>
+          </a:fontRef>
+        </p:style>
+        <p:txBody>
+          <a:bodyPr rtlCol="0" anchor="ctr" lIns="274320" tIns="274320" wrap="square"/>
+          <a:lstStyle/>
+          <a:p>
+            <a:pPr algn="ctr">
+              <a:defRPr sz="1600" b="1">
+                <a:solidFill>
+                  <a:srgbClr val="38BDF8"/>
+                </a:solidFill>
+                <a:latin typeface="Outfit"/>
+              </a:defRPr>
+            </a:pPr>
+            <a:r>
+              <a:t>FRONTEND CORE</a:t>
+            </a:r>
+          </a:p>
+          <a:p>
+            <a:br/>
+            <a:pPr>
+              <a:defRPr sz="1200">
+                <a:solidFill>
+                  <a:srgbClr val="E2E8F0"/>
+                </a:solidFill>
+                <a:latin typeface="Outfit"/>
+              </a:defRPr>
+            </a:pPr>
+            <a:r>
+              <a:t>• Vanilla Web Core:</a:t>
+            </a:r>
+            <a:br/>
+            <a:r>
+              <a:t>  HTML5, CSS3, and JavaScript deliver rapid execution without client overhead.</a:t>
+            </a:r>
+            <a:br/>
+            <a:br/>
+            <a:r>
+              <a:t>• WebGL Graphics Engine:</a:t>
+            </a:r>
+            <a:br/>
+            <a:r>
+              <a:t>  Three.js (r128) creates a first-person 3D labyrinth, running smoothly on integrated graphics without setup or installations.</a:t>
+            </a:r>
+          </a:p>
+        </p:txBody>
+      </p:sp>
+      <p:sp>
+        <p:nvSpPr>
+          <p:cNvPr id="5" name="Rectangle 4"/>
+          <p:cNvSpPr/>
+          <p:nvPr/>
+        </p:nvSpPr>
+        <p:spPr>
+          <a:xfrm>
+            <a:off x="4434840" y="1645920"/>
+            <a:ext cx="3383280" cy="4114800"/>
+          </a:xfrm>
+          <a:prstGeom prst="rect">
+            <a:avLst/>
+          </a:prstGeom>
+          <a:solidFill>
+            <a:srgbClr val="1A202C"/>
+          </a:solidFill>
+          <a:ln w="19050">
+            <a:solidFill>
+              <a:srgbClr val="D4AF37"/>
+            </a:solidFill>
+          </a:ln>
+        </p:spPr>
+        <p:style>
+          <a:lnRef idx="1">
+            <a:schemeClr val="accent1"/>
+          </a:lnRef>
+          <a:fillRef idx="3">
+            <a:schemeClr val="accent1"/>
+          </a:fillRef>
+          <a:effectRef idx="2">
+            <a:schemeClr val="accent1"/>
+          </a:effectRef>
+          <a:fontRef idx="minor">
+            <a:schemeClr val="lt1"/>
+          </a:fontRef>
+        </p:style>
+        <p:txBody>
+          <a:bodyPr rtlCol="0" anchor="ctr" lIns="274320" tIns="274320" wrap="square"/>
+          <a:lstStyle/>
+          <a:p>
+            <a:pPr algn="ctr">
+              <a:defRPr sz="1600" b="1">
+                <a:solidFill>
+                  <a:srgbClr val="D4AF37"/>
+                </a:solidFill>
+                <a:latin typeface="Outfit"/>
+              </a:defRPr>
+            </a:pPr>
+            <a:r>
+              <a:t>CLOUD INFRASTRUCTURE</a:t>
+            </a:r>
+          </a:p>
+          <a:p>
+            <a:br/>
+            <a:pPr>
+              <a:defRPr sz="1200">
+                <a:solidFill>
+                  <a:srgbClr val="E2E8F0"/>
+                </a:solidFill>
+                <a:latin typeface="Outfit"/>
+              </a:defRPr>
+            </a:pPr>
+            <a:r>
+              <a:t>• Firebase Hosting:</a:t>
+            </a:r>
+            <a:br/>
+            <a:r>
+              <a:t>  Deployed on a global CDN ensuring sub-second access.</a:t>
+            </a:r>
+            <a:br/>
+            <a:br/>
+            <a:r>
+              <a:t>• Real-Time Firestore:</a:t>
+            </a:r>
+            <a:br/>
+            <a:r>
+              <a:t>  Tracks leaderboard details and statistics.</a:t>
+            </a:r>
+            <a:br/>
+            <a:br/>
+            <a:r>
+              <a:t>• Anonymous Authentication:</a:t>
+            </a:r>
+            <a:br/>
+            <a:r>
+              <a:t>  Generates pseudonyms (Guardian #1731) to respect user privacy.</a:t>
+            </a:r>
+          </a:p>
+        </p:txBody>
+      </p:sp>
+      <p:sp>
+        <p:nvSpPr>
+          <p:cNvPr id="6" name="Rectangle 5"/>
+          <p:cNvSpPr/>
+          <p:nvPr/>
+        </p:nvSpPr>
+        <p:spPr>
+          <a:xfrm>
+            <a:off x="8183880" y="1645920"/>
+            <a:ext cx="3383280" cy="4114800"/>
+          </a:xfrm>
+          <a:prstGeom prst="rect">
+            <a:avLst/>
+          </a:prstGeom>
+          <a:solidFill>
+            <a:srgbClr val="1A202C"/>
+          </a:solidFill>
+          <a:ln w="19050">
+            <a:solidFill>
+              <a:srgbClr val="00FF66"/>
+            </a:solidFill>
+          </a:ln>
+        </p:spPr>
+        <p:style>
+          <a:lnRef idx="1">
+            <a:schemeClr val="accent1"/>
+          </a:lnRef>
+          <a:fillRef idx="3">
+            <a:schemeClr val="accent1"/>
+          </a:fillRef>
+          <a:effectRef idx="2">
+            <a:schemeClr val="accent1"/>
+          </a:effectRef>
+          <a:fontRef idx="minor">
+            <a:schemeClr val="lt1"/>
+          </a:fontRef>
+        </p:style>
+        <p:txBody>
+          <a:bodyPr rtlCol="0" anchor="ctr" lIns="274320" tIns="274320" wrap="square"/>
+          <a:lstStyle/>
+          <a:p>
+            <a:pPr algn="ctr">
+              <a:defRPr sz="1600" b="1">
+                <a:solidFill>
+                  <a:srgbClr val="00FF66"/>
+                </a:solidFill>
+                <a:latin typeface="Outfit"/>
+              </a:defRPr>
+            </a:pPr>
+            <a:r>
+              <a:t>SECURE AI &amp; INCLUSIVITY</a:t>
+            </a:r>
+          </a:p>
+          <a:p>
+            <a:br/>
+            <a:pPr>
+              <a:defRPr sz="1200">
+                <a:solidFill>
+                  <a:srgbClr val="E2E8F0"/>
+                </a:solidFill>
+                <a:latin typeface="Outfit"/>
+              </a:defRPr>
+            </a:pPr>
+            <a:r>
+              <a:t>• Serverless Cloud Functions:</a:t>
+            </a:r>
+            <a:br/>
+            <a:r>
+              <a:t>  Proxies API keys (Groq Chat Completion LLM) server-side, protecting tokens.</a:t>
+            </a:r>
+            <a:br/>
+            <a:br/>
+            <a:r>
+              <a:t>• Accessibility Adaptations:</a:t>
+            </a:r>
+            <a:br/>
+            <a:r>
+              <a:t>  Keyboard WASD/Arrow navigation, visual transcripts/subtitles for vishing audio calls, and zoom-friendly scales.</a:t>
+            </a:r>
+          </a:p>
+        </p:txBody>
+      </p:sp>
+    </p:spTree>
+  </p:cSld>
+  <p:clrMapOvr>
+    <a:masterClrMapping/>
+  </p:clrMapOvr>
+</p:sld>
+</file>
+
+<file path=ppt/slides/slide5.xml><?xml version="1.0" encoding="utf-8"?>
+<p:sld xmlns:a="http://schemas.openxmlformats.org/drawingml/2006/main" xmlns:p="http://schemas.openxmlformats.org/presentationml/2006/main" xmlns:r="http://schemas.openxmlformats.org/officeDocument/2006/relationships">
+  <p:cSld>
+    <p:bg>
+      <p:bgPr>
+        <a:solidFill>
+          <a:srgbClr val="0B0E14"/>
+        </a:solidFill>
+        <a:effectLst/>
+      </p:bgPr>
+    </p:bg>
+    <p:spTree>
+      <p:nvGrpSpPr>
+        <p:cNvPr id="1" name=""/>
+        <p:cNvGrpSpPr/>
+        <p:nvPr/>
+      </p:nvGrpSpPr>
+      <p:grpSpPr/>
+      <p:sp>
+        <p:nvSpPr>
+          <p:cNvPr id="2" name="TextBox 1"/>
+          <p:cNvSpPr txBox="1"/>
+          <p:nvPr/>
+        </p:nvSpPr>
+        <p:spPr>
+          <a:xfrm>
+            <a:off x="685800" y="365760"/>
+            <a:ext cx="10817352" cy="274320"/>
+          </a:xfrm>
+          <a:prstGeom prst="rect">
+            <a:avLst/>
+          </a:prstGeom>
+          <a:noFill/>
+        </p:spPr>
+        <p:txBody>
+          <a:bodyPr wrap="square">
+            <a:spAutoFit/>
+          </a:bodyPr>
+          <a:lstStyle/>
+          <a:p>
+            <a:pPr>
+              <a:defRPr sz="1000" b="1">
+                <a:solidFill>
+                  <a:srgbClr val="38BDF8"/>
+                </a:solidFill>
+                <a:latin typeface="Outfit"/>
+              </a:defRPr>
+            </a:pPr>
+            <a:r>
+              <a:t>DELIVERABLE OUTCOME</a:t>
+            </a:r>
+          </a:p>
+        </p:txBody>
+      </p:sp>
+      <p:sp>
+        <p:nvSpPr>
+          <p:cNvPr id="3" name="TextBox 2"/>
+          <p:cNvSpPr txBox="1"/>
+          <p:nvPr/>
+        </p:nvSpPr>
+        <p:spPr>
+          <a:xfrm>
+            <a:off x="685800" y="594360"/>
+            <a:ext cx="10817352" cy="731520"/>
+          </a:xfrm>
+          <a:prstGeom prst="rect">
+            <a:avLst/>
+          </a:prstGeom>
+          <a:noFill/>
+        </p:spPr>
+        <p:txBody>
+          <a:bodyPr wrap="square">
+            <a:spAutoFit/>
+          </a:bodyPr>
+          <a:lstStyle/>
+          <a:p>
+            <a:pPr>
+              <a:defRPr sz="3000" b="1">
+                <a:solidFill>
+                  <a:srgbClr val="D4AF37"/>
+                </a:solidFill>
+                <a:latin typeface="Cinzel"/>
+              </a:defRPr>
+            </a:pPr>
+            <a:r>
+              <a:t>Deliverable Outcome: Simulated Threat Scenarios</a:t>
+            </a:r>
+          </a:p>
+        </p:txBody>
+      </p:sp>
+      <p:sp>
+        <p:nvSpPr>
+          <p:cNvPr id="4" name="Rectangle 3"/>
+          <p:cNvSpPr/>
+          <p:nvPr/>
+        </p:nvSpPr>
+        <p:spPr>
+          <a:xfrm>
+            <a:off x="685800" y="1645920"/>
+            <a:ext cx="5120640" cy="1920240"/>
+          </a:xfrm>
+          <a:prstGeom prst="rect">
+            <a:avLst/>
+          </a:prstGeom>
+          <a:solidFill>
+            <a:srgbClr val="1A202C"/>
+          </a:solidFill>
+          <a:ln w="19050">
+            <a:solidFill>
+              <a:srgbClr val="D4AF37"/>
+            </a:solidFill>
+          </a:ln>
+        </p:spPr>
+        <p:style>
+          <a:lnRef idx="1">
+            <a:schemeClr val="accent1"/>
+          </a:lnRef>
+          <a:fillRef idx="3">
+            <a:schemeClr val="accent1"/>
+          </a:fillRef>
+          <a:effectRef idx="2">
+            <a:schemeClr val="accent1"/>
+          </a:effectRef>
+          <a:fontRef idx="minor">
+            <a:schemeClr val="lt1"/>
+          </a:fontRef>
+        </p:style>
+        <p:txBody>
+          <a:bodyPr rtlCol="0" anchor="ctr" lIns="182880" rIns="182880" tIns="127000" wrap="square"/>
+          <a:lstStyle/>
+          <a:p>
+            <a:pPr algn="ctr">
+              <a:defRPr sz="1500" b="1">
+                <a:solidFill>
+                  <a:srgbClr val="D4AF37"/>
+                </a:solidFill>
+                <a:latin typeface="Outfit"/>
+              </a:defRPr>
+            </a:pPr>
+            <a:r>
+              <a:t>01 | PHISHING LINKS (HOMOGRAPH DETECTION)</a:t>
+            </a:r>
+          </a:p>
+          <a:p>
+            <a:pPr>
+              <a:defRPr sz="1200">
+                <a:solidFill>
+                  <a:srgbClr val="E2E8F0"/>
+                </a:solidFill>
+                <a:latin typeface="Outfit"/>
+              </a:defRPr>
+            </a:pPr>
+            <a:r>
+              <a:t>Inspectable simulated alerts. Hovering over verify buttons reveals destination links, displaying homograph targets (e.g. Cyrillic lookalike letters in arcadıakyc-login.org).</a:t>
+            </a:r>
+          </a:p>
+        </p:txBody>
+      </p:sp>
+      <p:sp>
+        <p:nvSpPr>
+          <p:cNvPr id="5" name="Rectangle 4"/>
+          <p:cNvSpPr/>
+          <p:nvPr/>
+        </p:nvSpPr>
+        <p:spPr>
+          <a:xfrm>
+            <a:off x="6385255" y="1645920"/>
+            <a:ext cx="5120640" cy="1920240"/>
+          </a:xfrm>
+          <a:prstGeom prst="rect">
+            <a:avLst/>
+          </a:prstGeom>
+          <a:solidFill>
+            <a:srgbClr val="1A202C"/>
+          </a:solidFill>
+          <a:ln w="19050">
+            <a:solidFill>
+              <a:srgbClr val="38BDF8"/>
+            </a:solidFill>
+          </a:ln>
+        </p:spPr>
+        <p:style>
+          <a:lnRef idx="1">
+            <a:schemeClr val="accent1"/>
+          </a:lnRef>
+          <a:fillRef idx="3">
+            <a:schemeClr val="accent1"/>
+          </a:fillRef>
+          <a:effectRef idx="2">
+            <a:schemeClr val="accent1"/>
+          </a:effectRef>
+          <a:fontRef idx="minor">
+            <a:schemeClr val="lt1"/>
+          </a:fontRef>
+        </p:style>
+        <p:txBody>
+          <a:bodyPr rtlCol="0" anchor="ctr" lIns="182880" rIns="182880" tIns="127000" wrap="square"/>
+          <a:lstStyle/>
+          <a:p>
+            <a:pPr algn="ctr">
+              <a:defRPr sz="1500" b="1">
+                <a:solidFill>
+                  <a:srgbClr val="38BDF8"/>
+                </a:solidFill>
+                <a:latin typeface="Outfit"/>
+              </a:defRPr>
+            </a:pPr>
+            <a:r>
+              <a:t>02 | SOCIAL ENGINEERING VISHING CALLS</a:t>
+            </a:r>
+          </a:p>
+          <a:p>
+            <a:pPr>
+              <a:defRPr sz="1200">
+                <a:solidFill>
+                  <a:srgbClr val="E2E8F0"/>
+                </a:solidFill>
+                <a:latin typeface="Outfit"/>
+              </a:defRPr>
+            </a:pPr>
+            <a:r>
+              <a:t>Simulated Fraud Team telephone interactions. Evaluates user pressure limits, training them to hang up and verify rather than sharing confidential PINs/codes.</a:t>
+            </a:r>
+          </a:p>
+        </p:txBody>
+      </p:sp>
+      <p:sp>
+        <p:nvSpPr>
+          <p:cNvPr id="6" name="Rectangle 5"/>
+          <p:cNvSpPr/>
+          <p:nvPr/>
+        </p:nvSpPr>
+        <p:spPr>
+          <a:xfrm>
+            <a:off x="685800" y="3840480"/>
+            <a:ext cx="5120640" cy="1920240"/>
+          </a:xfrm>
+          <a:prstGeom prst="rect">
+            <a:avLst/>
+          </a:prstGeom>
+          <a:solidFill>
+            <a:srgbClr val="1A202C"/>
+          </a:solidFill>
+          <a:ln w="19050">
+            <a:solidFill>
+              <a:srgbClr val="EF4444"/>
+            </a:solidFill>
+          </a:ln>
+        </p:spPr>
+        <p:style>
+          <a:lnRef idx="1">
+            <a:schemeClr val="accent1"/>
+          </a:lnRef>
+          <a:fillRef idx="3">
+            <a:schemeClr val="accent1"/>
+          </a:fillRef>
+          <a:effectRef idx="2">
+            <a:schemeClr val="accent1"/>
+          </a:effectRef>
+          <a:fontRef idx="minor">
+            <a:schemeClr val="lt1"/>
+          </a:fontRef>
+        </p:style>
+        <p:txBody>
+          <a:bodyPr rtlCol="0" anchor="ctr" lIns="182880" rIns="182880" tIns="127000" wrap="square"/>
+          <a:lstStyle/>
+          <a:p>
+            <a:pPr algn="ctr">
+              <a:defRPr sz="1500" b="1">
+                <a:solidFill>
+                  <a:srgbClr val="EF4444"/>
+                </a:solidFill>
+                <a:latin typeface="Outfit"/>
+              </a:defRPr>
+            </a:pPr>
+            <a:r>
+              <a:t>03 | MALWARE UPDATES &amp; AI GUIDE</a:t>
+            </a:r>
+          </a:p>
+          <a:p>
+            <a:pPr>
+              <a:defRPr sz="1200">
+                <a:solidFill>
+                  <a:srgbClr val="E2E8F0"/>
+                </a:solidFill>
+                <a:latin typeface="Outfit"/>
+              </a:defRPr>
+            </a:pPr>
+            <a:r>
+              <a:t>Browser notification update simulation traps. Features an in-game conversational AI mentor ('Greymantle') powered by Firestore log histories and secure Groq APIs.</a:t>
+            </a:r>
+          </a:p>
+        </p:txBody>
+      </p:sp>
+      <p:sp>
+        <p:nvSpPr>
+          <p:cNvPr id="7" name="Rectangle 6"/>
+          <p:cNvSpPr/>
+          <p:nvPr/>
+        </p:nvSpPr>
+        <p:spPr>
+          <a:xfrm>
+            <a:off x="6385255" y="3840480"/>
+            <a:ext cx="5120640" cy="1920240"/>
+          </a:xfrm>
+          <a:prstGeom prst="rect">
+            <a:avLst/>
+          </a:prstGeom>
+          <a:solidFill>
+            <a:srgbClr val="1A202C"/>
+          </a:solidFill>
+          <a:ln w="19050">
+            <a:solidFill>
+              <a:srgbClr val="00FF66"/>
+            </a:solidFill>
+          </a:ln>
+        </p:spPr>
+        <p:style>
+          <a:lnRef idx="1">
+            <a:schemeClr val="accent1"/>
+          </a:lnRef>
+          <a:fillRef idx="3">
+            <a:schemeClr val="accent1"/>
+          </a:fillRef>
+          <a:effectRef idx="2">
+            <a:schemeClr val="accent1"/>
+          </a:effectRef>
+          <a:fontRef idx="minor">
+            <a:schemeClr val="lt1"/>
+          </a:fontRef>
+        </p:style>
+        <p:txBody>
+          <a:bodyPr rtlCol="0" anchor="ctr" lIns="182880" rIns="182880" tIns="127000" wrap="square"/>
+          <a:lstStyle/>
+          <a:p>
+            <a:pPr algn="ctr">
+              <a:defRPr sz="1500" b="1">
+                <a:solidFill>
+                  <a:srgbClr val="00FF66"/>
+                </a:solidFill>
+                <a:latin typeface="Outfit"/>
+              </a:defRPr>
+            </a:pPr>
+            <a:r>
+              <a:t>04 | VOID COLLECTIVE SECURITY MCQ GATES</a:t>
+            </a:r>
+          </a:p>
+          <a:p>
+            <a:pPr>
+              <a:defRPr sz="1200">
+                <a:solidFill>
+                  <a:srgbClr val="E2E8F0"/>
+                </a:solidFill>
+                <a:latin typeface="Outfit"/>
+              </a:defRPr>
+            </a:pPr>
+            <a:r>
+              <a:t>Portals requiring sequential MCQ answers (1 at a time, parallel choices). Players must score at least 2/3 correct to pass checkpoints and collect access keys.</a:t>
+            </a:r>
+          </a:p>
+        </p:txBody>
+      </p:sp>
+    </p:spTree>
+  </p:cSld>
+  <p:clrMapOvr>
+    <a:masterClrMapping/>
+  </p:clrMapOvr>
+</p:sld>
+</file>
+
+<file path=ppt/slides/slide6.xml><?xml version="1.0" encoding="utf-8"?>
+<p:sld xmlns:a="http://schemas.openxmlformats.org/drawingml/2006/main" xmlns:p="http://schemas.openxmlformats.org/presentationml/2006/main" xmlns:r="http://schemas.openxmlformats.org/officeDocument/2006/relationships">
+  <p:cSld>
+    <p:bg>
+      <p:bgPr>
+        <a:solidFill>
+          <a:srgbClr val="0B0E14"/>
+        </a:solidFill>
+        <a:effectLst/>
+      </p:bgPr>
+    </p:bg>
+    <p:spTree>
+      <p:nvGrpSpPr>
+        <p:cNvPr id="1" name=""/>
+        <p:cNvGrpSpPr/>
+        <p:nvPr/>
+      </p:nvGrpSpPr>
+      <p:grpSpPr/>
+      <p:sp>
+        <p:nvSpPr>
+          <p:cNvPr id="2" name="TextBox 1"/>
+          <p:cNvSpPr txBox="1"/>
+          <p:nvPr/>
+        </p:nvSpPr>
+        <p:spPr>
+          <a:xfrm>
+            <a:off x="685800" y="365760"/>
+            <a:ext cx="10817352" cy="274320"/>
+          </a:xfrm>
+          <a:prstGeom prst="rect">
+            <a:avLst/>
+          </a:prstGeom>
+          <a:noFill/>
+        </p:spPr>
+        <p:txBody>
+          <a:bodyPr wrap="square">
+            <a:spAutoFit/>
+          </a:bodyPr>
+          <a:lstStyle/>
+          <a:p>
+            <a:pPr>
+              <a:defRPr sz="1000" b="1">
+                <a:solidFill>
+                  <a:srgbClr val="38BDF8"/>
+                </a:solidFill>
+                <a:latin typeface="Outfit"/>
+              </a:defRPr>
+            </a:pPr>
+            <a:r>
+              <a:t>DEMONSTRATION</a:t>
+            </a:r>
+          </a:p>
+        </p:txBody>
+      </p:sp>
+      <p:sp>
+        <p:nvSpPr>
+          <p:cNvPr id="3" name="TextBox 2"/>
+          <p:cNvSpPr txBox="1"/>
+          <p:nvPr/>
+        </p:nvSpPr>
+        <p:spPr>
+          <a:xfrm>
+            <a:off x="685800" y="594360"/>
+            <a:ext cx="10817352" cy="731520"/>
+          </a:xfrm>
+          <a:prstGeom prst="rect">
+            <a:avLst/>
+          </a:prstGeom>
+          <a:noFill/>
+        </p:spPr>
+        <p:txBody>
+          <a:bodyPr wrap="square">
+            <a:spAutoFit/>
+          </a:bodyPr>
+          <a:lstStyle/>
+          <a:p>
+            <a:pPr>
+              <a:defRPr sz="3000" b="1">
+                <a:solidFill>
+                  <a:srgbClr val="D4AF37"/>
+                </a:solidFill>
+                <a:latin typeface="Cinzel"/>
+              </a:defRPr>
+            </a:pPr>
+            <a:r>
+              <a:t>Prototype Demonstration &amp; Evaluation Pitch</a:t>
             </a:r>
           </a:p>
         </p:txBody>
@@ -3377,7 +4603,7 @@
               </a:defRPr>
             </a:pPr>
             <a:r>
-              <a:t>CYBERQUEST RPG: FULLY DEPLOYED PROTOTYPE</a:t>
+              <a:t>CYBERQUEST RPG: PRODUCTION PITCH &amp; SCENARIOS</a:t>
             </a:r>
           </a:p>
           <a:p>
@@ -3391,29 +4617,32 @@
               </a:defRPr>
             </a:pPr>
             <a:r>
-              <a:t>• Fully Functional &amp; Hosted Web Application:</a:t>
+              <a:t>• 10-Minute Live Walkthrough Plan:</a:t>
             </a:r>
             <a:br/>
             <a:r>
-              <a:t>  Tested on multiple platforms, with zero setup required to inspect or evaluate.</a:t>
+              <a:t>  1. Welcome Hub: Selecting training modules (Phishing, Scam calls, Mixed Threats).</a:t>
+            </a:r>
+            <a:br/>
+            <a:r>
+              <a:t>  2. Interactive Scenarios: Showing Homograph URL hover cues and Scam Call responses.</a:t>
+            </a:r>
+            <a:br/>
+            <a:r>
+              <a:t>  3. AI Guide Interaction: Conversing with Greymantle for threat advice.</a:t>
+            </a:r>
+            <a:br/>
+            <a:r>
+              <a:t>  4. Void Gates &amp; Leaderboard: sequential MCQ checkpoints and Firestore score submission.</a:t>
             </a:r>
             <a:br/>
             <a:br/>
             <a:r>
-              <a:t>• Integrated Learning Sandbox:</a:t>
+              <a:t>• Scoring Mechanics:</a:t>
             </a:r>
             <a:br/>
             <a:r>
-              <a:t>  Successfully combines threat spotting, vishing audio vishing calls, homograph URLs, security MCQ checkpoints, and dynamic AI guidance.</a:t>
-            </a:r>
-            <a:br/>
-            <a:br/>
-            <a:r>
-              <a:t>• Designed for Inclusivity:</a:t>
-            </a:r>
-            <a:br/>
-            <a:r>
-              <a:t>  Includes keyboard motor control mappings, screen reader accommodations, visual subtitles, and lightweight optimization.</a:t>
+              <a:t>  Score = XP earned + (Accuracy% × 2) + HP remaining.</a:t>
             </a:r>
           </a:p>
         </p:txBody>
@@ -3473,2618 +4702,6 @@
             <a:br/>
             <a:r>
               <a:t>Play now: https://cyberquest-rpg.web.app</a:t>
-            </a:r>
-          </a:p>
-        </p:txBody>
-      </p:sp>
-    </p:spTree>
-  </p:cSld>
-  <p:clrMapOvr>
-    <a:masterClrMapping/>
-  </p:clrMapOvr>
-</p:sld>
-</file>
-
-<file path=ppt/slides/slide2.xml><?xml version="1.0" encoding="utf-8"?>
-<p:sld xmlns:a="http://schemas.openxmlformats.org/drawingml/2006/main" xmlns:p="http://schemas.openxmlformats.org/presentationml/2006/main" xmlns:r="http://schemas.openxmlformats.org/officeDocument/2006/relationships">
-  <p:cSld>
-    <p:bg>
-      <p:bgPr>
-        <a:solidFill>
-          <a:srgbClr val="0B0E14"/>
-        </a:solidFill>
-        <a:effectLst/>
-      </p:bgPr>
-    </p:bg>
-    <p:spTree>
-      <p:nvGrpSpPr>
-        <p:cNvPr id="1" name=""/>
-        <p:cNvGrpSpPr/>
-        <p:nvPr/>
-      </p:nvGrpSpPr>
-      <p:grpSpPr/>
-      <p:sp>
-        <p:nvSpPr>
-          <p:cNvPr id="2" name="TextBox 1"/>
-          <p:cNvSpPr txBox="1"/>
-          <p:nvPr/>
-        </p:nvSpPr>
-        <p:spPr>
-          <a:xfrm>
-            <a:off x="685800" y="365760"/>
-            <a:ext cx="10817352" cy="274320"/>
-          </a:xfrm>
-          <a:prstGeom prst="rect">
-            <a:avLst/>
-          </a:prstGeom>
-          <a:noFill/>
-        </p:spPr>
-        <p:txBody>
-          <a:bodyPr wrap="square">
-            <a:spAutoFit/>
-          </a:bodyPr>
-          <a:lstStyle/>
-          <a:p>
-            <a:pPr>
-              <a:defRPr sz="1000" b="1">
-                <a:solidFill>
-                  <a:srgbClr val="38BDF8"/>
-                </a:solidFill>
-                <a:latin typeface="Outfit"/>
-              </a:defRPr>
-            </a:pPr>
-            <a:r>
-              <a:t>PROBLEM STATEMENT</a:t>
-            </a:r>
-          </a:p>
-        </p:txBody>
-      </p:sp>
-      <p:sp>
-        <p:nvSpPr>
-          <p:cNvPr id="3" name="TextBox 2"/>
-          <p:cNvSpPr txBox="1"/>
-          <p:nvPr/>
-        </p:nvSpPr>
-        <p:spPr>
-          <a:xfrm>
-            <a:off x="685800" y="594360"/>
-            <a:ext cx="10817352" cy="731520"/>
-          </a:xfrm>
-          <a:prstGeom prst="rect">
-            <a:avLst/>
-          </a:prstGeom>
-          <a:noFill/>
-        </p:spPr>
-        <p:txBody>
-          <a:bodyPr wrap="square">
-            <a:spAutoFit/>
-          </a:bodyPr>
-          <a:lstStyle/>
-          <a:p>
-            <a:pPr>
-              <a:defRPr sz="3000" b="1">
-                <a:solidFill>
-                  <a:srgbClr val="D4AF37"/>
-                </a:solidFill>
-                <a:latin typeface="Cinzel"/>
-              </a:defRPr>
-            </a:pPr>
-            <a:r>
-              <a:t>The Social Engineering Threat Landscape</a:t>
-            </a:r>
-          </a:p>
-        </p:txBody>
-      </p:sp>
-      <p:sp>
-        <p:nvSpPr>
-          <p:cNvPr id="4" name="TextBox 3"/>
-          <p:cNvSpPr txBox="1"/>
-          <p:nvPr/>
-        </p:nvSpPr>
-        <p:spPr>
-          <a:xfrm>
-            <a:off x="685800" y="1645920"/>
-            <a:ext cx="5029200" cy="4114800"/>
-          </a:xfrm>
-          <a:prstGeom prst="rect">
-            <a:avLst/>
-          </a:prstGeom>
-          <a:noFill/>
-        </p:spPr>
-        <p:txBody>
-          <a:bodyPr wrap="square">
-            <a:spAutoFit/>
-          </a:bodyPr>
-          <a:lstStyle/>
-          <a:p>
-            <a:pPr>
-              <a:defRPr sz="1800" b="1">
-                <a:solidFill>
-                  <a:srgbClr val="EF4444"/>
-                </a:solidFill>
-                <a:latin typeface="Outfit"/>
-              </a:defRPr>
-            </a:pPr>
-            <a:r>
-              <a:t>THE AWARENESS GAP</a:t>
-            </a:r>
-          </a:p>
-          <a:p>
-            <a:br/>
-            <a:pPr>
-              <a:defRPr sz="1500">
-                <a:solidFill>
-                  <a:srgbClr val="E2E8F0"/>
-                </a:solidFill>
-                <a:latin typeface="Outfit"/>
-              </a:defRPr>
-            </a:pPr>
-            <a:r>
-              <a:t>Today, millions of users fall victim to social engineering and malicious attacks due to a critical lack of cybersecurity awareness.</a:t>
-            </a:r>
-            <a:br/>
-            <a:br/>
-            <a:r>
-              <a:t>Attackers target vulnerable human emotions using urgency and fear. Because standard training tools (text guides, videos, simple presentations) are passive and compliance-driven, they fail to build the split-second reflexes users need to defend themselves against live threats.</a:t>
-            </a:r>
-          </a:p>
-        </p:txBody>
-      </p:sp>
-      <p:sp>
-        <p:nvSpPr>
-          <p:cNvPr id="5" name="Rectangle 4"/>
-          <p:cNvSpPr/>
-          <p:nvPr/>
-        </p:nvSpPr>
-        <p:spPr>
-          <a:xfrm>
-            <a:off x="6217920" y="1645920"/>
-            <a:ext cx="5303520" cy="4114800"/>
-          </a:xfrm>
-          <a:prstGeom prst="rect">
-            <a:avLst/>
-          </a:prstGeom>
-          <a:solidFill>
-            <a:srgbClr val="1A202C"/>
-          </a:solidFill>
-          <a:ln w="19050">
-            <a:solidFill>
-              <a:srgbClr val="EF4444"/>
-            </a:solidFill>
-          </a:ln>
-        </p:spPr>
-        <p:style>
-          <a:lnRef idx="1">
-            <a:schemeClr val="accent1"/>
-          </a:lnRef>
-          <a:fillRef idx="3">
-            <a:schemeClr val="accent1"/>
-          </a:fillRef>
-          <a:effectRef idx="2">
-            <a:schemeClr val="accent1"/>
-          </a:effectRef>
-          <a:fontRef idx="minor">
-            <a:schemeClr val="lt1"/>
-          </a:fontRef>
-        </p:style>
-        <p:txBody>
-          <a:bodyPr rtlCol="0" anchor="ctr" lIns="365760" rIns="365760" tIns="365760" wrap="square"/>
-          <a:lstStyle/>
-          <a:p>
-            <a:pPr algn="ctr">
-              <a:defRPr sz="1800" b="1">
-                <a:solidFill>
-                  <a:srgbClr val="D4AF37"/>
-                </a:solidFill>
-                <a:latin typeface="Outfit"/>
-              </a:defRPr>
-            </a:pPr>
-            <a:r>
-              <a:t>PRIMARY SECURITY CHALLENGES</a:t>
-            </a:r>
-          </a:p>
-          <a:p>
-            <a:br/>
-            <a:pPr>
-              <a:defRPr sz="1300">
-                <a:solidFill>
-                  <a:srgbClr val="E2E8F0"/>
-                </a:solidFill>
-                <a:latin typeface="Outfit"/>
-              </a:defRPr>
-            </a:pPr>
-            <a:r>
-              <a:t>• Sophisticated Attack Vectors:</a:t>
-            </a:r>
-            <a:br/>
-            <a:r>
-              <a:t>  Phishing emails, homograph domains, vishing scam calls, and malicious fake updates target unsuspecting users.</a:t>
-            </a:r>
-            <a:br/>
-            <a:br/>
-            <a:r>
-              <a:t>• Emotional Pressure Tactics:</a:t>
-            </a:r>
-            <a:br/>
-            <a:r>
-              <a:t>  Attackers manipulate situations (e.g. fake bank alerts) to force rapid actions, bypassing logical checks.</a:t>
-            </a:r>
-            <a:br/>
-            <a:br/>
-            <a:r>
-              <a:t>• Flat Learning Drawbacks:</a:t>
-            </a:r>
-            <a:br/>
-            <a:r>
-              <a:t>  Users memorize facts for tests but fail to apply safety measures when facing real-world interactions.</a:t>
-            </a:r>
-          </a:p>
-        </p:txBody>
-      </p:sp>
-    </p:spTree>
-  </p:cSld>
-  <p:clrMapOvr>
-    <a:masterClrMapping/>
-  </p:clrMapOvr>
-</p:sld>
-</file>
-
-<file path=ppt/slides/slide3.xml><?xml version="1.0" encoding="utf-8"?>
-<p:sld xmlns:a="http://schemas.openxmlformats.org/drawingml/2006/main" xmlns:p="http://schemas.openxmlformats.org/presentationml/2006/main" xmlns:r="http://schemas.openxmlformats.org/officeDocument/2006/relationships">
-  <p:cSld>
-    <p:bg>
-      <p:bgPr>
-        <a:solidFill>
-          <a:srgbClr val="0B0E14"/>
-        </a:solidFill>
-        <a:effectLst/>
-      </p:bgPr>
-    </p:bg>
-    <p:spTree>
-      <p:nvGrpSpPr>
-        <p:cNvPr id="1" name=""/>
-        <p:cNvGrpSpPr/>
-        <p:nvPr/>
-      </p:nvGrpSpPr>
-      <p:grpSpPr/>
-      <p:sp>
-        <p:nvSpPr>
-          <p:cNvPr id="2" name="TextBox 1"/>
-          <p:cNvSpPr txBox="1"/>
-          <p:nvPr/>
-        </p:nvSpPr>
-        <p:spPr>
-          <a:xfrm>
-            <a:off x="685800" y="365760"/>
-            <a:ext cx="10817352" cy="274320"/>
-          </a:xfrm>
-          <a:prstGeom prst="rect">
-            <a:avLst/>
-          </a:prstGeom>
-          <a:noFill/>
-        </p:spPr>
-        <p:txBody>
-          <a:bodyPr wrap="square">
-            <a:spAutoFit/>
-          </a:bodyPr>
-          <a:lstStyle/>
-          <a:p>
-            <a:pPr>
-              <a:defRPr sz="1000" b="1">
-                <a:solidFill>
-                  <a:srgbClr val="38BDF8"/>
-                </a:solidFill>
-                <a:latin typeface="Outfit"/>
-              </a:defRPr>
-            </a:pPr>
-            <a:r>
-              <a:t>OBJECTIVE AND ABSTRACT</a:t>
-            </a:r>
-          </a:p>
-        </p:txBody>
-      </p:sp>
-      <p:sp>
-        <p:nvSpPr>
-          <p:cNvPr id="3" name="TextBox 2"/>
-          <p:cNvSpPr txBox="1"/>
-          <p:nvPr/>
-        </p:nvSpPr>
-        <p:spPr>
-          <a:xfrm>
-            <a:off x="685800" y="594360"/>
-            <a:ext cx="10817352" cy="731520"/>
-          </a:xfrm>
-          <a:prstGeom prst="rect">
-            <a:avLst/>
-          </a:prstGeom>
-          <a:noFill/>
-        </p:spPr>
-        <p:txBody>
-          <a:bodyPr wrap="square">
-            <a:spAutoFit/>
-          </a:bodyPr>
-          <a:lstStyle/>
-          <a:p>
-            <a:pPr>
-              <a:defRPr sz="3000" b="1">
-                <a:solidFill>
-                  <a:srgbClr val="D4AF37"/>
-                </a:solidFill>
-                <a:latin typeface="Cinzel"/>
-              </a:defRPr>
-            </a:pPr>
-            <a:r>
-              <a:t>Strategic Objectives &amp; Platform Abstract</a:t>
-            </a:r>
-          </a:p>
-        </p:txBody>
-      </p:sp>
-      <p:sp>
-        <p:nvSpPr>
-          <p:cNvPr id="4" name="Rectangle 3"/>
-          <p:cNvSpPr/>
-          <p:nvPr/>
-        </p:nvSpPr>
-        <p:spPr>
-          <a:xfrm>
-            <a:off x="685800" y="1645920"/>
-            <a:ext cx="5120640" cy="4114800"/>
-          </a:xfrm>
-          <a:prstGeom prst="rect">
-            <a:avLst/>
-          </a:prstGeom>
-          <a:solidFill>
-            <a:srgbClr val="1A202C"/>
-          </a:solidFill>
-          <a:ln w="19050">
-            <a:solidFill>
-              <a:srgbClr val="38BDF8"/>
-            </a:solidFill>
-          </a:ln>
-        </p:spPr>
-        <p:style>
-          <a:lnRef idx="1">
-            <a:schemeClr val="accent1"/>
-          </a:lnRef>
-          <a:fillRef idx="3">
-            <a:schemeClr val="accent1"/>
-          </a:fillRef>
-          <a:effectRef idx="2">
-            <a:schemeClr val="accent1"/>
-          </a:effectRef>
-          <a:fontRef idx="minor">
-            <a:schemeClr val="lt1"/>
-          </a:fontRef>
-        </p:style>
-        <p:txBody>
-          <a:bodyPr rtlCol="0" anchor="ctr" lIns="365760" tIns="365760" wrap="square"/>
-          <a:lstStyle/>
-          <a:p>
-            <a:pPr algn="ctr">
-              <a:defRPr sz="1800" b="1">
-                <a:solidFill>
-                  <a:srgbClr val="38BDF8"/>
-                </a:solidFill>
-                <a:latin typeface="Outfit"/>
-              </a:defRPr>
-            </a:pPr>
-            <a:r>
-              <a:t>PLATFORM ABSTRACT</a:t>
-            </a:r>
-          </a:p>
-          <a:p>
-            <a:br/>
-            <a:pPr>
-              <a:defRPr sz="1400">
-                <a:solidFill>
-                  <a:srgbClr val="E2E8F0"/>
-                </a:solidFill>
-                <a:latin typeface="Outfit"/>
-              </a:defRPr>
-            </a:pPr>
-            <a:r>
-              <a:t>CyberQuest RPG is a web-based, gamified training platform that transforms passive security guides into active decision-making experiences.</a:t>
-            </a:r>
-            <a:br/>
-            <a:br/>
-            <a:r>
-              <a:t>By placing users inside a interactive 3D labyrinth, players encounter simulations of real-world threats. They learn to identify tactics, make high-stakes choices, analyze fake link signatures, and verify caller identities in a completely safe failures-tolerant environment.</a:t>
-            </a:r>
-          </a:p>
-        </p:txBody>
-      </p:sp>
-      <p:sp>
-        <p:nvSpPr>
-          <p:cNvPr id="5" name="Rectangle 4"/>
-          <p:cNvSpPr/>
-          <p:nvPr/>
-        </p:nvSpPr>
-        <p:spPr>
-          <a:xfrm>
-            <a:off x="6355080" y="1645920"/>
-            <a:ext cx="5150815" cy="4114800"/>
-          </a:xfrm>
-          <a:prstGeom prst="rect">
-            <a:avLst/>
-          </a:prstGeom>
-          <a:solidFill>
-            <a:srgbClr val="1A202C"/>
-          </a:solidFill>
-          <a:ln w="19050">
-            <a:solidFill>
-              <a:srgbClr val="D4AF37"/>
-            </a:solidFill>
-          </a:ln>
-        </p:spPr>
-        <p:style>
-          <a:lnRef idx="1">
-            <a:schemeClr val="accent1"/>
-          </a:lnRef>
-          <a:fillRef idx="3">
-            <a:schemeClr val="accent1"/>
-          </a:fillRef>
-          <a:effectRef idx="2">
-            <a:schemeClr val="accent1"/>
-          </a:effectRef>
-          <a:fontRef idx="minor">
-            <a:schemeClr val="lt1"/>
-          </a:fontRef>
-        </p:style>
-        <p:txBody>
-          <a:bodyPr rtlCol="0" anchor="ctr" lIns="365760" tIns="365760" wrap="square"/>
-          <a:lstStyle/>
-          <a:p>
-            <a:pPr algn="ctr">
-              <a:defRPr sz="1800" b="1">
-                <a:solidFill>
-                  <a:srgbClr val="D4AF37"/>
-                </a:solidFill>
-                <a:latin typeface="Outfit"/>
-              </a:defRPr>
-            </a:pPr>
-            <a:r>
-              <a:t>KEY OBJECTIVES</a:t>
-            </a:r>
-          </a:p>
-          <a:p>
-            <a:br/>
-            <a:pPr>
-              <a:defRPr sz="1300">
-                <a:solidFill>
-                  <a:srgbClr val="E2E8F0"/>
-                </a:solidFill>
-                <a:latin typeface="Outfit"/>
-              </a:defRPr>
-            </a:pPr>
-            <a:r>
-              <a:t>• Recognize Deceptive Tactics:</a:t>
-            </a:r>
-            <a:br/>
-            <a:r>
-              <a:t>  Train users to spot phishing attempts, malware traps, and AI vishing call pressures.</a:t>
-            </a:r>
-            <a:br/>
-            <a:br/>
-            <a:r>
-              <a:t>• Adaptive Decision Practice:</a:t>
-            </a:r>
-            <a:br/>
-            <a:r>
-              <a:t>  Allow users to experience consequences of actions safely. Bad decisions drop HP; correct ones build confidence.</a:t>
-            </a:r>
-            <a:br/>
-            <a:br/>
-            <a:r>
-              <a:t>• Build Actionable Reflexes:</a:t>
-            </a:r>
-            <a:br/>
-            <a:r>
-              <a:t>  Provide immediate, actionable steps to protect credentials and utilize official verification channels.</a:t>
-            </a:r>
-          </a:p>
-        </p:txBody>
-      </p:sp>
-    </p:spTree>
-  </p:cSld>
-  <p:clrMapOvr>
-    <a:masterClrMapping/>
-  </p:clrMapOvr>
-</p:sld>
-</file>
-
-<file path=ppt/slides/slide4.xml><?xml version="1.0" encoding="utf-8"?>
-<p:sld xmlns:a="http://schemas.openxmlformats.org/drawingml/2006/main" xmlns:p="http://schemas.openxmlformats.org/presentationml/2006/main" xmlns:r="http://schemas.openxmlformats.org/officeDocument/2006/relationships">
-  <p:cSld>
-    <p:bg>
-      <p:bgPr>
-        <a:solidFill>
-          <a:srgbClr val="0B0E14"/>
-        </a:solidFill>
-        <a:effectLst/>
-      </p:bgPr>
-    </p:bg>
-    <p:spTree>
-      <p:nvGrpSpPr>
-        <p:cNvPr id="1" name=""/>
-        <p:cNvGrpSpPr/>
-        <p:nvPr/>
-      </p:nvGrpSpPr>
-      <p:grpSpPr/>
-      <p:sp>
-        <p:nvSpPr>
-          <p:cNvPr id="2" name="TextBox 1"/>
-          <p:cNvSpPr txBox="1"/>
-          <p:nvPr/>
-        </p:nvSpPr>
-        <p:spPr>
-          <a:xfrm>
-            <a:off x="685800" y="365760"/>
-            <a:ext cx="10817352" cy="274320"/>
-          </a:xfrm>
-          <a:prstGeom prst="rect">
-            <a:avLst/>
-          </a:prstGeom>
-          <a:noFill/>
-        </p:spPr>
-        <p:txBody>
-          <a:bodyPr wrap="square">
-            <a:spAutoFit/>
-          </a:bodyPr>
-          <a:lstStyle/>
-          <a:p>
-            <a:pPr>
-              <a:defRPr sz="1000" b="1">
-                <a:solidFill>
-                  <a:srgbClr val="38BDF8"/>
-                </a:solidFill>
-                <a:latin typeface="Outfit"/>
-              </a:defRPr>
-            </a:pPr>
-            <a:r>
-              <a:t>OBJECTIVE AND ABSTRACT</a:t>
-            </a:r>
-          </a:p>
-        </p:txBody>
-      </p:sp>
-      <p:sp>
-        <p:nvSpPr>
-          <p:cNvPr id="3" name="TextBox 2"/>
-          <p:cNvSpPr txBox="1"/>
-          <p:nvPr/>
-        </p:nvSpPr>
-        <p:spPr>
-          <a:xfrm>
-            <a:off x="685800" y="594360"/>
-            <a:ext cx="10817352" cy="731520"/>
-          </a:xfrm>
-          <a:prstGeom prst="rect">
-            <a:avLst/>
-          </a:prstGeom>
-          <a:noFill/>
-        </p:spPr>
-        <p:txBody>
-          <a:bodyPr wrap="square">
-            <a:spAutoFit/>
-          </a:bodyPr>
-          <a:lstStyle/>
-          <a:p>
-            <a:pPr>
-              <a:defRPr sz="3000" b="1">
-                <a:solidFill>
-                  <a:srgbClr val="D4AF37"/>
-                </a:solidFill>
-                <a:latin typeface="Cinzel"/>
-              </a:defRPr>
-            </a:pPr>
-            <a:r>
-              <a:t>How Gamification Meets Educational Objectives</a:t>
-            </a:r>
-          </a:p>
-        </p:txBody>
-      </p:sp>
-      <p:sp>
-        <p:nvSpPr>
-          <p:cNvPr id="4" name="Rectangle 3"/>
-          <p:cNvSpPr/>
-          <p:nvPr/>
-        </p:nvSpPr>
-        <p:spPr>
-          <a:xfrm>
-            <a:off x="685800" y="1645920"/>
-            <a:ext cx="3383280" cy="4114800"/>
-          </a:xfrm>
-          <a:prstGeom prst="rect">
-            <a:avLst/>
-          </a:prstGeom>
-          <a:solidFill>
-            <a:srgbClr val="1A202C"/>
-          </a:solidFill>
-          <a:ln w="19050">
-            <a:solidFill>
-              <a:srgbClr val="D4AF37"/>
-            </a:solidFill>
-          </a:ln>
-        </p:spPr>
-        <p:style>
-          <a:lnRef idx="1">
-            <a:schemeClr val="accent1"/>
-          </a:lnRef>
-          <a:fillRef idx="3">
-            <a:schemeClr val="accent1"/>
-          </a:fillRef>
-          <a:effectRef idx="2">
-            <a:schemeClr val="accent1"/>
-          </a:effectRef>
-          <a:fontRef idx="minor">
-            <a:schemeClr val="lt1"/>
-          </a:fontRef>
-        </p:style>
-        <p:txBody>
-          <a:bodyPr rtlCol="0" anchor="ctr" lIns="274320" tIns="274320" wrap="square"/>
-          <a:lstStyle/>
-          <a:p>
-            <a:pPr algn="ctr">
-              <a:defRPr sz="1600" b="1">
-                <a:solidFill>
-                  <a:srgbClr val="D4AF37"/>
-                </a:solidFill>
-                <a:latin typeface="Outfit"/>
-              </a:defRPr>
-            </a:pPr>
-            <a:r>
-              <a:t>EXPLORATION &amp; EMOTION</a:t>
-            </a:r>
-          </a:p>
-          <a:p>
-            <a:br/>
-            <a:pPr>
-              <a:defRPr sz="1200">
-                <a:solidFill>
-                  <a:srgbClr val="E2E8F0"/>
-                </a:solidFill>
-                <a:latin typeface="Outfit"/>
-              </a:defRPr>
-            </a:pPr>
-            <a:r>
-              <a:t>• First-Person 3D Space:</a:t>
-            </a:r>
-            <a:br/>
-            <a:r>
-              <a:t>  Players navigate using keyboard controls (WASD/Arrows + Enter), creating active physical coordination.</a:t>
-            </a:r>
-            <a:br/>
-            <a:br/>
-            <a:r>
-              <a:t>• Tension &amp; Health Pool:</a:t>
-            </a:r>
-            <a:br/>
-            <a:r>
-              <a:t>  Starting at 100 HP, players face threats directly. Losing HP when tricked creates low-stakes stress, simulating real attacks.</a:t>
-            </a:r>
-          </a:p>
-        </p:txBody>
-      </p:sp>
-      <p:sp>
-        <p:nvSpPr>
-          <p:cNvPr id="5" name="Rectangle 4"/>
-          <p:cNvSpPr/>
-          <p:nvPr/>
-        </p:nvSpPr>
-        <p:spPr>
-          <a:xfrm>
-            <a:off x="4434840" y="1645920"/>
-            <a:ext cx="3383280" cy="4114800"/>
-          </a:xfrm>
-          <a:prstGeom prst="rect">
-            <a:avLst/>
-          </a:prstGeom>
-          <a:solidFill>
-            <a:srgbClr val="1A202C"/>
-          </a:solidFill>
-          <a:ln w="19050">
-            <a:solidFill>
-              <a:srgbClr val="38BDF8"/>
-            </a:solidFill>
-          </a:ln>
-        </p:spPr>
-        <p:style>
-          <a:lnRef idx="1">
-            <a:schemeClr val="accent1"/>
-          </a:lnRef>
-          <a:fillRef idx="3">
-            <a:schemeClr val="accent1"/>
-          </a:fillRef>
-          <a:effectRef idx="2">
-            <a:schemeClr val="accent1"/>
-          </a:effectRef>
-          <a:fontRef idx="minor">
-            <a:schemeClr val="lt1"/>
-          </a:fontRef>
-        </p:style>
-        <p:txBody>
-          <a:bodyPr rtlCol="0" anchor="ctr" lIns="274320" tIns="274320" wrap="square"/>
-          <a:lstStyle/>
-          <a:p>
-            <a:pPr algn="ctr">
-              <a:defRPr sz="1600" b="1">
-                <a:solidFill>
-                  <a:srgbClr val="38BDF8"/>
-                </a:solidFill>
-                <a:latin typeface="Outfit"/>
-              </a:defRPr>
-            </a:pPr>
-            <a:r>
-              <a:t>ADAPTIVE SIMULATION</a:t>
-            </a:r>
-          </a:p>
-          <a:p>
-            <a:br/>
-            <a:pPr>
-              <a:defRPr sz="1200">
-                <a:solidFill>
-                  <a:srgbClr val="E2E8F0"/>
-                </a:solidFill>
-                <a:latin typeface="Outfit"/>
-              </a:defRPr>
-            </a:pPr>
-            <a:r>
-              <a:t>• Branching Consequences:</a:t>
-            </a:r>
-            <a:br/>
-            <a:r>
-              <a:t>  Platform adapts to user choices. Spotting threats early opens easier paths; failing redirects the player to secure checkpoint gates.</a:t>
-            </a:r>
-            <a:br/>
-            <a:br/>
-            <a:r>
-              <a:t>• Actionable Practice:</a:t>
-            </a:r>
-            <a:br/>
-            <a:r>
-              <a:t>  Teaches specific check protocols, such as hovering to read link paths before clicking.</a:t>
-            </a:r>
-          </a:p>
-        </p:txBody>
-      </p:sp>
-      <p:sp>
-        <p:nvSpPr>
-          <p:cNvPr id="6" name="Rectangle 5"/>
-          <p:cNvSpPr/>
-          <p:nvPr/>
-        </p:nvSpPr>
-        <p:spPr>
-          <a:xfrm>
-            <a:off x="8183880" y="1645920"/>
-            <a:ext cx="3383280" cy="4114800"/>
-          </a:xfrm>
-          <a:prstGeom prst="rect">
-            <a:avLst/>
-          </a:prstGeom>
-          <a:solidFill>
-            <a:srgbClr val="1A202C"/>
-          </a:solidFill>
-          <a:ln w="19050">
-            <a:solidFill>
-              <a:srgbClr val="00FF66"/>
-            </a:solidFill>
-          </a:ln>
-        </p:spPr>
-        <p:style>
-          <a:lnRef idx="1">
-            <a:schemeClr val="accent1"/>
-          </a:lnRef>
-          <a:fillRef idx="3">
-            <a:schemeClr val="accent1"/>
-          </a:fillRef>
-          <a:effectRef idx="2">
-            <a:schemeClr val="accent1"/>
-          </a:effectRef>
-          <a:fontRef idx="minor">
-            <a:schemeClr val="lt1"/>
-          </a:fontRef>
-        </p:style>
-        <p:txBody>
-          <a:bodyPr rtlCol="0" anchor="ctr" lIns="274320" tIns="274320" wrap="square"/>
-          <a:lstStyle/>
-          <a:p>
-            <a:pPr algn="ctr">
-              <a:defRPr sz="1600" b="1">
-                <a:solidFill>
-                  <a:srgbClr val="00FF66"/>
-                </a:solidFill>
-                <a:latin typeface="Outfit"/>
-              </a:defRPr>
-            </a:pPr>
-            <a:r>
-              <a:t>REINFORCING BEHAVIORS</a:t>
-            </a:r>
-          </a:p>
-          <a:p>
-            <a:br/>
-            <a:pPr>
-              <a:defRPr sz="1200">
-                <a:solidFill>
-                  <a:srgbClr val="E2E8F0"/>
-                </a:solidFill>
-                <a:latin typeface="Outfit"/>
-              </a:defRPr>
-            </a:pPr>
-            <a:r>
-              <a:t>• Score Rewards System:</a:t>
-            </a:r>
-            <a:br/>
-            <a:r>
-              <a:t>  XP, coins, and shields reinforce correct actions.</a:t>
-            </a:r>
-            <a:br/>
-            <a:br/>
-            <a:r>
-              <a:t>• Failure Integration:</a:t>
-            </a:r>
-            <a:br/>
-            <a:r>
-              <a:t>  When players fall below HP limits, they restart corridors with feedback. Encourages trial-and-error memory building.</a:t>
-            </a:r>
-          </a:p>
-        </p:txBody>
-      </p:sp>
-    </p:spTree>
-  </p:cSld>
-  <p:clrMapOvr>
-    <a:masterClrMapping/>
-  </p:clrMapOvr>
-</p:sld>
-</file>
-
-<file path=ppt/slides/slide5.xml><?xml version="1.0" encoding="utf-8"?>
-<p:sld xmlns:a="http://schemas.openxmlformats.org/drawingml/2006/main" xmlns:p="http://schemas.openxmlformats.org/presentationml/2006/main" xmlns:r="http://schemas.openxmlformats.org/officeDocument/2006/relationships">
-  <p:cSld>
-    <p:bg>
-      <p:bgPr>
-        <a:solidFill>
-          <a:srgbClr val="0B0E14"/>
-        </a:solidFill>
-        <a:effectLst/>
-      </p:bgPr>
-    </p:bg>
-    <p:spTree>
-      <p:nvGrpSpPr>
-        <p:cNvPr id="1" name=""/>
-        <p:cNvGrpSpPr/>
-        <p:nvPr/>
-      </p:nvGrpSpPr>
-      <p:grpSpPr/>
-      <p:sp>
-        <p:nvSpPr>
-          <p:cNvPr id="2" name="TextBox 1"/>
-          <p:cNvSpPr txBox="1"/>
-          <p:nvPr/>
-        </p:nvSpPr>
-        <p:spPr>
-          <a:xfrm>
-            <a:off x="685800" y="365760"/>
-            <a:ext cx="10817352" cy="274320"/>
-          </a:xfrm>
-          <a:prstGeom prst="rect">
-            <a:avLst/>
-          </a:prstGeom>
-          <a:noFill/>
-        </p:spPr>
-        <p:txBody>
-          <a:bodyPr wrap="square">
-            <a:spAutoFit/>
-          </a:bodyPr>
-          <a:lstStyle/>
-          <a:p>
-            <a:pPr>
-              <a:defRPr sz="1000" b="1">
-                <a:solidFill>
-                  <a:srgbClr val="38BDF8"/>
-                </a:solidFill>
-                <a:latin typeface="Outfit"/>
-              </a:defRPr>
-            </a:pPr>
-            <a:r>
-              <a:t>TECHNOLOGY AND TOOLS USED</a:t>
-            </a:r>
-          </a:p>
-        </p:txBody>
-      </p:sp>
-      <p:sp>
-        <p:nvSpPr>
-          <p:cNvPr id="3" name="TextBox 2"/>
-          <p:cNvSpPr txBox="1"/>
-          <p:nvPr/>
-        </p:nvSpPr>
-        <p:spPr>
-          <a:xfrm>
-            <a:off x="685800" y="594360"/>
-            <a:ext cx="10817352" cy="731520"/>
-          </a:xfrm>
-          <a:prstGeom prst="rect">
-            <a:avLst/>
-          </a:prstGeom>
-          <a:noFill/>
-        </p:spPr>
-        <p:txBody>
-          <a:bodyPr wrap="square">
-            <a:spAutoFit/>
-          </a:bodyPr>
-          <a:lstStyle/>
-          <a:p>
-            <a:pPr>
-              <a:defRPr sz="3000" b="1">
-                <a:solidFill>
-                  <a:srgbClr val="D4AF37"/>
-                </a:solidFill>
-                <a:latin typeface="Cinzel"/>
-              </a:defRPr>
-            </a:pPr>
-            <a:r>
-              <a:t>Lightweight Tech Stack &amp; Secure AI Integration</a:t>
-            </a:r>
-          </a:p>
-        </p:txBody>
-      </p:sp>
-      <p:sp>
-        <p:nvSpPr>
-          <p:cNvPr id="4" name="Rectangle 3"/>
-          <p:cNvSpPr/>
-          <p:nvPr/>
-        </p:nvSpPr>
-        <p:spPr>
-          <a:xfrm>
-            <a:off x="685800" y="1645920"/>
-            <a:ext cx="3383280" cy="4114800"/>
-          </a:xfrm>
-          <a:prstGeom prst="rect">
-            <a:avLst/>
-          </a:prstGeom>
-          <a:solidFill>
-            <a:srgbClr val="1A202C"/>
-          </a:solidFill>
-          <a:ln w="19050">
-            <a:solidFill>
-              <a:srgbClr val="38BDF8"/>
-            </a:solidFill>
-          </a:ln>
-        </p:spPr>
-        <p:style>
-          <a:lnRef idx="1">
-            <a:schemeClr val="accent1"/>
-          </a:lnRef>
-          <a:fillRef idx="3">
-            <a:schemeClr val="accent1"/>
-          </a:fillRef>
-          <a:effectRef idx="2">
-            <a:schemeClr val="accent1"/>
-          </a:effectRef>
-          <a:fontRef idx="minor">
-            <a:schemeClr val="lt1"/>
-          </a:fontRef>
-        </p:style>
-        <p:txBody>
-          <a:bodyPr rtlCol="0" anchor="ctr" lIns="274320" tIns="274320" wrap="square"/>
-          <a:lstStyle/>
-          <a:p>
-            <a:pPr algn="ctr">
-              <a:defRPr sz="1600" b="1">
-                <a:solidFill>
-                  <a:srgbClr val="38BDF8"/>
-                </a:solidFill>
-                <a:latin typeface="Outfit"/>
-              </a:defRPr>
-            </a:pPr>
-            <a:r>
-              <a:t>FRONTEND &amp; GRAPHICS</a:t>
-            </a:r>
-          </a:p>
-          <a:p>
-            <a:br/>
-            <a:pPr>
-              <a:defRPr sz="1200">
-                <a:solidFill>
-                  <a:srgbClr val="E2E8F0"/>
-                </a:solidFill>
-                <a:latin typeface="Outfit"/>
-              </a:defRPr>
-            </a:pPr>
-            <a:r>
-              <a:t>• Vanilla Web Core:</a:t>
-            </a:r>
-            <a:br/>
-            <a:r>
-              <a:t>  HTML5, CSS3, and JavaScript ensure rapid loading and maximum browser support.</a:t>
-            </a:r>
-            <a:br/>
-            <a:br/>
-            <a:r>
-              <a:t>• WebGL 3D Rendering:</a:t>
-            </a:r>
-            <a:br/>
-            <a:r>
-              <a:t>  Three.js (r128) powers the 3D exploration interface efficiently, avoiding heavy engine weight or installation barriers.</a:t>
-            </a:r>
-          </a:p>
-        </p:txBody>
-      </p:sp>
-      <p:sp>
-        <p:nvSpPr>
-          <p:cNvPr id="5" name="Rectangle 4"/>
-          <p:cNvSpPr/>
-          <p:nvPr/>
-        </p:nvSpPr>
-        <p:spPr>
-          <a:xfrm>
-            <a:off x="4434840" y="1645920"/>
-            <a:ext cx="3383280" cy="4114800"/>
-          </a:xfrm>
-          <a:prstGeom prst="rect">
-            <a:avLst/>
-          </a:prstGeom>
-          <a:solidFill>
-            <a:srgbClr val="1A202C"/>
-          </a:solidFill>
-          <a:ln w="19050">
-            <a:solidFill>
-              <a:srgbClr val="D4AF37"/>
-            </a:solidFill>
-          </a:ln>
-        </p:spPr>
-        <p:style>
-          <a:lnRef idx="1">
-            <a:schemeClr val="accent1"/>
-          </a:lnRef>
-          <a:fillRef idx="3">
-            <a:schemeClr val="accent1"/>
-          </a:fillRef>
-          <a:effectRef idx="2">
-            <a:schemeClr val="accent1"/>
-          </a:effectRef>
-          <a:fontRef idx="minor">
-            <a:schemeClr val="lt1"/>
-          </a:fontRef>
-        </p:style>
-        <p:txBody>
-          <a:bodyPr rtlCol="0" anchor="ctr" lIns="274320" tIns="274320" wrap="square"/>
-          <a:lstStyle/>
-          <a:p>
-            <a:pPr algn="ctr">
-              <a:defRPr sz="1600" b="1">
-                <a:solidFill>
-                  <a:srgbClr val="D4AF37"/>
-                </a:solidFill>
-                <a:latin typeface="Outfit"/>
-              </a:defRPr>
-            </a:pPr>
-            <a:r>
-              <a:t>CLOUD BACKEND</a:t>
-            </a:r>
-          </a:p>
-          <a:p>
-            <a:br/>
-            <a:pPr>
-              <a:defRPr sz="1200">
-                <a:solidFill>
-                  <a:srgbClr val="E2E8F0"/>
-                </a:solidFill>
-                <a:latin typeface="Outfit"/>
-              </a:defRPr>
-            </a:pPr>
-            <a:r>
-              <a:t>• Firebase Hosting:</a:t>
-            </a:r>
-            <a:br/>
-            <a:r>
-              <a:t>  Deployed on a global CDN ensuring zero latency.</a:t>
-            </a:r>
-            <a:br/>
-            <a:br/>
-            <a:r>
-              <a:t>• Firestore Database:</a:t>
-            </a:r>
-            <a:br/>
-            <a:r>
-              <a:t>  Maintains secure real-time leaderboard states.</a:t>
-            </a:r>
-            <a:br/>
-            <a:br/>
-            <a:r>
-              <a:t>• Anonymous Auth:</a:t>
-            </a:r>
-            <a:br/>
-            <a:r>
-              <a:t>  Generates pseudonyms (Guardian #1731) to guarantee absolute data privacy.</a:t>
-            </a:r>
-          </a:p>
-        </p:txBody>
-      </p:sp>
-      <p:sp>
-        <p:nvSpPr>
-          <p:cNvPr id="6" name="Rectangle 5"/>
-          <p:cNvSpPr/>
-          <p:nvPr/>
-        </p:nvSpPr>
-        <p:spPr>
-          <a:xfrm>
-            <a:off x="8183880" y="1645920"/>
-            <a:ext cx="3383280" cy="4114800"/>
-          </a:xfrm>
-          <a:prstGeom prst="rect">
-            <a:avLst/>
-          </a:prstGeom>
-          <a:solidFill>
-            <a:srgbClr val="1A202C"/>
-          </a:solidFill>
-          <a:ln w="19050">
-            <a:solidFill>
-              <a:srgbClr val="00FF66"/>
-            </a:solidFill>
-          </a:ln>
-        </p:spPr>
-        <p:style>
-          <a:lnRef idx="1">
-            <a:schemeClr val="accent1"/>
-          </a:lnRef>
-          <a:fillRef idx="3">
-            <a:schemeClr val="accent1"/>
-          </a:fillRef>
-          <a:effectRef idx="2">
-            <a:schemeClr val="accent1"/>
-          </a:effectRef>
-          <a:fontRef idx="minor">
-            <a:schemeClr val="lt1"/>
-          </a:fontRef>
-        </p:style>
-        <p:txBody>
-          <a:bodyPr rtlCol="0" anchor="ctr" lIns="274320" tIns="274320" wrap="square"/>
-          <a:lstStyle/>
-          <a:p>
-            <a:pPr algn="ctr">
-              <a:defRPr sz="1600" b="1">
-                <a:solidFill>
-                  <a:srgbClr val="00FF66"/>
-                </a:solidFill>
-                <a:latin typeface="Outfit"/>
-              </a:defRPr>
-            </a:pPr>
-            <a:r>
-              <a:t>SECURE AI API PROXY</a:t>
-            </a:r>
-          </a:p>
-          <a:p>
-            <a:br/>
-            <a:pPr>
-              <a:defRPr sz="1200">
-                <a:solidFill>
-                  <a:srgbClr val="E2E8F0"/>
-                </a:solidFill>
-                <a:latin typeface="Outfit"/>
-              </a:defRPr>
-            </a:pPr>
-            <a:r>
-              <a:t>• Serverless Cloud Functions:</a:t>
-            </a:r>
-            <a:br/>
-            <a:r>
-              <a:t>  Client commands call a backend proxy function (/api/guide).</a:t>
-            </a:r>
-            <a:br/>
-            <a:br/>
-            <a:r>
-              <a:t>• API Key Obfuscation:</a:t>
-            </a:r>
-            <a:br/>
-            <a:r>
-              <a:t>  API keys (Groq Chat Completion) are stored server-side to satisfy push protection rules.</a:t>
-            </a:r>
-            <a:br/>
-            <a:br/>
-            <a:r>
-              <a:t>• LLM Safeguards:</a:t>
-            </a:r>
-            <a:br/>
-            <a:r>
-              <a:t>  Restricts response scoping to cybersecurity topics.</a:t>
-            </a:r>
-          </a:p>
-        </p:txBody>
-      </p:sp>
-    </p:spTree>
-  </p:cSld>
-  <p:clrMapOvr>
-    <a:masterClrMapping/>
-  </p:clrMapOvr>
-</p:sld>
-</file>
-
-<file path=ppt/slides/slide6.xml><?xml version="1.0" encoding="utf-8"?>
-<p:sld xmlns:a="http://schemas.openxmlformats.org/drawingml/2006/main" xmlns:p="http://schemas.openxmlformats.org/presentationml/2006/main" xmlns:r="http://schemas.openxmlformats.org/officeDocument/2006/relationships">
-  <p:cSld>
-    <p:bg>
-      <p:bgPr>
-        <a:solidFill>
-          <a:srgbClr val="0B0E14"/>
-        </a:solidFill>
-        <a:effectLst/>
-      </p:bgPr>
-    </p:bg>
-    <p:spTree>
-      <p:nvGrpSpPr>
-        <p:cNvPr id="1" name=""/>
-        <p:cNvGrpSpPr/>
-        <p:nvPr/>
-      </p:nvGrpSpPr>
-      <p:grpSpPr/>
-      <p:sp>
-        <p:nvSpPr>
-          <p:cNvPr id="2" name="TextBox 1"/>
-          <p:cNvSpPr txBox="1"/>
-          <p:nvPr/>
-        </p:nvSpPr>
-        <p:spPr>
-          <a:xfrm>
-            <a:off x="685800" y="365760"/>
-            <a:ext cx="10817352" cy="274320"/>
-          </a:xfrm>
-          <a:prstGeom prst="rect">
-            <a:avLst/>
-          </a:prstGeom>
-          <a:noFill/>
-        </p:spPr>
-        <p:txBody>
-          <a:bodyPr wrap="square">
-            <a:spAutoFit/>
-          </a:bodyPr>
-          <a:lstStyle/>
-          <a:p>
-            <a:pPr>
-              <a:defRPr sz="1000" b="1">
-                <a:solidFill>
-                  <a:srgbClr val="38BDF8"/>
-                </a:solidFill>
-                <a:latin typeface="Outfit"/>
-              </a:defRPr>
-            </a:pPr>
-            <a:r>
-              <a:t>TECHNOLOGY AND TOOLS USED</a:t>
-            </a:r>
-          </a:p>
-        </p:txBody>
-      </p:sp>
-      <p:sp>
-        <p:nvSpPr>
-          <p:cNvPr id="3" name="TextBox 2"/>
-          <p:cNvSpPr txBox="1"/>
-          <p:nvPr/>
-        </p:nvSpPr>
-        <p:spPr>
-          <a:xfrm>
-            <a:off x="685800" y="594360"/>
-            <a:ext cx="10817352" cy="731520"/>
-          </a:xfrm>
-          <a:prstGeom prst="rect">
-            <a:avLst/>
-          </a:prstGeom>
-          <a:noFill/>
-        </p:spPr>
-        <p:txBody>
-          <a:bodyPr wrap="square">
-            <a:spAutoFit/>
-          </a:bodyPr>
-          <a:lstStyle/>
-          <a:p>
-            <a:pPr>
-              <a:defRPr sz="3000" b="1">
-                <a:solidFill>
-                  <a:srgbClr val="D4AF37"/>
-                </a:solidFill>
-                <a:latin typeface="Cinzel"/>
-              </a:defRPr>
-            </a:pPr>
-            <a:r>
-              <a:t>Accessibility &amp; Inclusivity Features</a:t>
-            </a:r>
-          </a:p>
-        </p:txBody>
-      </p:sp>
-      <p:sp>
-        <p:nvSpPr>
-          <p:cNvPr id="4" name="Rectangle 3"/>
-          <p:cNvSpPr/>
-          <p:nvPr/>
-        </p:nvSpPr>
-        <p:spPr>
-          <a:xfrm>
-            <a:off x="685800" y="1920240"/>
-            <a:ext cx="2468880" cy="3931920"/>
-          </a:xfrm>
-          <a:prstGeom prst="rect">
-            <a:avLst/>
-          </a:prstGeom>
-          <a:solidFill>
-            <a:srgbClr val="1A202C"/>
-          </a:solidFill>
-          <a:ln w="19050">
-            <a:solidFill>
-              <a:srgbClr val="38BDF8"/>
-            </a:solidFill>
-          </a:ln>
-        </p:spPr>
-        <p:style>
-          <a:lnRef idx="1">
-            <a:schemeClr val="accent1"/>
-          </a:lnRef>
-          <a:fillRef idx="3">
-            <a:schemeClr val="accent1"/>
-          </a:fillRef>
-          <a:effectRef idx="2">
-            <a:schemeClr val="accent1"/>
-          </a:effectRef>
-          <a:fontRef idx="minor">
-            <a:schemeClr val="lt1"/>
-          </a:fontRef>
-        </p:style>
-        <p:txBody>
-          <a:bodyPr rtlCol="0" anchor="ctr" lIns="228600" tIns="274320" wrap="square"/>
-          <a:lstStyle/>
-          <a:p>
-            <a:pPr algn="ctr">
-              <a:defRPr sz="1500" b="1">
-                <a:solidFill>
-                  <a:srgbClr val="38BDF8"/>
-                </a:solidFill>
-                <a:latin typeface="Outfit"/>
-              </a:defRPr>
-            </a:pPr>
-            <a:r>
-              <a:t>HEARING ASSISTANCE</a:t>
-            </a:r>
-          </a:p>
-          <a:p>
-            <a:br/>
-            <a:pPr>
-              <a:defRPr sz="1100">
-                <a:solidFill>
-                  <a:srgbClr val="E2E8F0"/>
-                </a:solidFill>
-                <a:latin typeface="Outfit"/>
-              </a:defRPr>
-            </a:pPr>
-            <a:r>
-              <a:t>Simulated vishing phone calls feature automated visual transcript overlays and clear subtitles, letting hearing-impaired users identify threat patterns without sound.</a:t>
-            </a:r>
-          </a:p>
-        </p:txBody>
-      </p:sp>
-      <p:sp>
-        <p:nvSpPr>
-          <p:cNvPr id="5" name="Rectangle 4"/>
-          <p:cNvSpPr/>
-          <p:nvPr/>
-        </p:nvSpPr>
-        <p:spPr>
-          <a:xfrm>
-            <a:off x="3429000" y="1920240"/>
-            <a:ext cx="2468880" cy="3931920"/>
-          </a:xfrm>
-          <a:prstGeom prst="rect">
-            <a:avLst/>
-          </a:prstGeom>
-          <a:solidFill>
-            <a:srgbClr val="1A202C"/>
-          </a:solidFill>
-          <a:ln w="19050">
-            <a:solidFill>
-              <a:srgbClr val="D4AF37"/>
-            </a:solidFill>
-          </a:ln>
-        </p:spPr>
-        <p:style>
-          <a:lnRef idx="1">
-            <a:schemeClr val="accent1"/>
-          </a:lnRef>
-          <a:fillRef idx="3">
-            <a:schemeClr val="accent1"/>
-          </a:fillRef>
-          <a:effectRef idx="2">
-            <a:schemeClr val="accent1"/>
-          </a:effectRef>
-          <a:fontRef idx="minor">
-            <a:schemeClr val="lt1"/>
-          </a:fontRef>
-        </p:style>
-        <p:txBody>
-          <a:bodyPr rtlCol="0" anchor="ctr" lIns="228600" tIns="274320" wrap="square"/>
-          <a:lstStyle/>
-          <a:p>
-            <a:pPr algn="ctr">
-              <a:defRPr sz="1500" b="1">
-                <a:solidFill>
-                  <a:srgbClr val="D4AF37"/>
-                </a:solidFill>
-                <a:latin typeface="Outfit"/>
-              </a:defRPr>
-            </a:pPr>
-            <a:r>
-              <a:t>VISUAL ADJUSTMENTS</a:t>
-            </a:r>
-          </a:p>
-          <a:p>
-            <a:br/>
-            <a:pPr>
-              <a:defRPr sz="1100">
-                <a:solidFill>
-                  <a:srgbClr val="E2E8F0"/>
-                </a:solidFill>
-                <a:latin typeface="Outfit"/>
-              </a:defRPr>
-            </a:pPr>
-            <a:r>
-              <a:t>Utilizes high-contrast dark backgrounds, responsive scales, gold highlight headers, and clear color coding (green correct vs red incorrect) to help focus.</a:t>
-            </a:r>
-          </a:p>
-        </p:txBody>
-      </p:sp>
-      <p:sp>
-        <p:nvSpPr>
-          <p:cNvPr id="6" name="Rectangle 5"/>
-          <p:cNvSpPr/>
-          <p:nvPr/>
-        </p:nvSpPr>
-        <p:spPr>
-          <a:xfrm>
-            <a:off x="6172200" y="1920240"/>
-            <a:ext cx="2468880" cy="3931920"/>
-          </a:xfrm>
-          <a:prstGeom prst="rect">
-            <a:avLst/>
-          </a:prstGeom>
-          <a:solidFill>
-            <a:srgbClr val="1A202C"/>
-          </a:solidFill>
-          <a:ln w="19050">
-            <a:solidFill>
-              <a:srgbClr val="00FF66"/>
-            </a:solidFill>
-          </a:ln>
-        </p:spPr>
-        <p:style>
-          <a:lnRef idx="1">
-            <a:schemeClr val="accent1"/>
-          </a:lnRef>
-          <a:fillRef idx="3">
-            <a:schemeClr val="accent1"/>
-          </a:fillRef>
-          <a:effectRef idx="2">
-            <a:schemeClr val="accent1"/>
-          </a:effectRef>
-          <a:fontRef idx="minor">
-            <a:schemeClr val="lt1"/>
-          </a:fontRef>
-        </p:style>
-        <p:txBody>
-          <a:bodyPr rtlCol="0" anchor="ctr" lIns="228600" tIns="274320" wrap="square"/>
-          <a:lstStyle/>
-          <a:p>
-            <a:pPr algn="ctr">
-              <a:defRPr sz="1500" b="1">
-                <a:solidFill>
-                  <a:srgbClr val="00FF66"/>
-                </a:solidFill>
-                <a:latin typeface="Outfit"/>
-              </a:defRPr>
-            </a:pPr>
-            <a:r>
-              <a:t>PHYSICAL CONTROLS</a:t>
-            </a:r>
-          </a:p>
-          <a:p>
-            <a:br/>
-            <a:pPr>
-              <a:defRPr sz="1100">
-                <a:solidFill>
-                  <a:srgbClr val="E2E8F0"/>
-                </a:solidFill>
-                <a:latin typeface="Outfit"/>
-              </a:defRPr>
-            </a:pPr>
-            <a:r>
-              <a:t>Supports simple keyboard controls (WASD/Arrows) and enter key interaction bypasses, offering motor-impaired players straightforward navigation options.</a:t>
-            </a:r>
-          </a:p>
-        </p:txBody>
-      </p:sp>
-      <p:sp>
-        <p:nvSpPr>
-          <p:cNvPr id="7" name="Rectangle 6"/>
-          <p:cNvSpPr/>
-          <p:nvPr/>
-        </p:nvSpPr>
-        <p:spPr>
-          <a:xfrm>
-            <a:off x="8915400" y="1920240"/>
-            <a:ext cx="2468880" cy="3931920"/>
-          </a:xfrm>
-          <a:prstGeom prst="rect">
-            <a:avLst/>
-          </a:prstGeom>
-          <a:solidFill>
-            <a:srgbClr val="1A202C"/>
-          </a:solidFill>
-          <a:ln w="19050">
-            <a:solidFill>
-              <a:srgbClr val="EF4444"/>
-            </a:solidFill>
-          </a:ln>
-        </p:spPr>
-        <p:style>
-          <a:lnRef idx="1">
-            <a:schemeClr val="accent1"/>
-          </a:lnRef>
-          <a:fillRef idx="3">
-            <a:schemeClr val="accent1"/>
-          </a:fillRef>
-          <a:effectRef idx="2">
-            <a:schemeClr val="accent1"/>
-          </a:effectRef>
-          <a:fontRef idx="minor">
-            <a:schemeClr val="lt1"/>
-          </a:fontRef>
-        </p:style>
-        <p:txBody>
-          <a:bodyPr rtlCol="0" anchor="ctr" lIns="228600" tIns="274320" wrap="square"/>
-          <a:lstStyle/>
-          <a:p>
-            <a:pPr algn="ctr">
-              <a:defRPr sz="1500" b="1">
-                <a:solidFill>
-                  <a:srgbClr val="EF4444"/>
-                </a:solidFill>
-                <a:latin typeface="Outfit"/>
-              </a:defRPr>
-            </a:pPr>
-            <a:r>
-              <a:t>HARDWARE BARRIERS</a:t>
-            </a:r>
-          </a:p>
-          <a:p>
-            <a:br/>
-            <a:pPr>
-              <a:defRPr sz="1100">
-                <a:solidFill>
-                  <a:srgbClr val="E2E8F0"/>
-                </a:solidFill>
-                <a:latin typeface="Outfit"/>
-              </a:defRPr>
-            </a:pPr>
-            <a:r>
-              <a:t>Optimized to execute smoothly on standard laptops and integrated graphics, loading under 1.5 seconds even on low-bandwidth connections.</a:t>
-            </a:r>
-          </a:p>
-        </p:txBody>
-      </p:sp>
-    </p:spTree>
-  </p:cSld>
-  <p:clrMapOvr>
-    <a:masterClrMapping/>
-  </p:clrMapOvr>
-</p:sld>
-</file>
-
-<file path=ppt/slides/slide7.xml><?xml version="1.0" encoding="utf-8"?>
-<p:sld xmlns:a="http://schemas.openxmlformats.org/drawingml/2006/main" xmlns:p="http://schemas.openxmlformats.org/presentationml/2006/main" xmlns:r="http://schemas.openxmlformats.org/officeDocument/2006/relationships">
-  <p:cSld>
-    <p:bg>
-      <p:bgPr>
-        <a:solidFill>
-          <a:srgbClr val="0B0E14"/>
-        </a:solidFill>
-        <a:effectLst/>
-      </p:bgPr>
-    </p:bg>
-    <p:spTree>
-      <p:nvGrpSpPr>
-        <p:cNvPr id="1" name=""/>
-        <p:cNvGrpSpPr/>
-        <p:nvPr/>
-      </p:nvGrpSpPr>
-      <p:grpSpPr/>
-      <p:sp>
-        <p:nvSpPr>
-          <p:cNvPr id="2" name="TextBox 1"/>
-          <p:cNvSpPr txBox="1"/>
-          <p:nvPr/>
-        </p:nvSpPr>
-        <p:spPr>
-          <a:xfrm>
-            <a:off x="685800" y="365760"/>
-            <a:ext cx="10817352" cy="274320"/>
-          </a:xfrm>
-          <a:prstGeom prst="rect">
-            <a:avLst/>
-          </a:prstGeom>
-          <a:noFill/>
-        </p:spPr>
-        <p:txBody>
-          <a:bodyPr wrap="square">
-            <a:spAutoFit/>
-          </a:bodyPr>
-          <a:lstStyle/>
-          <a:p>
-            <a:pPr>
-              <a:defRPr sz="1000" b="1">
-                <a:solidFill>
-                  <a:srgbClr val="38BDF8"/>
-                </a:solidFill>
-                <a:latin typeface="Outfit"/>
-              </a:defRPr>
-            </a:pPr>
-            <a:r>
-              <a:t>DELIVERABLE OUTCOME</a:t>
-            </a:r>
-          </a:p>
-        </p:txBody>
-      </p:sp>
-      <p:sp>
-        <p:nvSpPr>
-          <p:cNvPr id="3" name="TextBox 2"/>
-          <p:cNvSpPr txBox="1"/>
-          <p:nvPr/>
-        </p:nvSpPr>
-        <p:spPr>
-          <a:xfrm>
-            <a:off x="685800" y="594360"/>
-            <a:ext cx="10817352" cy="731520"/>
-          </a:xfrm>
-          <a:prstGeom prst="rect">
-            <a:avLst/>
-          </a:prstGeom>
-          <a:noFill/>
-        </p:spPr>
-        <p:txBody>
-          <a:bodyPr wrap="square">
-            <a:spAutoFit/>
-          </a:bodyPr>
-          <a:lstStyle/>
-          <a:p>
-            <a:pPr>
-              <a:defRPr sz="3000" b="1">
-                <a:solidFill>
-                  <a:srgbClr val="D4AF37"/>
-                </a:solidFill>
-                <a:latin typeface="Cinzel"/>
-              </a:defRPr>
-            </a:pPr>
-            <a:r>
-              <a:t>Deliverable Outcome: Simulated Threat Scenarios</a:t>
-            </a:r>
-          </a:p>
-        </p:txBody>
-      </p:sp>
-      <p:sp>
-        <p:nvSpPr>
-          <p:cNvPr id="4" name="Rectangle 3"/>
-          <p:cNvSpPr/>
-          <p:nvPr/>
-        </p:nvSpPr>
-        <p:spPr>
-          <a:xfrm>
-            <a:off x="685800" y="1645920"/>
-            <a:ext cx="5120640" cy="1920240"/>
-          </a:xfrm>
-          <a:prstGeom prst="rect">
-            <a:avLst/>
-          </a:prstGeom>
-          <a:solidFill>
-            <a:srgbClr val="1A202C"/>
-          </a:solidFill>
-          <a:ln w="19050">
-            <a:solidFill>
-              <a:srgbClr val="D4AF37"/>
-            </a:solidFill>
-          </a:ln>
-        </p:spPr>
-        <p:style>
-          <a:lnRef idx="1">
-            <a:schemeClr val="accent1"/>
-          </a:lnRef>
-          <a:fillRef idx="3">
-            <a:schemeClr val="accent1"/>
-          </a:fillRef>
-          <a:effectRef idx="2">
-            <a:schemeClr val="accent1"/>
-          </a:effectRef>
-          <a:fontRef idx="minor">
-            <a:schemeClr val="lt1"/>
-          </a:fontRef>
-        </p:style>
-        <p:txBody>
-          <a:bodyPr rtlCol="0" anchor="ctr" lIns="182880" rIns="182880" tIns="127000" wrap="square"/>
-          <a:lstStyle/>
-          <a:p>
-            <a:pPr algn="ctr">
-              <a:defRPr sz="1500" b="1">
-                <a:solidFill>
-                  <a:srgbClr val="D4AF37"/>
-                </a:solidFill>
-                <a:latin typeface="Outfit"/>
-              </a:defRPr>
-            </a:pPr>
-            <a:r>
-              <a:t>01 | PHISHING LINKS (HOMOGRAPH ATTACKS)</a:t>
-            </a:r>
-          </a:p>
-          <a:p>
-            <a:pPr>
-              <a:defRPr sz="1200">
-                <a:solidFill>
-                  <a:srgbClr val="E2E8F0"/>
-                </a:solidFill>
-                <a:latin typeface="Outfit"/>
-              </a:defRPr>
-            </a:pPr>
-            <a:r>
-              <a:t>Simulated security alerts. Hovering over a fake link reveals its destination URL, highlighting homograph traps (such as Cyrillic 'ı' in arcadıakyc-login.org).</a:t>
-            </a:r>
-          </a:p>
-        </p:txBody>
-      </p:sp>
-      <p:sp>
-        <p:nvSpPr>
-          <p:cNvPr id="5" name="Rectangle 4"/>
-          <p:cNvSpPr/>
-          <p:nvPr/>
-        </p:nvSpPr>
-        <p:spPr>
-          <a:xfrm>
-            <a:off x="6385255" y="1645920"/>
-            <a:ext cx="5120640" cy="1920240"/>
-          </a:xfrm>
-          <a:prstGeom prst="rect">
-            <a:avLst/>
-          </a:prstGeom>
-          <a:solidFill>
-            <a:srgbClr val="1A202C"/>
-          </a:solidFill>
-          <a:ln w="19050">
-            <a:solidFill>
-              <a:srgbClr val="38BDF8"/>
-            </a:solidFill>
-          </a:ln>
-        </p:spPr>
-        <p:style>
-          <a:lnRef idx="1">
-            <a:schemeClr val="accent1"/>
-          </a:lnRef>
-          <a:fillRef idx="3">
-            <a:schemeClr val="accent1"/>
-          </a:fillRef>
-          <a:effectRef idx="2">
-            <a:schemeClr val="accent1"/>
-          </a:effectRef>
-          <a:fontRef idx="minor">
-            <a:schemeClr val="lt1"/>
-          </a:fontRef>
-        </p:style>
-        <p:txBody>
-          <a:bodyPr rtlCol="0" anchor="ctr" lIns="182880" rIns="182880" tIns="127000" wrap="square"/>
-          <a:lstStyle/>
-          <a:p>
-            <a:pPr algn="ctr">
-              <a:defRPr sz="1500" b="1">
-                <a:solidFill>
-                  <a:srgbClr val="38BDF8"/>
-                </a:solidFill>
-                <a:latin typeface="Outfit"/>
-              </a:defRPr>
-            </a:pPr>
-            <a:r>
-              <a:t>02 | SOCIAL ENGINEERING VISHING SIMULATION</a:t>
-            </a:r>
-          </a:p>
-          <a:p>
-            <a:pPr>
-              <a:defRPr sz="1200">
-                <a:solidFill>
-                  <a:srgbClr val="E2E8F0"/>
-                </a:solidFill>
-                <a:latin typeface="Outfit"/>
-              </a:defRPr>
-            </a:pPr>
-            <a:r>
-              <a:t>Simulates phone calls (e.g. Arcadia Bank Fraud Team) pressuring the user to reveal OTPs. Players must reject the call and verify through official channels.</a:t>
-            </a:r>
-          </a:p>
-        </p:txBody>
-      </p:sp>
-      <p:sp>
-        <p:nvSpPr>
-          <p:cNvPr id="6" name="Rectangle 5"/>
-          <p:cNvSpPr/>
-          <p:nvPr/>
-        </p:nvSpPr>
-        <p:spPr>
-          <a:xfrm>
-            <a:off x="685800" y="3840480"/>
-            <a:ext cx="5120640" cy="1920240"/>
-          </a:xfrm>
-          <a:prstGeom prst="rect">
-            <a:avLst/>
-          </a:prstGeom>
-          <a:solidFill>
-            <a:srgbClr val="1A202C"/>
-          </a:solidFill>
-          <a:ln w="19050">
-            <a:solidFill>
-              <a:srgbClr val="EF4444"/>
-            </a:solidFill>
-          </a:ln>
-        </p:spPr>
-        <p:style>
-          <a:lnRef idx="1">
-            <a:schemeClr val="accent1"/>
-          </a:lnRef>
-          <a:fillRef idx="3">
-            <a:schemeClr val="accent1"/>
-          </a:fillRef>
-          <a:effectRef idx="2">
-            <a:schemeClr val="accent1"/>
-          </a:effectRef>
-          <a:fontRef idx="minor">
-            <a:schemeClr val="lt1"/>
-          </a:fontRef>
-        </p:style>
-        <p:txBody>
-          <a:bodyPr rtlCol="0" anchor="ctr" lIns="182880" rIns="182880" tIns="127000" wrap="square"/>
-          <a:lstStyle/>
-          <a:p>
-            <a:pPr algn="ctr">
-              <a:defRPr sz="1500" b="1">
-                <a:solidFill>
-                  <a:srgbClr val="EF4444"/>
-                </a:solidFill>
-                <a:latin typeface="Outfit"/>
-              </a:defRPr>
-            </a:pPr>
-            <a:r>
-              <a:t>03 | MALWARE UPDATES &amp; POPUPS</a:t>
-            </a:r>
-          </a:p>
-          <a:p>
-            <a:pPr>
-              <a:defRPr sz="1200">
-                <a:solidFill>
-                  <a:srgbClr val="E2E8F0"/>
-                </a:solidFill>
-                <a:latin typeface="Outfit"/>
-              </a:defRPr>
-            </a:pPr>
-            <a:r>
-              <a:t>Deceptive popup updating alerts block corridor lanes. Players must spot signature visual red flags and redirect to official vendor stores.</a:t>
-            </a:r>
-          </a:p>
-        </p:txBody>
-      </p:sp>
-      <p:sp>
-        <p:nvSpPr>
-          <p:cNvPr id="7" name="Rectangle 6"/>
-          <p:cNvSpPr/>
-          <p:nvPr/>
-        </p:nvSpPr>
-        <p:spPr>
-          <a:xfrm>
-            <a:off x="6385255" y="3840480"/>
-            <a:ext cx="5120640" cy="1920240"/>
-          </a:xfrm>
-          <a:prstGeom prst="rect">
-            <a:avLst/>
-          </a:prstGeom>
-          <a:solidFill>
-            <a:srgbClr val="1A202C"/>
-          </a:solidFill>
-          <a:ln w="19050">
-            <a:solidFill>
-              <a:srgbClr val="00FF66"/>
-            </a:solidFill>
-          </a:ln>
-        </p:spPr>
-        <p:style>
-          <a:lnRef idx="1">
-            <a:schemeClr val="accent1"/>
-          </a:lnRef>
-          <a:fillRef idx="3">
-            <a:schemeClr val="accent1"/>
-          </a:fillRef>
-          <a:effectRef idx="2">
-            <a:schemeClr val="accent1"/>
-          </a:effectRef>
-          <a:fontRef idx="minor">
-            <a:schemeClr val="lt1"/>
-          </a:fontRef>
-        </p:style>
-        <p:txBody>
-          <a:bodyPr rtlCol="0" anchor="ctr" lIns="182880" rIns="182880" tIns="127000" wrap="square"/>
-          <a:lstStyle/>
-          <a:p>
-            <a:pPr algn="ctr">
-              <a:defRPr sz="1500" b="1">
-                <a:solidFill>
-                  <a:srgbClr val="00FF66"/>
-                </a:solidFill>
-                <a:latin typeface="Outfit"/>
-              </a:defRPr>
-            </a:pPr>
-            <a:r>
-              <a:t>04 | CREDENTIAL HYGIENE &amp; FORTRESS GATES</a:t>
-            </a:r>
-          </a:p>
-          <a:p>
-            <a:pPr>
-              <a:defRPr sz="1200">
-                <a:solidFill>
-                  <a:srgbClr val="E2E8F0"/>
-                </a:solidFill>
-                <a:latin typeface="Outfit"/>
-              </a:defRPr>
-            </a:pPr>
-            <a:r>
-              <a:t>Explores brute-force mechanics, reinforcing passphrase length, multi-factor authentication (MFA), and credential reuse hazards.</a:t>
-            </a:r>
-          </a:p>
-        </p:txBody>
-      </p:sp>
-    </p:spTree>
-  </p:cSld>
-  <p:clrMapOvr>
-    <a:masterClrMapping/>
-  </p:clrMapOvr>
-</p:sld>
-</file>
-
-<file path=ppt/slides/slide8.xml><?xml version="1.0" encoding="utf-8"?>
-<p:sld xmlns:a="http://schemas.openxmlformats.org/drawingml/2006/main" xmlns:p="http://schemas.openxmlformats.org/presentationml/2006/main" xmlns:r="http://schemas.openxmlformats.org/officeDocument/2006/relationships">
-  <p:cSld>
-    <p:bg>
-      <p:bgPr>
-        <a:solidFill>
-          <a:srgbClr val="0B0E14"/>
-        </a:solidFill>
-        <a:effectLst/>
-      </p:bgPr>
-    </p:bg>
-    <p:spTree>
-      <p:nvGrpSpPr>
-        <p:cNvPr id="1" name=""/>
-        <p:cNvGrpSpPr/>
-        <p:nvPr/>
-      </p:nvGrpSpPr>
-      <p:grpSpPr/>
-      <p:sp>
-        <p:nvSpPr>
-          <p:cNvPr id="2" name="TextBox 1"/>
-          <p:cNvSpPr txBox="1"/>
-          <p:nvPr/>
-        </p:nvSpPr>
-        <p:spPr>
-          <a:xfrm>
-            <a:off x="685800" y="365760"/>
-            <a:ext cx="10817352" cy="274320"/>
-          </a:xfrm>
-          <a:prstGeom prst="rect">
-            <a:avLst/>
-          </a:prstGeom>
-          <a:noFill/>
-        </p:spPr>
-        <p:txBody>
-          <a:bodyPr wrap="square">
-            <a:spAutoFit/>
-          </a:bodyPr>
-          <a:lstStyle/>
-          <a:p>
-            <a:pPr>
-              <a:defRPr sz="1000" b="1">
-                <a:solidFill>
-                  <a:srgbClr val="38BDF8"/>
-                </a:solidFill>
-                <a:latin typeface="Outfit"/>
-              </a:defRPr>
-            </a:pPr>
-            <a:r>
-              <a:t>DELIVERABLE OUTCOME</a:t>
-            </a:r>
-          </a:p>
-        </p:txBody>
-      </p:sp>
-      <p:sp>
-        <p:nvSpPr>
-          <p:cNvPr id="3" name="TextBox 2"/>
-          <p:cNvSpPr txBox="1"/>
-          <p:nvPr/>
-        </p:nvSpPr>
-        <p:spPr>
-          <a:xfrm>
-            <a:off x="685800" y="594360"/>
-            <a:ext cx="10817352" cy="731520"/>
-          </a:xfrm>
-          <a:prstGeom prst="rect">
-            <a:avLst/>
-          </a:prstGeom>
-          <a:noFill/>
-        </p:spPr>
-        <p:txBody>
-          <a:bodyPr wrap="square">
-            <a:spAutoFit/>
-          </a:bodyPr>
-          <a:lstStyle/>
-          <a:p>
-            <a:pPr>
-              <a:defRPr sz="3000" b="1">
-                <a:solidFill>
-                  <a:srgbClr val="D4AF37"/>
-                </a:solidFill>
-                <a:latin typeface="Cinzel"/>
-              </a:defRPr>
-            </a:pPr>
-            <a:r>
-              <a:t>Deliverable Outcome: Conversational Guide &amp; MCQ Gates</a:t>
-            </a:r>
-          </a:p>
-        </p:txBody>
-      </p:sp>
-      <p:sp>
-        <p:nvSpPr>
-          <p:cNvPr id="4" name="Rectangle 3"/>
-          <p:cNvSpPr/>
-          <p:nvPr/>
-        </p:nvSpPr>
-        <p:spPr>
-          <a:xfrm>
-            <a:off x="685800" y="1645920"/>
-            <a:ext cx="5120640" cy="4114800"/>
-          </a:xfrm>
-          <a:prstGeom prst="rect">
-            <a:avLst/>
-          </a:prstGeom>
-          <a:solidFill>
-            <a:srgbClr val="1A202C"/>
-          </a:solidFill>
-          <a:ln w="19050">
-            <a:solidFill>
-              <a:srgbClr val="D4AF37"/>
-            </a:solidFill>
-          </a:ln>
-        </p:spPr>
-        <p:style>
-          <a:lnRef idx="1">
-            <a:schemeClr val="accent1"/>
-          </a:lnRef>
-          <a:fillRef idx="3">
-            <a:schemeClr val="accent1"/>
-          </a:fillRef>
-          <a:effectRef idx="2">
-            <a:schemeClr val="accent1"/>
-          </a:effectRef>
-          <a:fontRef idx="minor">
-            <a:schemeClr val="lt1"/>
-          </a:fontRef>
-        </p:style>
-        <p:txBody>
-          <a:bodyPr rtlCol="0" anchor="ctr" lIns="365760" tIns="365760" wrap="square"/>
-          <a:lstStyle/>
-          <a:p>
-            <a:pPr algn="ctr">
-              <a:defRPr sz="1800" b="1">
-                <a:solidFill>
-                  <a:srgbClr val="D4AF37"/>
-                </a:solidFill>
-                <a:latin typeface="Outfit"/>
-              </a:defRPr>
-            </a:pPr>
-            <a:r>
-              <a:t>ASK THE CYBER GUIDE</a:t>
-            </a:r>
-          </a:p>
-          <a:p>
-            <a:br/>
-            <a:pPr>
-              <a:defRPr sz="1400">
-                <a:solidFill>
-                  <a:srgbClr val="E2E8F0"/>
-                </a:solidFill>
-                <a:latin typeface="Outfit"/>
-              </a:defRPr>
-            </a:pPr>
-            <a:r>
-              <a:t>• Serverless LLM Mentor:</a:t>
-            </a:r>
-            <a:br/>
-            <a:r>
-              <a:t>  Greymantle answers dynamic player questions inside the game context, using Firestore logs for history.</a:t>
-            </a:r>
-            <a:br/>
-            <a:br/>
-            <a:r>
-              <a:t>• Risk-free Inquiry:</a:t>
-            </a:r>
-            <a:br/>
-            <a:r>
-              <a:t>  Players clarify complex threats safely during gameplay, or purchase tactical guides using coins.</a:t>
-            </a:r>
-            <a:br/>
-            <a:br/>
-            <a:r>
-              <a:t>• Secure Architecture:</a:t>
-            </a:r>
-            <a:br/>
-            <a:r>
-              <a:t>  Proxies API keys server-side via Firebase Cloud Functions, resolving key leakage alerts.</a:t>
-            </a:r>
-          </a:p>
-        </p:txBody>
-      </p:sp>
-      <p:sp>
-        <p:nvSpPr>
-          <p:cNvPr id="5" name="Rectangle 4"/>
-          <p:cNvSpPr/>
-          <p:nvPr/>
-        </p:nvSpPr>
-        <p:spPr>
-          <a:xfrm>
-            <a:off x="6355080" y="1645920"/>
-            <a:ext cx="5150815" cy="4114800"/>
-          </a:xfrm>
-          <a:prstGeom prst="rect">
-            <a:avLst/>
-          </a:prstGeom>
-          <a:solidFill>
-            <a:srgbClr val="1A202C"/>
-          </a:solidFill>
-          <a:ln w="19050">
-            <a:solidFill>
-              <a:srgbClr val="00FF66"/>
-            </a:solidFill>
-          </a:ln>
-        </p:spPr>
-        <p:style>
-          <a:lnRef idx="1">
-            <a:schemeClr val="accent1"/>
-          </a:lnRef>
-          <a:fillRef idx="3">
-            <a:schemeClr val="accent1"/>
-          </a:fillRef>
-          <a:effectRef idx="2">
-            <a:schemeClr val="accent1"/>
-          </a:effectRef>
-          <a:fontRef idx="minor">
-            <a:schemeClr val="lt1"/>
-          </a:fontRef>
-        </p:style>
-        <p:txBody>
-          <a:bodyPr rtlCol="0" anchor="ctr" lIns="365760" tIns="365760" wrap="square"/>
-          <a:lstStyle/>
-          <a:p>
-            <a:pPr algn="ctr">
-              <a:defRPr sz="1800" b="1">
-                <a:solidFill>
-                  <a:srgbClr val="00FF66"/>
-                </a:solidFill>
-                <a:latin typeface="Outfit"/>
-              </a:defRPr>
-            </a:pPr>
-            <a:r>
-              <a:t>VOID COLLECTIVE SECURITY GATES</a:t>
-            </a:r>
-          </a:p>
-          <a:p>
-            <a:br/>
-            <a:pPr>
-              <a:defRPr sz="1400">
-                <a:solidFill>
-                  <a:srgbClr val="E2E8F0"/>
-                </a:solidFill>
-                <a:latin typeface="Outfit"/>
-              </a:defRPr>
-            </a:pPr>
-            <a:r>
-              <a:t>• MCQ Checkpoints:</a:t>
-            </a:r>
-            <a:br/>
-            <a:r>
-              <a:t>  Checkpoint gates block paths, requiring players to clear a 3-question MCQ quiz to collect key segments.</a:t>
-            </a:r>
-            <a:br/>
-            <a:br/>
-            <a:r>
-              <a:t>• Sequential Quiz Interface:</a:t>
-            </a:r>
-            <a:br/>
-            <a:r>
-              <a:t>  Presents questions one-at-a-time, featuring parallel-aligned choices and a clean flow.</a:t>
-            </a:r>
-            <a:br/>
-            <a:br/>
-            <a:r>
-              <a:t>• Threshold Enforcement:</a:t>
-            </a:r>
-            <a:br/>
-            <a:r>
-              <a:t>  Requires a score of 2/3 correct to bypass. Failing locks the gate, demanding a retry of the corridor.</a:t>
-            </a:r>
-          </a:p>
-        </p:txBody>
-      </p:sp>
-      <p:sp>
-        <p:nvSpPr>
-          <p:cNvPr id="6" name="Rectangle 5"/>
-          <p:cNvSpPr/>
-          <p:nvPr/>
-        </p:nvSpPr>
-        <p:spPr>
-          <a:xfrm>
-            <a:off x="685800" y="1645920"/>
-            <a:ext cx="5120640" cy="4114800"/>
-          </a:xfrm>
-          <a:prstGeom prst="rect">
-            <a:avLst/>
-          </a:prstGeom>
-        </p:spPr>
-        <p:style>
-          <a:lnRef idx="1">
-            <a:schemeClr val="accent1"/>
-          </a:lnRef>
-          <a:fillRef idx="3">
-            <a:schemeClr val="accent1"/>
-          </a:fillRef>
-          <a:effectRef idx="2">
-            <a:schemeClr val="accent1"/>
-          </a:effectRef>
-          <a:fontRef idx="minor">
-            <a:schemeClr val="lt1"/>
-          </a:fontRef>
-        </p:style>
-        <p:txBody>
-          <a:bodyPr rtlCol="0" anchor="ctr"/>
-          <a:lstStyle/>
-          <a:p>
-            <a:pPr algn="ctr"/>
-          </a:p>
-        </p:txBody>
-      </p:sp>
-    </p:spTree>
-  </p:cSld>
-  <p:clrMapOvr>
-    <a:masterClrMapping/>
-  </p:clrMapOvr>
-</p:sld>
-</file>
-
-<file path=ppt/slides/slide9.xml><?xml version="1.0" encoding="utf-8"?>
-<p:sld xmlns:a="http://schemas.openxmlformats.org/drawingml/2006/main" xmlns:p="http://schemas.openxmlformats.org/presentationml/2006/main" xmlns:r="http://schemas.openxmlformats.org/officeDocument/2006/relationships">
-  <p:cSld>
-    <p:bg>
-      <p:bgPr>
-        <a:solidFill>
-          <a:srgbClr val="0B0E14"/>
-        </a:solidFill>
-        <a:effectLst/>
-      </p:bgPr>
-    </p:bg>
-    <p:spTree>
-      <p:nvGrpSpPr>
-        <p:cNvPr id="1" name=""/>
-        <p:cNvGrpSpPr/>
-        <p:nvPr/>
-      </p:nvGrpSpPr>
-      <p:grpSpPr/>
-      <p:sp>
-        <p:nvSpPr>
-          <p:cNvPr id="2" name="TextBox 1"/>
-          <p:cNvSpPr txBox="1"/>
-          <p:nvPr/>
-        </p:nvSpPr>
-        <p:spPr>
-          <a:xfrm>
-            <a:off x="685800" y="365760"/>
-            <a:ext cx="10817352" cy="274320"/>
-          </a:xfrm>
-          <a:prstGeom prst="rect">
-            <a:avLst/>
-          </a:prstGeom>
-          <a:noFill/>
-        </p:spPr>
-        <p:txBody>
-          <a:bodyPr wrap="square">
-            <a:spAutoFit/>
-          </a:bodyPr>
-          <a:lstStyle/>
-          <a:p>
-            <a:pPr>
-              <a:defRPr sz="1000" b="1">
-                <a:solidFill>
-                  <a:srgbClr val="38BDF8"/>
-                </a:solidFill>
-                <a:latin typeface="Outfit"/>
-              </a:defRPr>
-            </a:pPr>
-            <a:r>
-              <a:t>DELIVERABLE OUTCOME</a:t>
-            </a:r>
-          </a:p>
-        </p:txBody>
-      </p:sp>
-      <p:sp>
-        <p:nvSpPr>
-          <p:cNvPr id="3" name="TextBox 2"/>
-          <p:cNvSpPr txBox="1"/>
-          <p:nvPr/>
-        </p:nvSpPr>
-        <p:spPr>
-          <a:xfrm>
-            <a:off x="685800" y="594360"/>
-            <a:ext cx="10817352" cy="731520"/>
-          </a:xfrm>
-          <a:prstGeom prst="rect">
-            <a:avLst/>
-          </a:prstGeom>
-          <a:noFill/>
-        </p:spPr>
-        <p:txBody>
-          <a:bodyPr wrap="square">
-            <a:spAutoFit/>
-          </a:bodyPr>
-          <a:lstStyle/>
-          <a:p>
-            <a:pPr>
-              <a:defRPr sz="3000" b="1">
-                <a:solidFill>
-                  <a:srgbClr val="D4AF37"/>
-                </a:solidFill>
-                <a:latin typeface="Cinzel"/>
-              </a:defRPr>
-            </a:pPr>
-            <a:r>
-              <a:t>Deliverable Outcome: Gamified Score &amp; Leaderboard</a:t>
-            </a:r>
-          </a:p>
-        </p:txBody>
-      </p:sp>
-      <p:sp>
-        <p:nvSpPr>
-          <p:cNvPr id="4" name="Rectangle 3"/>
-          <p:cNvSpPr/>
-          <p:nvPr/>
-        </p:nvSpPr>
-        <p:spPr>
-          <a:xfrm>
-            <a:off x="685800" y="1645920"/>
-            <a:ext cx="5120640" cy="4114800"/>
-          </a:xfrm>
-          <a:prstGeom prst="rect">
-            <a:avLst/>
-          </a:prstGeom>
-          <a:solidFill>
-            <a:srgbClr val="1A202C"/>
-          </a:solidFill>
-          <a:ln w="25400">
-            <a:solidFill>
-              <a:srgbClr val="D4AF37"/>
-            </a:solidFill>
-          </a:ln>
-        </p:spPr>
-        <p:style>
-          <a:lnRef idx="1">
-            <a:schemeClr val="accent1"/>
-          </a:lnRef>
-          <a:fillRef idx="3">
-            <a:schemeClr val="accent1"/>
-          </a:fillRef>
-          <a:effectRef idx="2">
-            <a:schemeClr val="accent1"/>
-          </a:effectRef>
-          <a:fontRef idx="minor">
-            <a:schemeClr val="lt1"/>
-          </a:fontRef>
-        </p:style>
-        <p:txBody>
-          <a:bodyPr rtlCol="0" anchor="ctr" lIns="365760" tIns="365760" wrap="square"/>
-          <a:lstStyle/>
-          <a:p>
-            <a:pPr algn="ctr">
-              <a:defRPr sz="1800" b="1">
-                <a:solidFill>
-                  <a:srgbClr val="D4AF37"/>
-                </a:solidFill>
-                <a:latin typeface="Outfit"/>
-              </a:defRPr>
-            </a:pPr>
-            <a:r>
-              <a:t>THE GUARDIAN PERFORMANCE FORMULA</a:t>
-            </a:r>
-          </a:p>
-          <a:p>
-            <a:br/>
-            <a:pPr>
-              <a:defRPr sz="1400">
-                <a:solidFill>
-                  <a:srgbClr val="E2E8F0"/>
-                </a:solidFill>
-                <a:latin typeface="Outfit"/>
-              </a:defRPr>
-            </a:pPr>
-            <a:r>
-              <a:t>Player achievements are graded using an active defense formula:</a:t>
-            </a:r>
-          </a:p>
-          <a:p>
-            <a:br/>
-            <a:br/>
-            <a:br/>
-            <a:br/>
-            <a:pPr>
-              <a:defRPr sz="1200">
-                <a:solidFill>
-                  <a:srgbClr val="E2E8F0"/>
-                </a:solidFill>
-                <a:latin typeface="Outfit"/>
-              </a:defRPr>
-            </a:pPr>
-            <a:r>
-              <a:t>• XP represents successful threat spotting.</a:t>
-            </a:r>
-            <a:br/>
-            <a:r>
-              <a:t>• Accuracy rewards precision in choice trials.</a:t>
-            </a:r>
-            <a:br/>
-            <a:r>
-              <a:t>• HP remaining ensures survival tactics were applied.</a:t>
-            </a:r>
-          </a:p>
-        </p:txBody>
-      </p:sp>
-      <p:sp>
-        <p:nvSpPr>
-          <p:cNvPr id="5" name="Rectangle 4"/>
-          <p:cNvSpPr/>
-          <p:nvPr/>
-        </p:nvSpPr>
-        <p:spPr>
-          <a:xfrm>
-            <a:off x="1051560" y="2743200"/>
-            <a:ext cx="4389120" cy="1097280"/>
-          </a:xfrm>
-          <a:prstGeom prst="rect">
-            <a:avLst/>
-          </a:prstGeom>
-          <a:solidFill>
-            <a:srgbClr val="0B0E14"/>
-          </a:solidFill>
-          <a:ln w="12700">
-            <a:solidFill>
-              <a:srgbClr val="38BDF8"/>
-            </a:solidFill>
-          </a:ln>
-        </p:spPr>
-        <p:style>
-          <a:lnRef idx="1">
-            <a:schemeClr val="accent1"/>
-          </a:lnRef>
-          <a:fillRef idx="3">
-            <a:schemeClr val="accent1"/>
-          </a:fillRef>
-          <a:effectRef idx="2">
-            <a:schemeClr val="accent1"/>
-          </a:effectRef>
-          <a:fontRef idx="minor">
-            <a:schemeClr val="lt1"/>
-          </a:fontRef>
-        </p:style>
-        <p:txBody>
-          <a:bodyPr rtlCol="0" anchor="ctr" wrap="square"/>
-          <a:lstStyle/>
-          <a:p>
-            <a:pPr algn="ctr">
-              <a:defRPr sz="1800" b="1">
-                <a:solidFill>
-                  <a:srgbClr val="00FF66"/>
-                </a:solidFill>
-                <a:latin typeface="Outfit"/>
-              </a:defRPr>
-            </a:pPr>
-            <a:r>
-              <a:t>Score = XP + (Accuracy% × 2) + HP</a:t>
-            </a:r>
-          </a:p>
-        </p:txBody>
-      </p:sp>
-      <p:sp>
-        <p:nvSpPr>
-          <p:cNvPr id="6" name="Rectangle 5"/>
-          <p:cNvSpPr/>
-          <p:nvPr/>
-        </p:nvSpPr>
-        <p:spPr>
-          <a:xfrm>
-            <a:off x="6355080" y="1645920"/>
-            <a:ext cx="5150815" cy="4114800"/>
-          </a:xfrm>
-          <a:prstGeom prst="rect">
-            <a:avLst/>
-          </a:prstGeom>
-          <a:solidFill>
-            <a:srgbClr val="1A202C"/>
-          </a:solidFill>
-          <a:ln w="19050">
-            <a:solidFill>
-              <a:srgbClr val="38BDF8"/>
-            </a:solidFill>
-          </a:ln>
-        </p:spPr>
-        <p:style>
-          <a:lnRef idx="1">
-            <a:schemeClr val="accent1"/>
-          </a:lnRef>
-          <a:fillRef idx="3">
-            <a:schemeClr val="accent1"/>
-          </a:fillRef>
-          <a:effectRef idx="2">
-            <a:schemeClr val="accent1"/>
-          </a:effectRef>
-          <a:fontRef idx="minor">
-            <a:schemeClr val="lt1"/>
-          </a:fontRef>
-        </p:style>
-        <p:txBody>
-          <a:bodyPr rtlCol="0" anchor="ctr" lIns="365760" tIns="365760" wrap="square"/>
-          <a:lstStyle/>
-          <a:p>
-            <a:pPr algn="ctr">
-              <a:defRPr sz="1800" b="1">
-                <a:solidFill>
-                  <a:srgbClr val="38BDF8"/>
-                </a:solidFill>
-                <a:latin typeface="Outfit"/>
-              </a:defRPr>
-            </a:pPr>
-            <a:r>
-              <a:t>LEADERBOARD &amp; ENGAGEMENT LOOP</a:t>
-            </a:r>
-          </a:p>
-          <a:p>
-            <a:br/>
-            <a:pPr>
-              <a:defRPr sz="1400">
-                <a:solidFill>
-                  <a:srgbClr val="E2E8F0"/>
-                </a:solidFill>
-                <a:latin typeface="Outfit"/>
-              </a:defRPr>
-            </a:pPr>
-            <a:r>
-              <a:t>• Real-Time Firestore Leaderboard:</a:t>
-            </a:r>
-            <a:br/>
-            <a:r>
-              <a:t>  Saves scores anonymously, fostering healthy competition among team members or organizations.</a:t>
-            </a:r>
-            <a:br/>
-            <a:br/>
-            <a:r>
-              <a:t>• Immediate Correction Feedback:</a:t>
-            </a:r>
-            <a:br/>
-            <a:r>
-              <a:t>  Decisions display instant alerts explaining why an action was insecure, building memory loops.</a:t>
-            </a:r>
-            <a:br/>
-            <a:br/>
-            <a:r>
-              <a:t>• Frictionless Failing:</a:t>
-            </a:r>
-            <a:br/>
-            <a:r>
-              <a:t>  Low-stakes errors keep players engaged, avoiding the fatigue of standard cyber compliance training.</a:t>
             </a:r>
           </a:p>
         </p:txBody>

</xml_diff>